<commit_message>
docs: finalize live defect issue sync
</commit_message>
<xml_diff>
--- a/Report Test subject/Powered by GPT/MainReport/Powered by GPT - Software Quality Verification - Presentation.pptx
+++ b/Report Test subject/Powered by GPT/MainReport/Powered by GPT - Software Quality Verification - Presentation.pptx
@@ -139,7 +139,7 @@
           <p:cNvPr id="2" name="Title 1">
             <a:extLst>
               <a:ext uri="{FF2B5EF4-FFF2-40B4-BE49-F238E27FC236}">
-                <a16:creationId xmlns:a16="http://schemas.microsoft.com/office/drawing/2014/main" id="{DE9F2F33-6FE6-AC06-BDE5-153B5B1FDD6F}"/>
+                <a16:creationId xmlns:a16="http://schemas.microsoft.com/office/drawing/2014/main" id="{FEE0F406-38B4-101C-4526-0087BE238B21}"/>
               </a:ext>
             </a:extLst>
           </p:cNvPr>
@@ -176,7 +176,7 @@
           <p:cNvPr id="3" name="Subtitle 2">
             <a:extLst>
               <a:ext uri="{FF2B5EF4-FFF2-40B4-BE49-F238E27FC236}">
-                <a16:creationId xmlns:a16="http://schemas.microsoft.com/office/drawing/2014/main" id="{1A9375CB-FE86-C419-FCC6-8FD4A23DEB44}"/>
+                <a16:creationId xmlns:a16="http://schemas.microsoft.com/office/drawing/2014/main" id="{4BB97A93-5281-DCCA-3308-E9B396B5F5B7}"/>
               </a:ext>
             </a:extLst>
           </p:cNvPr>
@@ -246,7 +246,7 @@
           <p:cNvPr id="4" name="Date Placeholder 3">
             <a:extLst>
               <a:ext uri="{FF2B5EF4-FFF2-40B4-BE49-F238E27FC236}">
-                <a16:creationId xmlns:a16="http://schemas.microsoft.com/office/drawing/2014/main" id="{09C83F34-F8FA-1283-18CF-4AAA476C4AC3}"/>
+                <a16:creationId xmlns:a16="http://schemas.microsoft.com/office/drawing/2014/main" id="{736250F2-C827-D14F-BE74-7AA93D756D16}"/>
               </a:ext>
             </a:extLst>
           </p:cNvPr>
@@ -262,7 +262,7 @@
           <a:bodyPr/>
           <a:lstStyle/>
           <a:p>
-            <a:fld id="{DE32CFBE-E2A3-4D0D-AC42-676856CBE8FF}" type="datetimeFigureOut">
+            <a:fld id="{EFC7B293-C39B-4341-97D8-8A5D589474B0}" type="datetimeFigureOut">
               <a:rPr lang="en-US" smtClean="0"/>
               <a:t>4/11/2026</a:t>
             </a:fld>
@@ -275,7 +275,7 @@
           <p:cNvPr id="5" name="Footer Placeholder 4">
             <a:extLst>
               <a:ext uri="{FF2B5EF4-FFF2-40B4-BE49-F238E27FC236}">
-                <a16:creationId xmlns:a16="http://schemas.microsoft.com/office/drawing/2014/main" id="{16BCB9D0-E704-4481-E56F-9D389CA5A5EB}"/>
+                <a16:creationId xmlns:a16="http://schemas.microsoft.com/office/drawing/2014/main" id="{5645D2F1-5001-897A-5D55-9A0E47EB0A4D}"/>
               </a:ext>
             </a:extLst>
           </p:cNvPr>
@@ -300,7 +300,7 @@
           <p:cNvPr id="6" name="Slide Number Placeholder 5">
             <a:extLst>
               <a:ext uri="{FF2B5EF4-FFF2-40B4-BE49-F238E27FC236}">
-                <a16:creationId xmlns:a16="http://schemas.microsoft.com/office/drawing/2014/main" id="{E77DF922-C136-4C67-DFF7-05F97C7D94A9}"/>
+                <a16:creationId xmlns:a16="http://schemas.microsoft.com/office/drawing/2014/main" id="{A2131251-F85E-C0FC-936B-6F900FD1A849}"/>
               </a:ext>
             </a:extLst>
           </p:cNvPr>
@@ -316,7 +316,7 @@
           <a:bodyPr/>
           <a:lstStyle/>
           <a:p>
-            <a:fld id="{ABD641DF-BBFB-4415-A959-2AE3777557CA}" type="slidenum">
+            <a:fld id="{1E42A513-68A6-42F7-94CC-B181D5F7CFB8}" type="slidenum">
               <a:rPr lang="en-US" smtClean="0"/>
               <a:t>‹#›</a:t>
             </a:fld>
@@ -327,7 +327,7 @@
     </p:spTree>
     <p:extLst>
       <p:ext uri="{BB962C8B-B14F-4D97-AF65-F5344CB8AC3E}">
-        <p14:creationId xmlns:p14="http://schemas.microsoft.com/office/powerpoint/2010/main" val="3121057453"/>
+        <p14:creationId xmlns:p14="http://schemas.microsoft.com/office/powerpoint/2010/main" val="1499045366"/>
       </p:ext>
     </p:extLst>
   </p:cSld>
@@ -359,7 +359,7 @@
           <p:cNvPr id="2" name="Title 1">
             <a:extLst>
               <a:ext uri="{FF2B5EF4-FFF2-40B4-BE49-F238E27FC236}">
-                <a16:creationId xmlns:a16="http://schemas.microsoft.com/office/drawing/2014/main" id="{C46716A3-48CA-5A64-F7CF-157187F206B8}"/>
+                <a16:creationId xmlns:a16="http://schemas.microsoft.com/office/drawing/2014/main" id="{32962257-06DC-A608-591B-66B392A5E371}"/>
               </a:ext>
             </a:extLst>
           </p:cNvPr>
@@ -387,7 +387,7 @@
           <p:cNvPr id="3" name="Vertical Text Placeholder 2">
             <a:extLst>
               <a:ext uri="{FF2B5EF4-FFF2-40B4-BE49-F238E27FC236}">
-                <a16:creationId xmlns:a16="http://schemas.microsoft.com/office/drawing/2014/main" id="{902CD575-07D1-8B59-348A-EB6F956AEB79}"/>
+                <a16:creationId xmlns:a16="http://schemas.microsoft.com/office/drawing/2014/main" id="{E679B511-6E9C-9964-A97A-A77CC8E63E8E}"/>
               </a:ext>
             </a:extLst>
           </p:cNvPr>
@@ -444,7 +444,7 @@
           <p:cNvPr id="4" name="Date Placeholder 3">
             <a:extLst>
               <a:ext uri="{FF2B5EF4-FFF2-40B4-BE49-F238E27FC236}">
-                <a16:creationId xmlns:a16="http://schemas.microsoft.com/office/drawing/2014/main" id="{CB70B5EB-E3B3-1B02-6329-3EA1AC39E4BA}"/>
+                <a16:creationId xmlns:a16="http://schemas.microsoft.com/office/drawing/2014/main" id="{DEC771E3-D1BA-681B-7CBD-AE68327AB058}"/>
               </a:ext>
             </a:extLst>
           </p:cNvPr>
@@ -460,7 +460,7 @@
           <a:bodyPr/>
           <a:lstStyle/>
           <a:p>
-            <a:fld id="{DE32CFBE-E2A3-4D0D-AC42-676856CBE8FF}" type="datetimeFigureOut">
+            <a:fld id="{EFC7B293-C39B-4341-97D8-8A5D589474B0}" type="datetimeFigureOut">
               <a:rPr lang="en-US" smtClean="0"/>
               <a:t>4/11/2026</a:t>
             </a:fld>
@@ -473,7 +473,7 @@
           <p:cNvPr id="5" name="Footer Placeholder 4">
             <a:extLst>
               <a:ext uri="{FF2B5EF4-FFF2-40B4-BE49-F238E27FC236}">
-                <a16:creationId xmlns:a16="http://schemas.microsoft.com/office/drawing/2014/main" id="{DF80389B-D38B-CFCD-2664-57748124FA32}"/>
+                <a16:creationId xmlns:a16="http://schemas.microsoft.com/office/drawing/2014/main" id="{BF3E26E0-3C9B-E5DF-2B05-EFA63C2DCCD7}"/>
               </a:ext>
             </a:extLst>
           </p:cNvPr>
@@ -498,7 +498,7 @@
           <p:cNvPr id="6" name="Slide Number Placeholder 5">
             <a:extLst>
               <a:ext uri="{FF2B5EF4-FFF2-40B4-BE49-F238E27FC236}">
-                <a16:creationId xmlns:a16="http://schemas.microsoft.com/office/drawing/2014/main" id="{260E4A8D-193E-8A0A-F38F-3D763E0D6088}"/>
+                <a16:creationId xmlns:a16="http://schemas.microsoft.com/office/drawing/2014/main" id="{DE1AFFD0-BF27-2C61-9927-7B4DD9769ECB}"/>
               </a:ext>
             </a:extLst>
           </p:cNvPr>
@@ -514,7 +514,7 @@
           <a:bodyPr/>
           <a:lstStyle/>
           <a:p>
-            <a:fld id="{ABD641DF-BBFB-4415-A959-2AE3777557CA}" type="slidenum">
+            <a:fld id="{1E42A513-68A6-42F7-94CC-B181D5F7CFB8}" type="slidenum">
               <a:rPr lang="en-US" smtClean="0"/>
               <a:t>‹#›</a:t>
             </a:fld>
@@ -525,7 +525,7 @@
     </p:spTree>
     <p:extLst>
       <p:ext uri="{BB962C8B-B14F-4D97-AF65-F5344CB8AC3E}">
-        <p14:creationId xmlns:p14="http://schemas.microsoft.com/office/powerpoint/2010/main" val="4148751713"/>
+        <p14:creationId xmlns:p14="http://schemas.microsoft.com/office/powerpoint/2010/main" val="2203331531"/>
       </p:ext>
     </p:extLst>
   </p:cSld>
@@ -557,7 +557,7 @@
           <p:cNvPr id="2" name="Vertical Title 1">
             <a:extLst>
               <a:ext uri="{FF2B5EF4-FFF2-40B4-BE49-F238E27FC236}">
-                <a16:creationId xmlns:a16="http://schemas.microsoft.com/office/drawing/2014/main" id="{258BB281-AEF7-8ADF-8586-B1D9FD6D1964}"/>
+                <a16:creationId xmlns:a16="http://schemas.microsoft.com/office/drawing/2014/main" id="{5E8021C5-864A-12EE-E81F-5F7DDB330696}"/>
               </a:ext>
             </a:extLst>
           </p:cNvPr>
@@ -590,7 +590,7 @@
           <p:cNvPr id="3" name="Vertical Text Placeholder 2">
             <a:extLst>
               <a:ext uri="{FF2B5EF4-FFF2-40B4-BE49-F238E27FC236}">
-                <a16:creationId xmlns:a16="http://schemas.microsoft.com/office/drawing/2014/main" id="{A65598F0-F36D-5E90-2BBC-7003A5F5AEA9}"/>
+                <a16:creationId xmlns:a16="http://schemas.microsoft.com/office/drawing/2014/main" id="{4ABCA6F0-0723-4EFB-0447-CF1B14C78CFF}"/>
               </a:ext>
             </a:extLst>
           </p:cNvPr>
@@ -652,7 +652,7 @@
           <p:cNvPr id="4" name="Date Placeholder 3">
             <a:extLst>
               <a:ext uri="{FF2B5EF4-FFF2-40B4-BE49-F238E27FC236}">
-                <a16:creationId xmlns:a16="http://schemas.microsoft.com/office/drawing/2014/main" id="{373278CE-8D46-EAE7-A8A7-4D29C112BF81}"/>
+                <a16:creationId xmlns:a16="http://schemas.microsoft.com/office/drawing/2014/main" id="{FB290688-8865-D1EC-9CB5-50F77ED04F24}"/>
               </a:ext>
             </a:extLst>
           </p:cNvPr>
@@ -668,7 +668,7 @@
           <a:bodyPr/>
           <a:lstStyle/>
           <a:p>
-            <a:fld id="{DE32CFBE-E2A3-4D0D-AC42-676856CBE8FF}" type="datetimeFigureOut">
+            <a:fld id="{EFC7B293-C39B-4341-97D8-8A5D589474B0}" type="datetimeFigureOut">
               <a:rPr lang="en-US" smtClean="0"/>
               <a:t>4/11/2026</a:t>
             </a:fld>
@@ -681,7 +681,7 @@
           <p:cNvPr id="5" name="Footer Placeholder 4">
             <a:extLst>
               <a:ext uri="{FF2B5EF4-FFF2-40B4-BE49-F238E27FC236}">
-                <a16:creationId xmlns:a16="http://schemas.microsoft.com/office/drawing/2014/main" id="{A6D5BD82-F280-638C-4597-74C28A62C7D8}"/>
+                <a16:creationId xmlns:a16="http://schemas.microsoft.com/office/drawing/2014/main" id="{5643F74B-151E-C155-C3A4-E8737ED517A8}"/>
               </a:ext>
             </a:extLst>
           </p:cNvPr>
@@ -706,7 +706,7 @@
           <p:cNvPr id="6" name="Slide Number Placeholder 5">
             <a:extLst>
               <a:ext uri="{FF2B5EF4-FFF2-40B4-BE49-F238E27FC236}">
-                <a16:creationId xmlns:a16="http://schemas.microsoft.com/office/drawing/2014/main" id="{5CE9489B-2216-3EDE-CE92-72B27CEAFEAE}"/>
+                <a16:creationId xmlns:a16="http://schemas.microsoft.com/office/drawing/2014/main" id="{760C3574-F39A-0A0F-E429-FDA30F31C67F}"/>
               </a:ext>
             </a:extLst>
           </p:cNvPr>
@@ -722,7 +722,7 @@
           <a:bodyPr/>
           <a:lstStyle/>
           <a:p>
-            <a:fld id="{ABD641DF-BBFB-4415-A959-2AE3777557CA}" type="slidenum">
+            <a:fld id="{1E42A513-68A6-42F7-94CC-B181D5F7CFB8}" type="slidenum">
               <a:rPr lang="en-US" smtClean="0"/>
               <a:t>‹#›</a:t>
             </a:fld>
@@ -733,7 +733,7 @@
     </p:spTree>
     <p:extLst>
       <p:ext uri="{BB962C8B-B14F-4D97-AF65-F5344CB8AC3E}">
-        <p14:creationId xmlns:p14="http://schemas.microsoft.com/office/powerpoint/2010/main" val="2138716398"/>
+        <p14:creationId xmlns:p14="http://schemas.microsoft.com/office/powerpoint/2010/main" val="1352993447"/>
       </p:ext>
     </p:extLst>
   </p:cSld>
@@ -765,7 +765,7 @@
           <p:cNvPr id="2" name="Title 1">
             <a:extLst>
               <a:ext uri="{FF2B5EF4-FFF2-40B4-BE49-F238E27FC236}">
-                <a16:creationId xmlns:a16="http://schemas.microsoft.com/office/drawing/2014/main" id="{3087E6E6-44F2-8545-4A82-75FB795F8922}"/>
+                <a16:creationId xmlns:a16="http://schemas.microsoft.com/office/drawing/2014/main" id="{E3300121-1170-349E-A7E6-A7E7682BA086}"/>
               </a:ext>
             </a:extLst>
           </p:cNvPr>
@@ -793,7 +793,7 @@
           <p:cNvPr id="3" name="Content Placeholder 2">
             <a:extLst>
               <a:ext uri="{FF2B5EF4-FFF2-40B4-BE49-F238E27FC236}">
-                <a16:creationId xmlns:a16="http://schemas.microsoft.com/office/drawing/2014/main" id="{0B3F5D0F-E0C4-39A4-EAF3-AFD9DC26383D}"/>
+                <a16:creationId xmlns:a16="http://schemas.microsoft.com/office/drawing/2014/main" id="{C181E408-46A8-B8BD-E426-CCB7B1EEE1C9}"/>
               </a:ext>
             </a:extLst>
           </p:cNvPr>
@@ -850,7 +850,7 @@
           <p:cNvPr id="4" name="Date Placeholder 3">
             <a:extLst>
               <a:ext uri="{FF2B5EF4-FFF2-40B4-BE49-F238E27FC236}">
-                <a16:creationId xmlns:a16="http://schemas.microsoft.com/office/drawing/2014/main" id="{7EEF94A2-2A19-494B-19A0-CFDFFF8AAAFD}"/>
+                <a16:creationId xmlns:a16="http://schemas.microsoft.com/office/drawing/2014/main" id="{B09CBFD9-AD94-6760-6EBD-1A5A8034D863}"/>
               </a:ext>
             </a:extLst>
           </p:cNvPr>
@@ -866,7 +866,7 @@
           <a:bodyPr/>
           <a:lstStyle/>
           <a:p>
-            <a:fld id="{DE32CFBE-E2A3-4D0D-AC42-676856CBE8FF}" type="datetimeFigureOut">
+            <a:fld id="{EFC7B293-C39B-4341-97D8-8A5D589474B0}" type="datetimeFigureOut">
               <a:rPr lang="en-US" smtClean="0"/>
               <a:t>4/11/2026</a:t>
             </a:fld>
@@ -879,7 +879,7 @@
           <p:cNvPr id="5" name="Footer Placeholder 4">
             <a:extLst>
               <a:ext uri="{FF2B5EF4-FFF2-40B4-BE49-F238E27FC236}">
-                <a16:creationId xmlns:a16="http://schemas.microsoft.com/office/drawing/2014/main" id="{57EFC5CD-60C4-82AB-CC90-21887BE84C36}"/>
+                <a16:creationId xmlns:a16="http://schemas.microsoft.com/office/drawing/2014/main" id="{A87DFE6E-AD45-0AD2-7C00-7E1A7A81539D}"/>
               </a:ext>
             </a:extLst>
           </p:cNvPr>
@@ -904,7 +904,7 @@
           <p:cNvPr id="6" name="Slide Number Placeholder 5">
             <a:extLst>
               <a:ext uri="{FF2B5EF4-FFF2-40B4-BE49-F238E27FC236}">
-                <a16:creationId xmlns:a16="http://schemas.microsoft.com/office/drawing/2014/main" id="{1681E159-9279-8CB4-C78A-B0C97803FC8E}"/>
+                <a16:creationId xmlns:a16="http://schemas.microsoft.com/office/drawing/2014/main" id="{44E35E1E-3593-722C-EECB-78F5E8EA6ABB}"/>
               </a:ext>
             </a:extLst>
           </p:cNvPr>
@@ -920,7 +920,7 @@
           <a:bodyPr/>
           <a:lstStyle/>
           <a:p>
-            <a:fld id="{ABD641DF-BBFB-4415-A959-2AE3777557CA}" type="slidenum">
+            <a:fld id="{1E42A513-68A6-42F7-94CC-B181D5F7CFB8}" type="slidenum">
               <a:rPr lang="en-US" smtClean="0"/>
               <a:t>‹#›</a:t>
             </a:fld>
@@ -931,7 +931,7 @@
     </p:spTree>
     <p:extLst>
       <p:ext uri="{BB962C8B-B14F-4D97-AF65-F5344CB8AC3E}">
-        <p14:creationId xmlns:p14="http://schemas.microsoft.com/office/powerpoint/2010/main" val="58389678"/>
+        <p14:creationId xmlns:p14="http://schemas.microsoft.com/office/powerpoint/2010/main" val="2557513472"/>
       </p:ext>
     </p:extLst>
   </p:cSld>
@@ -963,7 +963,7 @@
           <p:cNvPr id="2" name="Title 1">
             <a:extLst>
               <a:ext uri="{FF2B5EF4-FFF2-40B4-BE49-F238E27FC236}">
-                <a16:creationId xmlns:a16="http://schemas.microsoft.com/office/drawing/2014/main" id="{AFD3C548-9992-7AEC-FB1E-4C22AE76C2AF}"/>
+                <a16:creationId xmlns:a16="http://schemas.microsoft.com/office/drawing/2014/main" id="{4C13461E-C2A2-47FC-E405-40209D52BDF4}"/>
               </a:ext>
             </a:extLst>
           </p:cNvPr>
@@ -1000,7 +1000,7 @@
           <p:cNvPr id="3" name="Text Placeholder 2">
             <a:extLst>
               <a:ext uri="{FF2B5EF4-FFF2-40B4-BE49-F238E27FC236}">
-                <a16:creationId xmlns:a16="http://schemas.microsoft.com/office/drawing/2014/main" id="{3230E1B3-824C-58BD-AE6E-954ED7B2B3A5}"/>
+                <a16:creationId xmlns:a16="http://schemas.microsoft.com/office/drawing/2014/main" id="{224A3973-ECC4-7C82-19F8-3F378618540D}"/>
               </a:ext>
             </a:extLst>
           </p:cNvPr>
@@ -1125,7 +1125,7 @@
           <p:cNvPr id="4" name="Date Placeholder 3">
             <a:extLst>
               <a:ext uri="{FF2B5EF4-FFF2-40B4-BE49-F238E27FC236}">
-                <a16:creationId xmlns:a16="http://schemas.microsoft.com/office/drawing/2014/main" id="{0611C1E4-BA34-4EC1-C694-D901AA4CC726}"/>
+                <a16:creationId xmlns:a16="http://schemas.microsoft.com/office/drawing/2014/main" id="{951E0EB2-7666-CB02-E8DF-D753B206F767}"/>
               </a:ext>
             </a:extLst>
           </p:cNvPr>
@@ -1141,7 +1141,7 @@
           <a:bodyPr/>
           <a:lstStyle/>
           <a:p>
-            <a:fld id="{DE32CFBE-E2A3-4D0D-AC42-676856CBE8FF}" type="datetimeFigureOut">
+            <a:fld id="{EFC7B293-C39B-4341-97D8-8A5D589474B0}" type="datetimeFigureOut">
               <a:rPr lang="en-US" smtClean="0"/>
               <a:t>4/11/2026</a:t>
             </a:fld>
@@ -1154,7 +1154,7 @@
           <p:cNvPr id="5" name="Footer Placeholder 4">
             <a:extLst>
               <a:ext uri="{FF2B5EF4-FFF2-40B4-BE49-F238E27FC236}">
-                <a16:creationId xmlns:a16="http://schemas.microsoft.com/office/drawing/2014/main" id="{1D3DF9C7-04B1-FCD3-EC07-942E0DDA8DD7}"/>
+                <a16:creationId xmlns:a16="http://schemas.microsoft.com/office/drawing/2014/main" id="{C377353B-12E8-75C8-D506-52EAA31516BA}"/>
               </a:ext>
             </a:extLst>
           </p:cNvPr>
@@ -1179,7 +1179,7 @@
           <p:cNvPr id="6" name="Slide Number Placeholder 5">
             <a:extLst>
               <a:ext uri="{FF2B5EF4-FFF2-40B4-BE49-F238E27FC236}">
-                <a16:creationId xmlns:a16="http://schemas.microsoft.com/office/drawing/2014/main" id="{128D549D-F223-58AE-2C33-047B08E0D601}"/>
+                <a16:creationId xmlns:a16="http://schemas.microsoft.com/office/drawing/2014/main" id="{9E74C5A0-EBBD-C3B5-71E1-1C104747C978}"/>
               </a:ext>
             </a:extLst>
           </p:cNvPr>
@@ -1195,7 +1195,7 @@
           <a:bodyPr/>
           <a:lstStyle/>
           <a:p>
-            <a:fld id="{ABD641DF-BBFB-4415-A959-2AE3777557CA}" type="slidenum">
+            <a:fld id="{1E42A513-68A6-42F7-94CC-B181D5F7CFB8}" type="slidenum">
               <a:rPr lang="en-US" smtClean="0"/>
               <a:t>‹#›</a:t>
             </a:fld>
@@ -1206,7 +1206,7 @@
     </p:spTree>
     <p:extLst>
       <p:ext uri="{BB962C8B-B14F-4D97-AF65-F5344CB8AC3E}">
-        <p14:creationId xmlns:p14="http://schemas.microsoft.com/office/powerpoint/2010/main" val="4268976009"/>
+        <p14:creationId xmlns:p14="http://schemas.microsoft.com/office/powerpoint/2010/main" val="4143902439"/>
       </p:ext>
     </p:extLst>
   </p:cSld>
@@ -1238,7 +1238,7 @@
           <p:cNvPr id="2" name="Title 1">
             <a:extLst>
               <a:ext uri="{FF2B5EF4-FFF2-40B4-BE49-F238E27FC236}">
-                <a16:creationId xmlns:a16="http://schemas.microsoft.com/office/drawing/2014/main" id="{43F214C0-7DDC-2547-1E5E-4ECDD0BF2DDA}"/>
+                <a16:creationId xmlns:a16="http://schemas.microsoft.com/office/drawing/2014/main" id="{0DA08D84-4E49-1637-3A04-E67B3CCF62B8}"/>
               </a:ext>
             </a:extLst>
           </p:cNvPr>
@@ -1266,7 +1266,7 @@
           <p:cNvPr id="3" name="Content Placeholder 2">
             <a:extLst>
               <a:ext uri="{FF2B5EF4-FFF2-40B4-BE49-F238E27FC236}">
-                <a16:creationId xmlns:a16="http://schemas.microsoft.com/office/drawing/2014/main" id="{5022BFAE-95F8-8CB9-D0B9-B8A529FB12ED}"/>
+                <a16:creationId xmlns:a16="http://schemas.microsoft.com/office/drawing/2014/main" id="{B52C1875-07EE-A050-FFE1-E4A4C4690F8A}"/>
               </a:ext>
             </a:extLst>
           </p:cNvPr>
@@ -1328,7 +1328,7 @@
           <p:cNvPr id="4" name="Content Placeholder 3">
             <a:extLst>
               <a:ext uri="{FF2B5EF4-FFF2-40B4-BE49-F238E27FC236}">
-                <a16:creationId xmlns:a16="http://schemas.microsoft.com/office/drawing/2014/main" id="{15D8A6D8-C6A1-9499-2C25-9097BF2EB4F8}"/>
+                <a16:creationId xmlns:a16="http://schemas.microsoft.com/office/drawing/2014/main" id="{FF795A98-BD01-6CC6-F242-8A3ECA85ACD3}"/>
               </a:ext>
             </a:extLst>
           </p:cNvPr>
@@ -1390,7 +1390,7 @@
           <p:cNvPr id="5" name="Date Placeholder 4">
             <a:extLst>
               <a:ext uri="{FF2B5EF4-FFF2-40B4-BE49-F238E27FC236}">
-                <a16:creationId xmlns:a16="http://schemas.microsoft.com/office/drawing/2014/main" id="{C8E3D635-C642-D571-424A-4A11A1E26EB7}"/>
+                <a16:creationId xmlns:a16="http://schemas.microsoft.com/office/drawing/2014/main" id="{61DE5EF6-41D9-959A-10FD-612BD83F351F}"/>
               </a:ext>
             </a:extLst>
           </p:cNvPr>
@@ -1406,7 +1406,7 @@
           <a:bodyPr/>
           <a:lstStyle/>
           <a:p>
-            <a:fld id="{DE32CFBE-E2A3-4D0D-AC42-676856CBE8FF}" type="datetimeFigureOut">
+            <a:fld id="{EFC7B293-C39B-4341-97D8-8A5D589474B0}" type="datetimeFigureOut">
               <a:rPr lang="en-US" smtClean="0"/>
               <a:t>4/11/2026</a:t>
             </a:fld>
@@ -1419,7 +1419,7 @@
           <p:cNvPr id="6" name="Footer Placeholder 5">
             <a:extLst>
               <a:ext uri="{FF2B5EF4-FFF2-40B4-BE49-F238E27FC236}">
-                <a16:creationId xmlns:a16="http://schemas.microsoft.com/office/drawing/2014/main" id="{AB499CC4-D8A4-01AC-8004-DEC0D2DF8637}"/>
+                <a16:creationId xmlns:a16="http://schemas.microsoft.com/office/drawing/2014/main" id="{DAB01AA7-E5AB-912C-8E48-E5281BCCEAB8}"/>
               </a:ext>
             </a:extLst>
           </p:cNvPr>
@@ -1444,7 +1444,7 @@
           <p:cNvPr id="7" name="Slide Number Placeholder 6">
             <a:extLst>
               <a:ext uri="{FF2B5EF4-FFF2-40B4-BE49-F238E27FC236}">
-                <a16:creationId xmlns:a16="http://schemas.microsoft.com/office/drawing/2014/main" id="{2CCDA1D3-51FE-115D-308A-7D5EACED06DC}"/>
+                <a16:creationId xmlns:a16="http://schemas.microsoft.com/office/drawing/2014/main" id="{1A04BB1B-E86A-DA32-2EE5-ED08712B5CFD}"/>
               </a:ext>
             </a:extLst>
           </p:cNvPr>
@@ -1460,7 +1460,7 @@
           <a:bodyPr/>
           <a:lstStyle/>
           <a:p>
-            <a:fld id="{ABD641DF-BBFB-4415-A959-2AE3777557CA}" type="slidenum">
+            <a:fld id="{1E42A513-68A6-42F7-94CC-B181D5F7CFB8}" type="slidenum">
               <a:rPr lang="en-US" smtClean="0"/>
               <a:t>‹#›</a:t>
             </a:fld>
@@ -1471,7 +1471,7 @@
     </p:spTree>
     <p:extLst>
       <p:ext uri="{BB962C8B-B14F-4D97-AF65-F5344CB8AC3E}">
-        <p14:creationId xmlns:p14="http://schemas.microsoft.com/office/powerpoint/2010/main" val="3626741739"/>
+        <p14:creationId xmlns:p14="http://schemas.microsoft.com/office/powerpoint/2010/main" val="305011567"/>
       </p:ext>
     </p:extLst>
   </p:cSld>
@@ -1503,7 +1503,7 @@
           <p:cNvPr id="2" name="Title 1">
             <a:extLst>
               <a:ext uri="{FF2B5EF4-FFF2-40B4-BE49-F238E27FC236}">
-                <a16:creationId xmlns:a16="http://schemas.microsoft.com/office/drawing/2014/main" id="{62AE15A9-0B84-C4BC-6A62-7FBC55003B6F}"/>
+                <a16:creationId xmlns:a16="http://schemas.microsoft.com/office/drawing/2014/main" id="{59D8796A-3A90-6194-C5E7-DBEAFBE583A8}"/>
               </a:ext>
             </a:extLst>
           </p:cNvPr>
@@ -1536,7 +1536,7 @@
           <p:cNvPr id="3" name="Text Placeholder 2">
             <a:extLst>
               <a:ext uri="{FF2B5EF4-FFF2-40B4-BE49-F238E27FC236}">
-                <a16:creationId xmlns:a16="http://schemas.microsoft.com/office/drawing/2014/main" id="{C69F7972-E74F-CCB7-1414-A478F6BBAD47}"/>
+                <a16:creationId xmlns:a16="http://schemas.microsoft.com/office/drawing/2014/main" id="{AA209B99-A3E1-51BA-F792-2618108BF0A3}"/>
               </a:ext>
             </a:extLst>
           </p:cNvPr>
@@ -1607,7 +1607,7 @@
           <p:cNvPr id="4" name="Content Placeholder 3">
             <a:extLst>
               <a:ext uri="{FF2B5EF4-FFF2-40B4-BE49-F238E27FC236}">
-                <a16:creationId xmlns:a16="http://schemas.microsoft.com/office/drawing/2014/main" id="{4BAF5B6A-CBD3-DC7E-3C05-BE593650A696}"/>
+                <a16:creationId xmlns:a16="http://schemas.microsoft.com/office/drawing/2014/main" id="{DCB3E1F2-FC7C-876E-4082-E608A3427066}"/>
               </a:ext>
             </a:extLst>
           </p:cNvPr>
@@ -1669,7 +1669,7 @@
           <p:cNvPr id="5" name="Text Placeholder 4">
             <a:extLst>
               <a:ext uri="{FF2B5EF4-FFF2-40B4-BE49-F238E27FC236}">
-                <a16:creationId xmlns:a16="http://schemas.microsoft.com/office/drawing/2014/main" id="{634A6D93-F6A6-2E66-C6B3-275310B1E444}"/>
+                <a16:creationId xmlns:a16="http://schemas.microsoft.com/office/drawing/2014/main" id="{A840A954-B3D2-0D69-7A87-4589C93835D3}"/>
               </a:ext>
             </a:extLst>
           </p:cNvPr>
@@ -1740,7 +1740,7 @@
           <p:cNvPr id="6" name="Content Placeholder 5">
             <a:extLst>
               <a:ext uri="{FF2B5EF4-FFF2-40B4-BE49-F238E27FC236}">
-                <a16:creationId xmlns:a16="http://schemas.microsoft.com/office/drawing/2014/main" id="{019054A6-4511-0ACF-6BDA-B0E759FA0B7F}"/>
+                <a16:creationId xmlns:a16="http://schemas.microsoft.com/office/drawing/2014/main" id="{60C643D7-641B-5D83-83D5-D5E800B064B3}"/>
               </a:ext>
             </a:extLst>
           </p:cNvPr>
@@ -1802,7 +1802,7 @@
           <p:cNvPr id="7" name="Date Placeholder 6">
             <a:extLst>
               <a:ext uri="{FF2B5EF4-FFF2-40B4-BE49-F238E27FC236}">
-                <a16:creationId xmlns:a16="http://schemas.microsoft.com/office/drawing/2014/main" id="{AB2B6F2A-E40F-CF98-E826-05CE67F9201E}"/>
+                <a16:creationId xmlns:a16="http://schemas.microsoft.com/office/drawing/2014/main" id="{38938BFC-1D0F-A32A-5988-7DCD9019634E}"/>
               </a:ext>
             </a:extLst>
           </p:cNvPr>
@@ -1818,7 +1818,7 @@
           <a:bodyPr/>
           <a:lstStyle/>
           <a:p>
-            <a:fld id="{DE32CFBE-E2A3-4D0D-AC42-676856CBE8FF}" type="datetimeFigureOut">
+            <a:fld id="{EFC7B293-C39B-4341-97D8-8A5D589474B0}" type="datetimeFigureOut">
               <a:rPr lang="en-US" smtClean="0"/>
               <a:t>4/11/2026</a:t>
             </a:fld>
@@ -1831,7 +1831,7 @@
           <p:cNvPr id="8" name="Footer Placeholder 7">
             <a:extLst>
               <a:ext uri="{FF2B5EF4-FFF2-40B4-BE49-F238E27FC236}">
-                <a16:creationId xmlns:a16="http://schemas.microsoft.com/office/drawing/2014/main" id="{44295A94-A09D-6BBC-8E92-768B62437ACF}"/>
+                <a16:creationId xmlns:a16="http://schemas.microsoft.com/office/drawing/2014/main" id="{C63177B4-DB06-4823-B350-D8C29306F4B6}"/>
               </a:ext>
             </a:extLst>
           </p:cNvPr>
@@ -1856,7 +1856,7 @@
           <p:cNvPr id="9" name="Slide Number Placeholder 8">
             <a:extLst>
               <a:ext uri="{FF2B5EF4-FFF2-40B4-BE49-F238E27FC236}">
-                <a16:creationId xmlns:a16="http://schemas.microsoft.com/office/drawing/2014/main" id="{448278A4-58EC-F6F5-D523-284577AB79E1}"/>
+                <a16:creationId xmlns:a16="http://schemas.microsoft.com/office/drawing/2014/main" id="{AD6B9A2F-27FF-89EB-DC43-CA20A931F6A1}"/>
               </a:ext>
             </a:extLst>
           </p:cNvPr>
@@ -1872,7 +1872,7 @@
           <a:bodyPr/>
           <a:lstStyle/>
           <a:p>
-            <a:fld id="{ABD641DF-BBFB-4415-A959-2AE3777557CA}" type="slidenum">
+            <a:fld id="{1E42A513-68A6-42F7-94CC-B181D5F7CFB8}" type="slidenum">
               <a:rPr lang="en-US" smtClean="0"/>
               <a:t>‹#›</a:t>
             </a:fld>
@@ -1883,7 +1883,7 @@
     </p:spTree>
     <p:extLst>
       <p:ext uri="{BB962C8B-B14F-4D97-AF65-F5344CB8AC3E}">
-        <p14:creationId xmlns:p14="http://schemas.microsoft.com/office/powerpoint/2010/main" val="2439381583"/>
+        <p14:creationId xmlns:p14="http://schemas.microsoft.com/office/powerpoint/2010/main" val="785872257"/>
       </p:ext>
     </p:extLst>
   </p:cSld>
@@ -1915,7 +1915,7 @@
           <p:cNvPr id="2" name="Title 1">
             <a:extLst>
               <a:ext uri="{FF2B5EF4-FFF2-40B4-BE49-F238E27FC236}">
-                <a16:creationId xmlns:a16="http://schemas.microsoft.com/office/drawing/2014/main" id="{47376C8A-AA36-8124-355F-63374FCD9A20}"/>
+                <a16:creationId xmlns:a16="http://schemas.microsoft.com/office/drawing/2014/main" id="{7B734E6C-3453-8960-95C9-B0505EC4C108}"/>
               </a:ext>
             </a:extLst>
           </p:cNvPr>
@@ -1943,7 +1943,7 @@
           <p:cNvPr id="3" name="Date Placeholder 2">
             <a:extLst>
               <a:ext uri="{FF2B5EF4-FFF2-40B4-BE49-F238E27FC236}">
-                <a16:creationId xmlns:a16="http://schemas.microsoft.com/office/drawing/2014/main" id="{5B3CE494-1D5A-3370-AD28-4F0EE381936B}"/>
+                <a16:creationId xmlns:a16="http://schemas.microsoft.com/office/drawing/2014/main" id="{D47B2AC6-D81A-16E3-3AB5-3B14F1C131AF}"/>
               </a:ext>
             </a:extLst>
           </p:cNvPr>
@@ -1959,7 +1959,7 @@
           <a:bodyPr/>
           <a:lstStyle/>
           <a:p>
-            <a:fld id="{DE32CFBE-E2A3-4D0D-AC42-676856CBE8FF}" type="datetimeFigureOut">
+            <a:fld id="{EFC7B293-C39B-4341-97D8-8A5D589474B0}" type="datetimeFigureOut">
               <a:rPr lang="en-US" smtClean="0"/>
               <a:t>4/11/2026</a:t>
             </a:fld>
@@ -1972,7 +1972,7 @@
           <p:cNvPr id="4" name="Footer Placeholder 3">
             <a:extLst>
               <a:ext uri="{FF2B5EF4-FFF2-40B4-BE49-F238E27FC236}">
-                <a16:creationId xmlns:a16="http://schemas.microsoft.com/office/drawing/2014/main" id="{71CB9BB2-BC75-870B-28CC-D376E28026E3}"/>
+                <a16:creationId xmlns:a16="http://schemas.microsoft.com/office/drawing/2014/main" id="{B7DD85EC-27D8-F58A-96B1-6817C3555EAA}"/>
               </a:ext>
             </a:extLst>
           </p:cNvPr>
@@ -1997,7 +1997,7 @@
           <p:cNvPr id="5" name="Slide Number Placeholder 4">
             <a:extLst>
               <a:ext uri="{FF2B5EF4-FFF2-40B4-BE49-F238E27FC236}">
-                <a16:creationId xmlns:a16="http://schemas.microsoft.com/office/drawing/2014/main" id="{F13BB3BC-B547-E1BA-F268-7526AD5238F7}"/>
+                <a16:creationId xmlns:a16="http://schemas.microsoft.com/office/drawing/2014/main" id="{66AF8BDD-BAF5-36D9-D231-89ED42CA2D4F}"/>
               </a:ext>
             </a:extLst>
           </p:cNvPr>
@@ -2013,7 +2013,7 @@
           <a:bodyPr/>
           <a:lstStyle/>
           <a:p>
-            <a:fld id="{ABD641DF-BBFB-4415-A959-2AE3777557CA}" type="slidenum">
+            <a:fld id="{1E42A513-68A6-42F7-94CC-B181D5F7CFB8}" type="slidenum">
               <a:rPr lang="en-US" smtClean="0"/>
               <a:t>‹#›</a:t>
             </a:fld>
@@ -2024,7 +2024,7 @@
     </p:spTree>
     <p:extLst>
       <p:ext uri="{BB962C8B-B14F-4D97-AF65-F5344CB8AC3E}">
-        <p14:creationId xmlns:p14="http://schemas.microsoft.com/office/powerpoint/2010/main" val="1074389739"/>
+        <p14:creationId xmlns:p14="http://schemas.microsoft.com/office/powerpoint/2010/main" val="1720431638"/>
       </p:ext>
     </p:extLst>
   </p:cSld>
@@ -2056,7 +2056,7 @@
           <p:cNvPr id="2" name="Date Placeholder 1">
             <a:extLst>
               <a:ext uri="{FF2B5EF4-FFF2-40B4-BE49-F238E27FC236}">
-                <a16:creationId xmlns:a16="http://schemas.microsoft.com/office/drawing/2014/main" id="{C0288F58-A5CD-FB56-2B17-8BD46580ED5F}"/>
+                <a16:creationId xmlns:a16="http://schemas.microsoft.com/office/drawing/2014/main" id="{ADC5EB96-24FA-2819-D9D8-978B66D24A28}"/>
               </a:ext>
             </a:extLst>
           </p:cNvPr>
@@ -2072,7 +2072,7 @@
           <a:bodyPr/>
           <a:lstStyle/>
           <a:p>
-            <a:fld id="{DE32CFBE-E2A3-4D0D-AC42-676856CBE8FF}" type="datetimeFigureOut">
+            <a:fld id="{EFC7B293-C39B-4341-97D8-8A5D589474B0}" type="datetimeFigureOut">
               <a:rPr lang="en-US" smtClean="0"/>
               <a:t>4/11/2026</a:t>
             </a:fld>
@@ -2085,7 +2085,7 @@
           <p:cNvPr id="3" name="Footer Placeholder 2">
             <a:extLst>
               <a:ext uri="{FF2B5EF4-FFF2-40B4-BE49-F238E27FC236}">
-                <a16:creationId xmlns:a16="http://schemas.microsoft.com/office/drawing/2014/main" id="{E66FAE9F-078C-4AFD-09C1-269634E5A14E}"/>
+                <a16:creationId xmlns:a16="http://schemas.microsoft.com/office/drawing/2014/main" id="{A82DF6A0-6A06-08DE-46E0-37072CE6B8E0}"/>
               </a:ext>
             </a:extLst>
           </p:cNvPr>
@@ -2110,7 +2110,7 @@
           <p:cNvPr id="4" name="Slide Number Placeholder 3">
             <a:extLst>
               <a:ext uri="{FF2B5EF4-FFF2-40B4-BE49-F238E27FC236}">
-                <a16:creationId xmlns:a16="http://schemas.microsoft.com/office/drawing/2014/main" id="{E20D4DCB-1A94-3697-006A-4793C6160A7D}"/>
+                <a16:creationId xmlns:a16="http://schemas.microsoft.com/office/drawing/2014/main" id="{2F448D67-1696-EF86-C59E-E6CC4430551C}"/>
               </a:ext>
             </a:extLst>
           </p:cNvPr>
@@ -2126,7 +2126,7 @@
           <a:bodyPr/>
           <a:lstStyle/>
           <a:p>
-            <a:fld id="{ABD641DF-BBFB-4415-A959-2AE3777557CA}" type="slidenum">
+            <a:fld id="{1E42A513-68A6-42F7-94CC-B181D5F7CFB8}" type="slidenum">
               <a:rPr lang="en-US" smtClean="0"/>
               <a:t>‹#›</a:t>
             </a:fld>
@@ -2137,7 +2137,7 @@
     </p:spTree>
     <p:extLst>
       <p:ext uri="{BB962C8B-B14F-4D97-AF65-F5344CB8AC3E}">
-        <p14:creationId xmlns:p14="http://schemas.microsoft.com/office/powerpoint/2010/main" val="2813268537"/>
+        <p14:creationId xmlns:p14="http://schemas.microsoft.com/office/powerpoint/2010/main" val="3410793900"/>
       </p:ext>
     </p:extLst>
   </p:cSld>
@@ -2169,7 +2169,7 @@
           <p:cNvPr id="2" name="Title 1">
             <a:extLst>
               <a:ext uri="{FF2B5EF4-FFF2-40B4-BE49-F238E27FC236}">
-                <a16:creationId xmlns:a16="http://schemas.microsoft.com/office/drawing/2014/main" id="{C7F217FB-AAC6-6511-444D-E3660E827961}"/>
+                <a16:creationId xmlns:a16="http://schemas.microsoft.com/office/drawing/2014/main" id="{26D1EF70-F521-B823-E51E-ADD771F0C0B1}"/>
               </a:ext>
             </a:extLst>
           </p:cNvPr>
@@ -2206,7 +2206,7 @@
           <p:cNvPr id="3" name="Content Placeholder 2">
             <a:extLst>
               <a:ext uri="{FF2B5EF4-FFF2-40B4-BE49-F238E27FC236}">
-                <a16:creationId xmlns:a16="http://schemas.microsoft.com/office/drawing/2014/main" id="{09C079D9-4839-A8C9-2776-D2FB30633798}"/>
+                <a16:creationId xmlns:a16="http://schemas.microsoft.com/office/drawing/2014/main" id="{0FFD40D8-A5DF-785D-05F9-CE5FBD8DDA95}"/>
               </a:ext>
             </a:extLst>
           </p:cNvPr>
@@ -2296,7 +2296,7 @@
           <p:cNvPr id="4" name="Text Placeholder 3">
             <a:extLst>
               <a:ext uri="{FF2B5EF4-FFF2-40B4-BE49-F238E27FC236}">
-                <a16:creationId xmlns:a16="http://schemas.microsoft.com/office/drawing/2014/main" id="{E917F120-87A8-A980-40CC-16F7C2B53E71}"/>
+                <a16:creationId xmlns:a16="http://schemas.microsoft.com/office/drawing/2014/main" id="{E963F68A-7D48-9569-D6E6-D102D7B40987}"/>
               </a:ext>
             </a:extLst>
           </p:cNvPr>
@@ -2367,7 +2367,7 @@
           <p:cNvPr id="5" name="Date Placeholder 4">
             <a:extLst>
               <a:ext uri="{FF2B5EF4-FFF2-40B4-BE49-F238E27FC236}">
-                <a16:creationId xmlns:a16="http://schemas.microsoft.com/office/drawing/2014/main" id="{7FE42A45-537E-E35F-4B4A-E42E21D552B2}"/>
+                <a16:creationId xmlns:a16="http://schemas.microsoft.com/office/drawing/2014/main" id="{85EF194D-7F6C-AAD5-9424-BC0FD8CEA343}"/>
               </a:ext>
             </a:extLst>
           </p:cNvPr>
@@ -2383,7 +2383,7 @@
           <a:bodyPr/>
           <a:lstStyle/>
           <a:p>
-            <a:fld id="{DE32CFBE-E2A3-4D0D-AC42-676856CBE8FF}" type="datetimeFigureOut">
+            <a:fld id="{EFC7B293-C39B-4341-97D8-8A5D589474B0}" type="datetimeFigureOut">
               <a:rPr lang="en-US" smtClean="0"/>
               <a:t>4/11/2026</a:t>
             </a:fld>
@@ -2396,7 +2396,7 @@
           <p:cNvPr id="6" name="Footer Placeholder 5">
             <a:extLst>
               <a:ext uri="{FF2B5EF4-FFF2-40B4-BE49-F238E27FC236}">
-                <a16:creationId xmlns:a16="http://schemas.microsoft.com/office/drawing/2014/main" id="{0B1D6729-3726-A43E-8D64-EE7CF9B7C9DE}"/>
+                <a16:creationId xmlns:a16="http://schemas.microsoft.com/office/drawing/2014/main" id="{C6C90EE8-A6D7-F920-B3EB-86A3DE5B05A2}"/>
               </a:ext>
             </a:extLst>
           </p:cNvPr>
@@ -2421,7 +2421,7 @@
           <p:cNvPr id="7" name="Slide Number Placeholder 6">
             <a:extLst>
               <a:ext uri="{FF2B5EF4-FFF2-40B4-BE49-F238E27FC236}">
-                <a16:creationId xmlns:a16="http://schemas.microsoft.com/office/drawing/2014/main" id="{4980F1C4-A659-F47D-90C7-B795502A18A5}"/>
+                <a16:creationId xmlns:a16="http://schemas.microsoft.com/office/drawing/2014/main" id="{6DA53E23-DD7C-E43C-6119-816C30EAFE26}"/>
               </a:ext>
             </a:extLst>
           </p:cNvPr>
@@ -2437,7 +2437,7 @@
           <a:bodyPr/>
           <a:lstStyle/>
           <a:p>
-            <a:fld id="{ABD641DF-BBFB-4415-A959-2AE3777557CA}" type="slidenum">
+            <a:fld id="{1E42A513-68A6-42F7-94CC-B181D5F7CFB8}" type="slidenum">
               <a:rPr lang="en-US" smtClean="0"/>
               <a:t>‹#›</a:t>
             </a:fld>
@@ -2448,7 +2448,7 @@
     </p:spTree>
     <p:extLst>
       <p:ext uri="{BB962C8B-B14F-4D97-AF65-F5344CB8AC3E}">
-        <p14:creationId xmlns:p14="http://schemas.microsoft.com/office/powerpoint/2010/main" val="963107704"/>
+        <p14:creationId xmlns:p14="http://schemas.microsoft.com/office/powerpoint/2010/main" val="2126612357"/>
       </p:ext>
     </p:extLst>
   </p:cSld>
@@ -2480,7 +2480,7 @@
           <p:cNvPr id="2" name="Title 1">
             <a:extLst>
               <a:ext uri="{FF2B5EF4-FFF2-40B4-BE49-F238E27FC236}">
-                <a16:creationId xmlns:a16="http://schemas.microsoft.com/office/drawing/2014/main" id="{78FF4605-78C4-3595-9689-9D6C61D936C2}"/>
+                <a16:creationId xmlns:a16="http://schemas.microsoft.com/office/drawing/2014/main" id="{489103C6-3A31-FF88-968B-0642858CEF4B}"/>
               </a:ext>
             </a:extLst>
           </p:cNvPr>
@@ -2517,7 +2517,7 @@
           <p:cNvPr id="3" name="Picture Placeholder 2">
             <a:extLst>
               <a:ext uri="{FF2B5EF4-FFF2-40B4-BE49-F238E27FC236}">
-                <a16:creationId xmlns:a16="http://schemas.microsoft.com/office/drawing/2014/main" id="{05E6BE18-A072-1C17-E9D0-F29719D32196}"/>
+                <a16:creationId xmlns:a16="http://schemas.microsoft.com/office/drawing/2014/main" id="{4C93C130-2A6B-BD35-96C4-3FA7F0CC62AC}"/>
               </a:ext>
             </a:extLst>
           </p:cNvPr>
@@ -2584,7 +2584,7 @@
           <p:cNvPr id="4" name="Text Placeholder 3">
             <a:extLst>
               <a:ext uri="{FF2B5EF4-FFF2-40B4-BE49-F238E27FC236}">
-                <a16:creationId xmlns:a16="http://schemas.microsoft.com/office/drawing/2014/main" id="{D459E428-0D19-87E4-D78B-C403C2136617}"/>
+                <a16:creationId xmlns:a16="http://schemas.microsoft.com/office/drawing/2014/main" id="{2D1F6DF4-CC4A-B7B7-3BE7-393DE4421B42}"/>
               </a:ext>
             </a:extLst>
           </p:cNvPr>
@@ -2655,7 +2655,7 @@
           <p:cNvPr id="5" name="Date Placeholder 4">
             <a:extLst>
               <a:ext uri="{FF2B5EF4-FFF2-40B4-BE49-F238E27FC236}">
-                <a16:creationId xmlns:a16="http://schemas.microsoft.com/office/drawing/2014/main" id="{E07D1AC1-9CA8-0832-C6DF-2E304532D822}"/>
+                <a16:creationId xmlns:a16="http://schemas.microsoft.com/office/drawing/2014/main" id="{0A27004A-CE81-477C-2B29-3291CFAF4379}"/>
               </a:ext>
             </a:extLst>
           </p:cNvPr>
@@ -2671,7 +2671,7 @@
           <a:bodyPr/>
           <a:lstStyle/>
           <a:p>
-            <a:fld id="{DE32CFBE-E2A3-4D0D-AC42-676856CBE8FF}" type="datetimeFigureOut">
+            <a:fld id="{EFC7B293-C39B-4341-97D8-8A5D589474B0}" type="datetimeFigureOut">
               <a:rPr lang="en-US" smtClean="0"/>
               <a:t>4/11/2026</a:t>
             </a:fld>
@@ -2684,7 +2684,7 @@
           <p:cNvPr id="6" name="Footer Placeholder 5">
             <a:extLst>
               <a:ext uri="{FF2B5EF4-FFF2-40B4-BE49-F238E27FC236}">
-                <a16:creationId xmlns:a16="http://schemas.microsoft.com/office/drawing/2014/main" id="{F77EEEEF-6D19-E947-54CC-B7E1D5DFEAA9}"/>
+                <a16:creationId xmlns:a16="http://schemas.microsoft.com/office/drawing/2014/main" id="{BE8B3C0B-0CDC-6447-73AD-2495AF2FB3F9}"/>
               </a:ext>
             </a:extLst>
           </p:cNvPr>
@@ -2709,7 +2709,7 @@
           <p:cNvPr id="7" name="Slide Number Placeholder 6">
             <a:extLst>
               <a:ext uri="{FF2B5EF4-FFF2-40B4-BE49-F238E27FC236}">
-                <a16:creationId xmlns:a16="http://schemas.microsoft.com/office/drawing/2014/main" id="{536989F2-22EF-F5C9-9FC6-C7CFB01E5FAD}"/>
+                <a16:creationId xmlns:a16="http://schemas.microsoft.com/office/drawing/2014/main" id="{68A7CBDB-38F4-50CA-2C27-7252820C7211}"/>
               </a:ext>
             </a:extLst>
           </p:cNvPr>
@@ -2725,7 +2725,7 @@
           <a:bodyPr/>
           <a:lstStyle/>
           <a:p>
-            <a:fld id="{ABD641DF-BBFB-4415-A959-2AE3777557CA}" type="slidenum">
+            <a:fld id="{1E42A513-68A6-42F7-94CC-B181D5F7CFB8}" type="slidenum">
               <a:rPr lang="en-US" smtClean="0"/>
               <a:t>‹#›</a:t>
             </a:fld>
@@ -2736,7 +2736,7 @@
     </p:spTree>
     <p:extLst>
       <p:ext uri="{BB962C8B-B14F-4D97-AF65-F5344CB8AC3E}">
-        <p14:creationId xmlns:p14="http://schemas.microsoft.com/office/powerpoint/2010/main" val="4216917104"/>
+        <p14:creationId xmlns:p14="http://schemas.microsoft.com/office/powerpoint/2010/main" val="3350915204"/>
       </p:ext>
     </p:extLst>
   </p:cSld>
@@ -2773,7 +2773,7 @@
           <p:cNvPr id="2" name="Title Placeholder 1">
             <a:extLst>
               <a:ext uri="{FF2B5EF4-FFF2-40B4-BE49-F238E27FC236}">
-                <a16:creationId xmlns:a16="http://schemas.microsoft.com/office/drawing/2014/main" id="{DED51573-3759-1B82-2BB0-40990D44302F}"/>
+                <a16:creationId xmlns:a16="http://schemas.microsoft.com/office/drawing/2014/main" id="{0DE83F64-15DE-C502-0202-02CD280E1EE6}"/>
               </a:ext>
             </a:extLst>
           </p:cNvPr>
@@ -2811,7 +2811,7 @@
           <p:cNvPr id="3" name="Text Placeholder 2">
             <a:extLst>
               <a:ext uri="{FF2B5EF4-FFF2-40B4-BE49-F238E27FC236}">
-                <a16:creationId xmlns:a16="http://schemas.microsoft.com/office/drawing/2014/main" id="{E139DE2A-7C16-66D0-BA1C-6262D2095D2F}"/>
+                <a16:creationId xmlns:a16="http://schemas.microsoft.com/office/drawing/2014/main" id="{D0EEAB74-A744-42E0-2970-E646CC9DB508}"/>
               </a:ext>
             </a:extLst>
           </p:cNvPr>
@@ -2878,7 +2878,7 @@
           <p:cNvPr id="4" name="Date Placeholder 3">
             <a:extLst>
               <a:ext uri="{FF2B5EF4-FFF2-40B4-BE49-F238E27FC236}">
-                <a16:creationId xmlns:a16="http://schemas.microsoft.com/office/drawing/2014/main" id="{37FAE4ED-1736-8E12-D5D1-D4EA851B0B07}"/>
+                <a16:creationId xmlns:a16="http://schemas.microsoft.com/office/drawing/2014/main" id="{1D9F8FDD-ADE4-A755-2FA1-79CB129693DA}"/>
               </a:ext>
             </a:extLst>
           </p:cNvPr>
@@ -2912,7 +2912,7 @@
             </a:lvl1pPr>
           </a:lstStyle>
           <a:p>
-            <a:fld id="{DE32CFBE-E2A3-4D0D-AC42-676856CBE8FF}" type="datetimeFigureOut">
+            <a:fld id="{EFC7B293-C39B-4341-97D8-8A5D589474B0}" type="datetimeFigureOut">
               <a:rPr lang="en-US" smtClean="0"/>
               <a:t>4/11/2026</a:t>
             </a:fld>
@@ -2925,7 +2925,7 @@
           <p:cNvPr id="5" name="Footer Placeholder 4">
             <a:extLst>
               <a:ext uri="{FF2B5EF4-FFF2-40B4-BE49-F238E27FC236}">
-                <a16:creationId xmlns:a16="http://schemas.microsoft.com/office/drawing/2014/main" id="{1D7A06D8-F3CA-D772-74CD-BD08041797B9}"/>
+                <a16:creationId xmlns:a16="http://schemas.microsoft.com/office/drawing/2014/main" id="{D51FA743-4839-2FB3-6A81-F92D5B4DB6E4}"/>
               </a:ext>
             </a:extLst>
           </p:cNvPr>
@@ -2968,7 +2968,7 @@
           <p:cNvPr id="6" name="Slide Number Placeholder 5">
             <a:extLst>
               <a:ext uri="{FF2B5EF4-FFF2-40B4-BE49-F238E27FC236}">
-                <a16:creationId xmlns:a16="http://schemas.microsoft.com/office/drawing/2014/main" id="{B6262B38-440F-6225-93B4-171DBB3EDA4D}"/>
+                <a16:creationId xmlns:a16="http://schemas.microsoft.com/office/drawing/2014/main" id="{083419FE-DEA7-DE89-1F06-CBFB24EC4E3F}"/>
               </a:ext>
             </a:extLst>
           </p:cNvPr>
@@ -3002,7 +3002,7 @@
             </a:lvl1pPr>
           </a:lstStyle>
           <a:p>
-            <a:fld id="{ABD641DF-BBFB-4415-A959-2AE3777557CA}" type="slidenum">
+            <a:fld id="{1E42A513-68A6-42F7-94CC-B181D5F7CFB8}" type="slidenum">
               <a:rPr lang="en-US" smtClean="0"/>
               <a:t>‹#›</a:t>
             </a:fld>
@@ -3013,7 +3013,7 @@
     </p:spTree>
     <p:extLst>
       <p:ext uri="{BB962C8B-B14F-4D97-AF65-F5344CB8AC3E}">
-        <p14:creationId xmlns:p14="http://schemas.microsoft.com/office/powerpoint/2010/main" val="4182145208"/>
+        <p14:creationId xmlns:p14="http://schemas.microsoft.com/office/powerpoint/2010/main" val="1948317811"/>
       </p:ext>
     </p:extLst>
   </p:cSld>
@@ -3336,7 +3336,7 @@
           <p:cNvPr id="2" name="Title 1">
             <a:extLst>
               <a:ext uri="{FF2B5EF4-FFF2-40B4-BE49-F238E27FC236}">
-                <a16:creationId xmlns:a16="http://schemas.microsoft.com/office/drawing/2014/main" id="{C787B214-115D-15B0-C1C3-B7F320BC08A3}"/>
+                <a16:creationId xmlns:a16="http://schemas.microsoft.com/office/drawing/2014/main" id="{7D4E470A-88BA-C0EE-CB14-A66CCACBD3B4}"/>
               </a:ext>
             </a:extLst>
           </p:cNvPr>
@@ -3368,7 +3368,7 @@
           <p:cNvPr id="3" name="TextBox 2">
             <a:extLst>
               <a:ext uri="{FF2B5EF4-FFF2-40B4-BE49-F238E27FC236}">
-                <a16:creationId xmlns:a16="http://schemas.microsoft.com/office/drawing/2014/main" id="{D6C3695E-0E6C-B03A-D460-0521DCAE7FEB}"/>
+                <a16:creationId xmlns:a16="http://schemas.microsoft.com/office/drawing/2014/main" id="{4470E1FC-F68C-939D-C272-57E4F506D125}"/>
               </a:ext>
             </a:extLst>
           </p:cNvPr>
@@ -3459,7 +3459,7 @@
     </p:spTree>
     <p:extLst>
       <p:ext uri="{BB962C8B-B14F-4D97-AF65-F5344CB8AC3E}">
-        <p14:creationId xmlns:p14="http://schemas.microsoft.com/office/powerpoint/2010/main" val="1453023474"/>
+        <p14:creationId xmlns:p14="http://schemas.microsoft.com/office/powerpoint/2010/main" val="3813466840"/>
       </p:ext>
     </p:extLst>
   </p:cSld>
@@ -3491,7 +3491,7 @@
           <p:cNvPr id="2" name="Title 1">
             <a:extLst>
               <a:ext uri="{FF2B5EF4-FFF2-40B4-BE49-F238E27FC236}">
-                <a16:creationId xmlns:a16="http://schemas.microsoft.com/office/drawing/2014/main" id="{7C6FB571-59DF-3B6B-2EE1-CD00112A096C}"/>
+                <a16:creationId xmlns:a16="http://schemas.microsoft.com/office/drawing/2014/main" id="{9F101CC7-BAE3-6205-5598-60A9B398E898}"/>
               </a:ext>
             </a:extLst>
           </p:cNvPr>
@@ -3523,7 +3523,7 @@
           <p:cNvPr id="3" name="TextBox 2">
             <a:extLst>
               <a:ext uri="{FF2B5EF4-FFF2-40B4-BE49-F238E27FC236}">
-                <a16:creationId xmlns:a16="http://schemas.microsoft.com/office/drawing/2014/main" id="{642FDC5A-5551-0654-D6A0-A64045D7C7FE}"/>
+                <a16:creationId xmlns:a16="http://schemas.microsoft.com/office/drawing/2014/main" id="{5F8B3106-29FD-06E5-7F45-CDE1C9CF2FF6}"/>
               </a:ext>
             </a:extLst>
           </p:cNvPr>
@@ -3566,7 +3566,7 @@
               <a:rPr lang="en-US" sz="2200">
                 <a:latin typeface="Aptos" panose="020B0004020202020204" pitchFamily="34" charset="0"/>
               </a:rPr>
-              <a:t>2. open GitHub issues for BUG-20260411-002, BUG-20260411-003, and BUG-20260411-004</a:t>
+              <a:t>2. attach the saved package evidence to GitHub Issues #2, #3, and #4</a:t>
             </a:r>
           </a:p>
           <a:p>
@@ -3670,7 +3670,7 @@
     </p:spTree>
     <p:extLst>
       <p:ext uri="{BB962C8B-B14F-4D97-AF65-F5344CB8AC3E}">
-        <p14:creationId xmlns:p14="http://schemas.microsoft.com/office/powerpoint/2010/main" val="3442971497"/>
+        <p14:creationId xmlns:p14="http://schemas.microsoft.com/office/powerpoint/2010/main" val="1918212448"/>
       </p:ext>
     </p:extLst>
   </p:cSld>
@@ -3702,7 +3702,7 @@
           <p:cNvPr id="2" name="Title 1">
             <a:extLst>
               <a:ext uri="{FF2B5EF4-FFF2-40B4-BE49-F238E27FC236}">
-                <a16:creationId xmlns:a16="http://schemas.microsoft.com/office/drawing/2014/main" id="{922BA8EE-90D0-A218-E90A-59676E3A87CF}"/>
+                <a16:creationId xmlns:a16="http://schemas.microsoft.com/office/drawing/2014/main" id="{56389405-4355-EB10-8284-AEA67267F612}"/>
               </a:ext>
             </a:extLst>
           </p:cNvPr>
@@ -3734,7 +3734,7 @@
           <p:cNvPr id="3" name="TextBox 2">
             <a:extLst>
               <a:ext uri="{FF2B5EF4-FFF2-40B4-BE49-F238E27FC236}">
-                <a16:creationId xmlns:a16="http://schemas.microsoft.com/office/drawing/2014/main" id="{0FC06621-CF85-E2C0-FDB1-146F0A2483DA}"/>
+                <a16:creationId xmlns:a16="http://schemas.microsoft.com/office/drawing/2014/main" id="{8A49AB1A-E7BD-C808-C317-C539C3DDED3A}"/>
               </a:ext>
             </a:extLst>
           </p:cNvPr>
@@ -3769,15 +3769,15 @@
               <a:rPr lang="en-US" sz="2200">
                 <a:latin typeface="Aptos" panose="020B0004020202020204" pitchFamily="34" charset="0"/>
               </a:rPr>
-              <a:t>Why do you have 1 confirmed defect?</a:t>
-            </a:r>
-          </a:p>
-          <a:p>
-            <a:r>
-              <a:rPr lang="en-US" sz="2200">
-                <a:latin typeface="Aptos" panose="020B0004020202020204" pitchFamily="34" charset="0"/>
-              </a:rPr>
-              <a:t>Why is execution progress still low?</a:t>
+              <a:t>Why do you have 4 confirmed defects?</a:t>
+            </a:r>
+          </a:p>
+          <a:p>
+            <a:r>
+              <a:rPr lang="en-US" sz="2200">
+                <a:latin typeface="Aptos" panose="020B0004020202020204" pitchFamily="34" charset="0"/>
+              </a:rPr>
+              <a:t>Why is execution progress now 100%?</a:t>
             </a:r>
           </a:p>
           <a:p>
@@ -3809,7 +3809,7 @@
     </p:spTree>
     <p:extLst>
       <p:ext uri="{BB962C8B-B14F-4D97-AF65-F5344CB8AC3E}">
-        <p14:creationId xmlns:p14="http://schemas.microsoft.com/office/powerpoint/2010/main" val="685298245"/>
+        <p14:creationId xmlns:p14="http://schemas.microsoft.com/office/powerpoint/2010/main" val="3116988605"/>
       </p:ext>
     </p:extLst>
   </p:cSld>
@@ -3841,7 +3841,7 @@
           <p:cNvPr id="2" name="Title 1">
             <a:extLst>
               <a:ext uri="{FF2B5EF4-FFF2-40B4-BE49-F238E27FC236}">
-                <a16:creationId xmlns:a16="http://schemas.microsoft.com/office/drawing/2014/main" id="{FEA7A9DF-A40E-A48A-457D-A334FFA90BAB}"/>
+                <a16:creationId xmlns:a16="http://schemas.microsoft.com/office/drawing/2014/main" id="{89EF4DB3-BC61-0259-617C-7C326736948F}"/>
               </a:ext>
             </a:extLst>
           </p:cNvPr>
@@ -3873,7 +3873,7 @@
           <p:cNvPr id="3" name="TextBox 2">
             <a:extLst>
               <a:ext uri="{FF2B5EF4-FFF2-40B4-BE49-F238E27FC236}">
-                <a16:creationId xmlns:a16="http://schemas.microsoft.com/office/drawing/2014/main" id="{E7E0462C-9FDB-F7BF-3FAA-590972E2E012}"/>
+                <a16:creationId xmlns:a16="http://schemas.microsoft.com/office/drawing/2014/main" id="{31829902-406C-606D-CDF0-BFC175B7105C}"/>
               </a:ext>
             </a:extLst>
           </p:cNvPr>
@@ -3988,7 +3988,7 @@
     </p:spTree>
     <p:extLst>
       <p:ext uri="{BB962C8B-B14F-4D97-AF65-F5344CB8AC3E}">
-        <p14:creationId xmlns:p14="http://schemas.microsoft.com/office/powerpoint/2010/main" val="3809663234"/>
+        <p14:creationId xmlns:p14="http://schemas.microsoft.com/office/powerpoint/2010/main" val="3932739692"/>
       </p:ext>
     </p:extLst>
   </p:cSld>
@@ -4020,7 +4020,7 @@
           <p:cNvPr id="2" name="Title 1">
             <a:extLst>
               <a:ext uri="{FF2B5EF4-FFF2-40B4-BE49-F238E27FC236}">
-                <a16:creationId xmlns:a16="http://schemas.microsoft.com/office/drawing/2014/main" id="{3278F396-0A53-254F-0C13-0A7883D818A3}"/>
+                <a16:creationId xmlns:a16="http://schemas.microsoft.com/office/drawing/2014/main" id="{EA323ECF-AF6C-1FC1-0DBE-83C26C9BB4B7}"/>
               </a:ext>
             </a:extLst>
           </p:cNvPr>
@@ -4052,7 +4052,7 @@
           <p:cNvPr id="3" name="TextBox 2">
             <a:extLst>
               <a:ext uri="{FF2B5EF4-FFF2-40B4-BE49-F238E27FC236}">
-                <a16:creationId xmlns:a16="http://schemas.microsoft.com/office/drawing/2014/main" id="{02F60E0D-4E07-1A73-F14C-A3C9708E648F}"/>
+                <a16:creationId xmlns:a16="http://schemas.microsoft.com/office/drawing/2014/main" id="{EC23528D-80CF-0283-D8E8-D5AEB77575C4}"/>
               </a:ext>
             </a:extLst>
           </p:cNvPr>
@@ -4151,7 +4151,7 @@
     </p:spTree>
     <p:extLst>
       <p:ext uri="{BB962C8B-B14F-4D97-AF65-F5344CB8AC3E}">
-        <p14:creationId xmlns:p14="http://schemas.microsoft.com/office/powerpoint/2010/main" val="2834704052"/>
+        <p14:creationId xmlns:p14="http://schemas.microsoft.com/office/powerpoint/2010/main" val="4265834926"/>
       </p:ext>
     </p:extLst>
   </p:cSld>
@@ -4183,7 +4183,7 @@
           <p:cNvPr id="2" name="Title 1">
             <a:extLst>
               <a:ext uri="{FF2B5EF4-FFF2-40B4-BE49-F238E27FC236}">
-                <a16:creationId xmlns:a16="http://schemas.microsoft.com/office/drawing/2014/main" id="{CA1EF744-434B-E90E-2D96-25EC26448185}"/>
+                <a16:creationId xmlns:a16="http://schemas.microsoft.com/office/drawing/2014/main" id="{6074B849-B066-EB6F-A9EB-7B6D0DF6B351}"/>
               </a:ext>
             </a:extLst>
           </p:cNvPr>
@@ -4215,7 +4215,7 @@
           <p:cNvPr id="3" name="TextBox 2">
             <a:extLst>
               <a:ext uri="{FF2B5EF4-FFF2-40B4-BE49-F238E27FC236}">
-                <a16:creationId xmlns:a16="http://schemas.microsoft.com/office/drawing/2014/main" id="{3A01D83D-CFB4-2A44-15C1-C19920C85E84}"/>
+                <a16:creationId xmlns:a16="http://schemas.microsoft.com/office/drawing/2014/main" id="{4F68C5B4-4ECC-5E4A-5DBD-2C7BD7F48A59}"/>
               </a:ext>
             </a:extLst>
           </p:cNvPr>
@@ -4322,7 +4322,7 @@
     </p:spTree>
     <p:extLst>
       <p:ext uri="{BB962C8B-B14F-4D97-AF65-F5344CB8AC3E}">
-        <p14:creationId xmlns:p14="http://schemas.microsoft.com/office/powerpoint/2010/main" val="923438054"/>
+        <p14:creationId xmlns:p14="http://schemas.microsoft.com/office/powerpoint/2010/main" val="1742529042"/>
       </p:ext>
     </p:extLst>
   </p:cSld>
@@ -4354,7 +4354,7 @@
           <p:cNvPr id="2" name="Title 1">
             <a:extLst>
               <a:ext uri="{FF2B5EF4-FFF2-40B4-BE49-F238E27FC236}">
-                <a16:creationId xmlns:a16="http://schemas.microsoft.com/office/drawing/2014/main" id="{83CED03E-764A-2EE0-8249-F0C1CD4B1328}"/>
+                <a16:creationId xmlns:a16="http://schemas.microsoft.com/office/drawing/2014/main" id="{9CD46124-779D-E355-F1AB-32B20B239FB5}"/>
               </a:ext>
             </a:extLst>
           </p:cNvPr>
@@ -4386,7 +4386,7 @@
           <p:cNvPr id="3" name="TextBox 2">
             <a:extLst>
               <a:ext uri="{FF2B5EF4-FFF2-40B4-BE49-F238E27FC236}">
-                <a16:creationId xmlns:a16="http://schemas.microsoft.com/office/drawing/2014/main" id="{B311F15F-672D-9E74-15B9-189EA45F2438}"/>
+                <a16:creationId xmlns:a16="http://schemas.microsoft.com/office/drawing/2014/main" id="{2185FACF-8EB7-96E5-12D4-242404A071AC}"/>
               </a:ext>
             </a:extLst>
           </p:cNvPr>
@@ -4501,7 +4501,7 @@
     </p:spTree>
     <p:extLst>
       <p:ext uri="{BB962C8B-B14F-4D97-AF65-F5344CB8AC3E}">
-        <p14:creationId xmlns:p14="http://schemas.microsoft.com/office/powerpoint/2010/main" val="2605287177"/>
+        <p14:creationId xmlns:p14="http://schemas.microsoft.com/office/powerpoint/2010/main" val="647110517"/>
       </p:ext>
     </p:extLst>
   </p:cSld>
@@ -4533,7 +4533,7 @@
           <p:cNvPr id="2" name="Title 1">
             <a:extLst>
               <a:ext uri="{FF2B5EF4-FFF2-40B4-BE49-F238E27FC236}">
-                <a16:creationId xmlns:a16="http://schemas.microsoft.com/office/drawing/2014/main" id="{23006A04-0F07-DC87-3CBF-B7F501EDE607}"/>
+                <a16:creationId xmlns:a16="http://schemas.microsoft.com/office/drawing/2014/main" id="{80B59349-CB18-8063-0967-19A13C649A33}"/>
               </a:ext>
             </a:extLst>
           </p:cNvPr>
@@ -4565,7 +4565,7 @@
           <p:cNvPr id="3" name="TextBox 2">
             <a:extLst>
               <a:ext uri="{FF2B5EF4-FFF2-40B4-BE49-F238E27FC236}">
-                <a16:creationId xmlns:a16="http://schemas.microsoft.com/office/drawing/2014/main" id="{4E267EDF-E8D8-14CD-850B-C673F6713DDD}"/>
+                <a16:creationId xmlns:a16="http://schemas.microsoft.com/office/drawing/2014/main" id="{7822B5BA-CCFC-33DD-4EB1-3DF6946D4ED9}"/>
               </a:ext>
             </a:extLst>
           </p:cNvPr>
@@ -4722,7 +4722,7 @@
           <p:cNvPr id="5" name="Picture 4">
             <a:extLst>
               <a:ext uri="{FF2B5EF4-FFF2-40B4-BE49-F238E27FC236}">
-                <a16:creationId xmlns:a16="http://schemas.microsoft.com/office/drawing/2014/main" id="{8F5E30B2-FCAC-43BF-5D45-CE034BEEB6AF}"/>
+                <a16:creationId xmlns:a16="http://schemas.microsoft.com/office/drawing/2014/main" id="{56DC671F-BFC2-1150-361D-865EFDCF3098}"/>
               </a:ext>
             </a:extLst>
           </p:cNvPr>
@@ -4756,7 +4756,7 @@
     </p:spTree>
     <p:extLst>
       <p:ext uri="{BB962C8B-B14F-4D97-AF65-F5344CB8AC3E}">
-        <p14:creationId xmlns:p14="http://schemas.microsoft.com/office/powerpoint/2010/main" val="2367037776"/>
+        <p14:creationId xmlns:p14="http://schemas.microsoft.com/office/powerpoint/2010/main" val="855949967"/>
       </p:ext>
     </p:extLst>
   </p:cSld>
@@ -4788,7 +4788,7 @@
           <p:cNvPr id="2" name="Title 1">
             <a:extLst>
               <a:ext uri="{FF2B5EF4-FFF2-40B4-BE49-F238E27FC236}">
-                <a16:creationId xmlns:a16="http://schemas.microsoft.com/office/drawing/2014/main" id="{F974B3F3-4F75-8C6D-3377-CA860F547986}"/>
+                <a16:creationId xmlns:a16="http://schemas.microsoft.com/office/drawing/2014/main" id="{9B38594C-E952-F25D-C21E-E2540C3E3D70}"/>
               </a:ext>
             </a:extLst>
           </p:cNvPr>
@@ -4820,7 +4820,7 @@
           <p:cNvPr id="3" name="TextBox 2">
             <a:extLst>
               <a:ext uri="{FF2B5EF4-FFF2-40B4-BE49-F238E27FC236}">
-                <a16:creationId xmlns:a16="http://schemas.microsoft.com/office/drawing/2014/main" id="{13A64B92-C56D-12AC-5FF7-951130985110}"/>
+                <a16:creationId xmlns:a16="http://schemas.microsoft.com/office/drawing/2014/main" id="{BEEA19F3-00E6-D389-2C01-4FD322287F80}"/>
               </a:ext>
             </a:extLst>
           </p:cNvPr>
@@ -4945,7 +4945,7 @@
           <p:cNvPr id="5" name="Picture 4">
             <a:extLst>
               <a:ext uri="{FF2B5EF4-FFF2-40B4-BE49-F238E27FC236}">
-                <a16:creationId xmlns:a16="http://schemas.microsoft.com/office/drawing/2014/main" id="{01409513-418B-6F10-E011-2E7F9B3BEC1D}"/>
+                <a16:creationId xmlns:a16="http://schemas.microsoft.com/office/drawing/2014/main" id="{CADC0842-5834-0120-D665-B037F4B2D1D9}"/>
               </a:ext>
             </a:extLst>
           </p:cNvPr>
@@ -4979,7 +4979,7 @@
     </p:spTree>
     <p:extLst>
       <p:ext uri="{BB962C8B-B14F-4D97-AF65-F5344CB8AC3E}">
-        <p14:creationId xmlns:p14="http://schemas.microsoft.com/office/powerpoint/2010/main" val="488237658"/>
+        <p14:creationId xmlns:p14="http://schemas.microsoft.com/office/powerpoint/2010/main" val="1252753076"/>
       </p:ext>
     </p:extLst>
   </p:cSld>
@@ -5011,7 +5011,7 @@
           <p:cNvPr id="2" name="Title 1">
             <a:extLst>
               <a:ext uri="{FF2B5EF4-FFF2-40B4-BE49-F238E27FC236}">
-                <a16:creationId xmlns:a16="http://schemas.microsoft.com/office/drawing/2014/main" id="{CBCD18F5-C1DC-95B4-0A37-A6F42BC43DC1}"/>
+                <a16:creationId xmlns:a16="http://schemas.microsoft.com/office/drawing/2014/main" id="{2D7E75CF-71A9-0CE4-E2F1-BFDACA26F2DD}"/>
               </a:ext>
             </a:extLst>
           </p:cNvPr>
@@ -5043,7 +5043,7 @@
           <p:cNvPr id="3" name="TextBox 2">
             <a:extLst>
               <a:ext uri="{FF2B5EF4-FFF2-40B4-BE49-F238E27FC236}">
-                <a16:creationId xmlns:a16="http://schemas.microsoft.com/office/drawing/2014/main" id="{C2EB21BD-FD43-3DE9-B780-99A120141100}"/>
+                <a16:creationId xmlns:a16="http://schemas.microsoft.com/office/drawing/2014/main" id="{0BB10611-5CB4-7DBB-7169-28CA12C552DB}"/>
               </a:ext>
             </a:extLst>
           </p:cNvPr>
@@ -5053,7 +5053,7 @@
         <p:spPr>
           <a:xfrm>
             <a:off x="698500" y="1587500"/>
-            <a:ext cx="6604000" cy="5847755"/>
+            <a:ext cx="6604000" cy="6524863"/>
           </a:xfrm>
           <a:prstGeom prst="rect">
             <a:avLst/>
@@ -5094,23 +5094,23 @@
               <a:rPr lang="en-US" sz="2200">
                 <a:latin typeface="Aptos" panose="020B0004020202020204" pitchFamily="34" charset="0"/>
               </a:rPr>
-              <a:t>BUG-20260411-002 purchase validation banner defect</a:t>
-            </a:r>
-          </a:p>
-          <a:p>
-            <a:r>
-              <a:rPr lang="en-US" sz="2200">
-                <a:latin typeface="Aptos" panose="020B0004020202020204" pitchFamily="34" charset="0"/>
-              </a:rPr>
-              <a:t>BUG-20260411-003 import-confirm defect</a:t>
-            </a:r>
-          </a:p>
-          <a:p>
-            <a:r>
-              <a:rPr lang="en-US" sz="2200">
-                <a:latin typeface="Aptos" panose="020B0004020202020204" pitchFamily="34" charset="0"/>
-              </a:rPr>
-              <a:t>BUG-20260411-004 invoice-cancel defect</a:t>
+              <a:t>BUG-20260411-002 purchase validation banner defect, tracked in GitHub Issue #2</a:t>
+            </a:r>
+          </a:p>
+          <a:p>
+            <a:r>
+              <a:rPr lang="en-US" sz="2200">
+                <a:latin typeface="Aptos" panose="020B0004020202020204" pitchFamily="34" charset="0"/>
+              </a:rPr>
+              <a:t>BUG-20260411-003 import-confirm defect, tracked in GitHub Issue #3</a:t>
+            </a:r>
+          </a:p>
+          <a:p>
+            <a:r>
+              <a:rPr lang="en-US" sz="2200">
+                <a:latin typeface="Aptos" panose="020B0004020202020204" pitchFamily="34" charset="0"/>
+              </a:rPr>
+              <a:t>BUG-20260411-004 invoice-cancel defect, tracked in GitHub Issue #4</a:t>
             </a:r>
           </a:p>
           <a:p>
@@ -5184,7 +5184,7 @@
           <p:cNvPr id="5" name="Picture 4">
             <a:extLst>
               <a:ext uri="{FF2B5EF4-FFF2-40B4-BE49-F238E27FC236}">
-                <a16:creationId xmlns:a16="http://schemas.microsoft.com/office/drawing/2014/main" id="{61894093-E2EE-5538-7F16-F0A2282CCE0B}"/>
+                <a16:creationId xmlns:a16="http://schemas.microsoft.com/office/drawing/2014/main" id="{946522F4-012A-7C5C-2828-31097C10623C}"/>
               </a:ext>
             </a:extLst>
           </p:cNvPr>
@@ -5218,7 +5218,7 @@
     </p:spTree>
     <p:extLst>
       <p:ext uri="{BB962C8B-B14F-4D97-AF65-F5344CB8AC3E}">
-        <p14:creationId xmlns:p14="http://schemas.microsoft.com/office/powerpoint/2010/main" val="1230679560"/>
+        <p14:creationId xmlns:p14="http://schemas.microsoft.com/office/powerpoint/2010/main" val="2592893824"/>
       </p:ext>
     </p:extLst>
   </p:cSld>
@@ -5250,7 +5250,7 @@
           <p:cNvPr id="2" name="Title 1">
             <a:extLst>
               <a:ext uri="{FF2B5EF4-FFF2-40B4-BE49-F238E27FC236}">
-                <a16:creationId xmlns:a16="http://schemas.microsoft.com/office/drawing/2014/main" id="{2A025C4B-49C6-CE38-C4C6-B97FCF1C822B}"/>
+                <a16:creationId xmlns:a16="http://schemas.microsoft.com/office/drawing/2014/main" id="{359BE020-A800-6F6A-0B72-74E9B3BC85FC}"/>
               </a:ext>
             </a:extLst>
           </p:cNvPr>
@@ -5282,7 +5282,7 @@
           <p:cNvPr id="3" name="TextBox 2">
             <a:extLst>
               <a:ext uri="{FF2B5EF4-FFF2-40B4-BE49-F238E27FC236}">
-                <a16:creationId xmlns:a16="http://schemas.microsoft.com/office/drawing/2014/main" id="{2C78D205-57D0-9871-FD12-8868BADADBF7}"/>
+                <a16:creationId xmlns:a16="http://schemas.microsoft.com/office/drawing/2014/main" id="{165C5D9E-A901-520C-58AB-808CFCB5E679}"/>
               </a:ext>
             </a:extLst>
           </p:cNvPr>
@@ -5365,7 +5365,7 @@
               <a:rPr lang="en-US" sz="2200">
                 <a:latin typeface="Aptos" panose="020B0004020202020204" pitchFamily="34" charset="0"/>
               </a:rPr>
-              <a:t>post-fix retest and issue-tool expansion are still required for maximum confidence</a:t>
+              <a:t>post-fix retest is still required for maximum confidence</a:t>
             </a:r>
           </a:p>
         </p:txBody>
@@ -5373,7 +5373,7 @@
     </p:spTree>
     <p:extLst>
       <p:ext uri="{BB962C8B-B14F-4D97-AF65-F5344CB8AC3E}">
-        <p14:creationId xmlns:p14="http://schemas.microsoft.com/office/powerpoint/2010/main" val="4036155738"/>
+        <p14:creationId xmlns:p14="http://schemas.microsoft.com/office/powerpoint/2010/main" val="4089292942"/>
       </p:ext>
     </p:extLst>
   </p:cSld>

</xml_diff>

<commit_message>
docs: finalize powered by gpt submission package
</commit_message>
<xml_diff>
--- a/Report Test subject/Powered by GPT/MainReport/Powered by GPT - Software Quality Verification - Presentation.pptx
+++ b/Report Test subject/Powered by GPT/MainReport/Powered by GPT - Software Quality Verification - Presentation.pptx
@@ -139,7 +139,7 @@
           <p:cNvPr id="2" name="Title 1">
             <a:extLst>
               <a:ext uri="{FF2B5EF4-FFF2-40B4-BE49-F238E27FC236}">
-                <a16:creationId xmlns:a16="http://schemas.microsoft.com/office/drawing/2014/main" id="{FEE0F406-38B4-101C-4526-0087BE238B21}"/>
+                <a16:creationId xmlns:a16="http://schemas.microsoft.com/office/drawing/2014/main" id="{07B023E5-14E9-075C-BB9C-938E9048BFBB}"/>
               </a:ext>
             </a:extLst>
           </p:cNvPr>
@@ -176,7 +176,7 @@
           <p:cNvPr id="3" name="Subtitle 2">
             <a:extLst>
               <a:ext uri="{FF2B5EF4-FFF2-40B4-BE49-F238E27FC236}">
-                <a16:creationId xmlns:a16="http://schemas.microsoft.com/office/drawing/2014/main" id="{4BB97A93-5281-DCCA-3308-E9B396B5F5B7}"/>
+                <a16:creationId xmlns:a16="http://schemas.microsoft.com/office/drawing/2014/main" id="{D6FE90A3-047E-F498-09D3-FF27D2C9CD46}"/>
               </a:ext>
             </a:extLst>
           </p:cNvPr>
@@ -246,7 +246,7 @@
           <p:cNvPr id="4" name="Date Placeholder 3">
             <a:extLst>
               <a:ext uri="{FF2B5EF4-FFF2-40B4-BE49-F238E27FC236}">
-                <a16:creationId xmlns:a16="http://schemas.microsoft.com/office/drawing/2014/main" id="{736250F2-C827-D14F-BE74-7AA93D756D16}"/>
+                <a16:creationId xmlns:a16="http://schemas.microsoft.com/office/drawing/2014/main" id="{EF233487-3BAB-C48A-CB82-5472D7B04739}"/>
               </a:ext>
             </a:extLst>
           </p:cNvPr>
@@ -262,7 +262,7 @@
           <a:bodyPr/>
           <a:lstStyle/>
           <a:p>
-            <a:fld id="{EFC7B293-C39B-4341-97D8-8A5D589474B0}" type="datetimeFigureOut">
+            <a:fld id="{BD548FE3-2BC9-4C2E-A898-444148D39519}" type="datetimeFigureOut">
               <a:rPr lang="en-US" smtClean="0"/>
               <a:t>4/11/2026</a:t>
             </a:fld>
@@ -275,7 +275,7 @@
           <p:cNvPr id="5" name="Footer Placeholder 4">
             <a:extLst>
               <a:ext uri="{FF2B5EF4-FFF2-40B4-BE49-F238E27FC236}">
-                <a16:creationId xmlns:a16="http://schemas.microsoft.com/office/drawing/2014/main" id="{5645D2F1-5001-897A-5D55-9A0E47EB0A4D}"/>
+                <a16:creationId xmlns:a16="http://schemas.microsoft.com/office/drawing/2014/main" id="{1F701C24-B3D2-2A36-D8C4-A97918497FAA}"/>
               </a:ext>
             </a:extLst>
           </p:cNvPr>
@@ -300,7 +300,7 @@
           <p:cNvPr id="6" name="Slide Number Placeholder 5">
             <a:extLst>
               <a:ext uri="{FF2B5EF4-FFF2-40B4-BE49-F238E27FC236}">
-                <a16:creationId xmlns:a16="http://schemas.microsoft.com/office/drawing/2014/main" id="{A2131251-F85E-C0FC-936B-6F900FD1A849}"/>
+                <a16:creationId xmlns:a16="http://schemas.microsoft.com/office/drawing/2014/main" id="{BB26296B-E557-F894-524C-EAFA7374B742}"/>
               </a:ext>
             </a:extLst>
           </p:cNvPr>
@@ -316,7 +316,7 @@
           <a:bodyPr/>
           <a:lstStyle/>
           <a:p>
-            <a:fld id="{1E42A513-68A6-42F7-94CC-B181D5F7CFB8}" type="slidenum">
+            <a:fld id="{E99D46A9-7C22-4BEE-A79D-4FCC3D42940E}" type="slidenum">
               <a:rPr lang="en-US" smtClean="0"/>
               <a:t>‹#›</a:t>
             </a:fld>
@@ -327,7 +327,7 @@
     </p:spTree>
     <p:extLst>
       <p:ext uri="{BB962C8B-B14F-4D97-AF65-F5344CB8AC3E}">
-        <p14:creationId xmlns:p14="http://schemas.microsoft.com/office/powerpoint/2010/main" val="1499045366"/>
+        <p14:creationId xmlns:p14="http://schemas.microsoft.com/office/powerpoint/2010/main" val="1432057293"/>
       </p:ext>
     </p:extLst>
   </p:cSld>
@@ -359,7 +359,7 @@
           <p:cNvPr id="2" name="Title 1">
             <a:extLst>
               <a:ext uri="{FF2B5EF4-FFF2-40B4-BE49-F238E27FC236}">
-                <a16:creationId xmlns:a16="http://schemas.microsoft.com/office/drawing/2014/main" id="{32962257-06DC-A608-591B-66B392A5E371}"/>
+                <a16:creationId xmlns:a16="http://schemas.microsoft.com/office/drawing/2014/main" id="{798ED3FA-20EF-684E-C262-F9B698F023F2}"/>
               </a:ext>
             </a:extLst>
           </p:cNvPr>
@@ -387,7 +387,7 @@
           <p:cNvPr id="3" name="Vertical Text Placeholder 2">
             <a:extLst>
               <a:ext uri="{FF2B5EF4-FFF2-40B4-BE49-F238E27FC236}">
-                <a16:creationId xmlns:a16="http://schemas.microsoft.com/office/drawing/2014/main" id="{E679B511-6E9C-9964-A97A-A77CC8E63E8E}"/>
+                <a16:creationId xmlns:a16="http://schemas.microsoft.com/office/drawing/2014/main" id="{19F518FC-C90A-3816-72B8-07DB6ED1A0C8}"/>
               </a:ext>
             </a:extLst>
           </p:cNvPr>
@@ -444,7 +444,7 @@
           <p:cNvPr id="4" name="Date Placeholder 3">
             <a:extLst>
               <a:ext uri="{FF2B5EF4-FFF2-40B4-BE49-F238E27FC236}">
-                <a16:creationId xmlns:a16="http://schemas.microsoft.com/office/drawing/2014/main" id="{DEC771E3-D1BA-681B-7CBD-AE68327AB058}"/>
+                <a16:creationId xmlns:a16="http://schemas.microsoft.com/office/drawing/2014/main" id="{B63F6860-0302-4EEA-BFDB-45C0655F7EC8}"/>
               </a:ext>
             </a:extLst>
           </p:cNvPr>
@@ -460,7 +460,7 @@
           <a:bodyPr/>
           <a:lstStyle/>
           <a:p>
-            <a:fld id="{EFC7B293-C39B-4341-97D8-8A5D589474B0}" type="datetimeFigureOut">
+            <a:fld id="{BD548FE3-2BC9-4C2E-A898-444148D39519}" type="datetimeFigureOut">
               <a:rPr lang="en-US" smtClean="0"/>
               <a:t>4/11/2026</a:t>
             </a:fld>
@@ -473,7 +473,7 @@
           <p:cNvPr id="5" name="Footer Placeholder 4">
             <a:extLst>
               <a:ext uri="{FF2B5EF4-FFF2-40B4-BE49-F238E27FC236}">
-                <a16:creationId xmlns:a16="http://schemas.microsoft.com/office/drawing/2014/main" id="{BF3E26E0-3C9B-E5DF-2B05-EFA63C2DCCD7}"/>
+                <a16:creationId xmlns:a16="http://schemas.microsoft.com/office/drawing/2014/main" id="{D9874196-C9C4-01C3-A0D7-B9B042153AE8}"/>
               </a:ext>
             </a:extLst>
           </p:cNvPr>
@@ -498,7 +498,7 @@
           <p:cNvPr id="6" name="Slide Number Placeholder 5">
             <a:extLst>
               <a:ext uri="{FF2B5EF4-FFF2-40B4-BE49-F238E27FC236}">
-                <a16:creationId xmlns:a16="http://schemas.microsoft.com/office/drawing/2014/main" id="{DE1AFFD0-BF27-2C61-9927-7B4DD9769ECB}"/>
+                <a16:creationId xmlns:a16="http://schemas.microsoft.com/office/drawing/2014/main" id="{FF2D5FAC-1ABC-90FF-8662-A3E79E1BF80E}"/>
               </a:ext>
             </a:extLst>
           </p:cNvPr>
@@ -514,7 +514,7 @@
           <a:bodyPr/>
           <a:lstStyle/>
           <a:p>
-            <a:fld id="{1E42A513-68A6-42F7-94CC-B181D5F7CFB8}" type="slidenum">
+            <a:fld id="{E99D46A9-7C22-4BEE-A79D-4FCC3D42940E}" type="slidenum">
               <a:rPr lang="en-US" smtClean="0"/>
               <a:t>‹#›</a:t>
             </a:fld>
@@ -525,7 +525,7 @@
     </p:spTree>
     <p:extLst>
       <p:ext uri="{BB962C8B-B14F-4D97-AF65-F5344CB8AC3E}">
-        <p14:creationId xmlns:p14="http://schemas.microsoft.com/office/powerpoint/2010/main" val="2203331531"/>
+        <p14:creationId xmlns:p14="http://schemas.microsoft.com/office/powerpoint/2010/main" val="3415446000"/>
       </p:ext>
     </p:extLst>
   </p:cSld>
@@ -557,7 +557,7 @@
           <p:cNvPr id="2" name="Vertical Title 1">
             <a:extLst>
               <a:ext uri="{FF2B5EF4-FFF2-40B4-BE49-F238E27FC236}">
-                <a16:creationId xmlns:a16="http://schemas.microsoft.com/office/drawing/2014/main" id="{5E8021C5-864A-12EE-E81F-5F7DDB330696}"/>
+                <a16:creationId xmlns:a16="http://schemas.microsoft.com/office/drawing/2014/main" id="{599515CE-9359-0049-9BE6-ABF15DEFDF17}"/>
               </a:ext>
             </a:extLst>
           </p:cNvPr>
@@ -590,7 +590,7 @@
           <p:cNvPr id="3" name="Vertical Text Placeholder 2">
             <a:extLst>
               <a:ext uri="{FF2B5EF4-FFF2-40B4-BE49-F238E27FC236}">
-                <a16:creationId xmlns:a16="http://schemas.microsoft.com/office/drawing/2014/main" id="{4ABCA6F0-0723-4EFB-0447-CF1B14C78CFF}"/>
+                <a16:creationId xmlns:a16="http://schemas.microsoft.com/office/drawing/2014/main" id="{7F24640C-0325-A6A3-08B7-90FD88954E3C}"/>
               </a:ext>
             </a:extLst>
           </p:cNvPr>
@@ -652,7 +652,7 @@
           <p:cNvPr id="4" name="Date Placeholder 3">
             <a:extLst>
               <a:ext uri="{FF2B5EF4-FFF2-40B4-BE49-F238E27FC236}">
-                <a16:creationId xmlns:a16="http://schemas.microsoft.com/office/drawing/2014/main" id="{FB290688-8865-D1EC-9CB5-50F77ED04F24}"/>
+                <a16:creationId xmlns:a16="http://schemas.microsoft.com/office/drawing/2014/main" id="{1C286C95-982C-BB32-F2C1-3D2BA18DB490}"/>
               </a:ext>
             </a:extLst>
           </p:cNvPr>
@@ -668,7 +668,7 @@
           <a:bodyPr/>
           <a:lstStyle/>
           <a:p>
-            <a:fld id="{EFC7B293-C39B-4341-97D8-8A5D589474B0}" type="datetimeFigureOut">
+            <a:fld id="{BD548FE3-2BC9-4C2E-A898-444148D39519}" type="datetimeFigureOut">
               <a:rPr lang="en-US" smtClean="0"/>
               <a:t>4/11/2026</a:t>
             </a:fld>
@@ -681,7 +681,7 @@
           <p:cNvPr id="5" name="Footer Placeholder 4">
             <a:extLst>
               <a:ext uri="{FF2B5EF4-FFF2-40B4-BE49-F238E27FC236}">
-                <a16:creationId xmlns:a16="http://schemas.microsoft.com/office/drawing/2014/main" id="{5643F74B-151E-C155-C3A4-E8737ED517A8}"/>
+                <a16:creationId xmlns:a16="http://schemas.microsoft.com/office/drawing/2014/main" id="{3E583679-CC40-FB2C-0DDF-01469A3432B0}"/>
               </a:ext>
             </a:extLst>
           </p:cNvPr>
@@ -706,7 +706,7 @@
           <p:cNvPr id="6" name="Slide Number Placeholder 5">
             <a:extLst>
               <a:ext uri="{FF2B5EF4-FFF2-40B4-BE49-F238E27FC236}">
-                <a16:creationId xmlns:a16="http://schemas.microsoft.com/office/drawing/2014/main" id="{760C3574-F39A-0A0F-E429-FDA30F31C67F}"/>
+                <a16:creationId xmlns:a16="http://schemas.microsoft.com/office/drawing/2014/main" id="{98ADDF0A-2B35-A8E6-3600-186265C886C8}"/>
               </a:ext>
             </a:extLst>
           </p:cNvPr>
@@ -722,7 +722,7 @@
           <a:bodyPr/>
           <a:lstStyle/>
           <a:p>
-            <a:fld id="{1E42A513-68A6-42F7-94CC-B181D5F7CFB8}" type="slidenum">
+            <a:fld id="{E99D46A9-7C22-4BEE-A79D-4FCC3D42940E}" type="slidenum">
               <a:rPr lang="en-US" smtClean="0"/>
               <a:t>‹#›</a:t>
             </a:fld>
@@ -733,7 +733,7 @@
     </p:spTree>
     <p:extLst>
       <p:ext uri="{BB962C8B-B14F-4D97-AF65-F5344CB8AC3E}">
-        <p14:creationId xmlns:p14="http://schemas.microsoft.com/office/powerpoint/2010/main" val="1352993447"/>
+        <p14:creationId xmlns:p14="http://schemas.microsoft.com/office/powerpoint/2010/main" val="81774956"/>
       </p:ext>
     </p:extLst>
   </p:cSld>
@@ -765,7 +765,7 @@
           <p:cNvPr id="2" name="Title 1">
             <a:extLst>
               <a:ext uri="{FF2B5EF4-FFF2-40B4-BE49-F238E27FC236}">
-                <a16:creationId xmlns:a16="http://schemas.microsoft.com/office/drawing/2014/main" id="{E3300121-1170-349E-A7E6-A7E7682BA086}"/>
+                <a16:creationId xmlns:a16="http://schemas.microsoft.com/office/drawing/2014/main" id="{DD7CBB8E-0095-E203-4845-42DD7C3F395F}"/>
               </a:ext>
             </a:extLst>
           </p:cNvPr>
@@ -793,7 +793,7 @@
           <p:cNvPr id="3" name="Content Placeholder 2">
             <a:extLst>
               <a:ext uri="{FF2B5EF4-FFF2-40B4-BE49-F238E27FC236}">
-                <a16:creationId xmlns:a16="http://schemas.microsoft.com/office/drawing/2014/main" id="{C181E408-46A8-B8BD-E426-CCB7B1EEE1C9}"/>
+                <a16:creationId xmlns:a16="http://schemas.microsoft.com/office/drawing/2014/main" id="{802A9BA3-58BB-55E6-03E2-083DBD223A2A}"/>
               </a:ext>
             </a:extLst>
           </p:cNvPr>
@@ -850,7 +850,7 @@
           <p:cNvPr id="4" name="Date Placeholder 3">
             <a:extLst>
               <a:ext uri="{FF2B5EF4-FFF2-40B4-BE49-F238E27FC236}">
-                <a16:creationId xmlns:a16="http://schemas.microsoft.com/office/drawing/2014/main" id="{B09CBFD9-AD94-6760-6EBD-1A5A8034D863}"/>
+                <a16:creationId xmlns:a16="http://schemas.microsoft.com/office/drawing/2014/main" id="{F29258C8-BA66-9FA2-978C-BD96D42DA6FB}"/>
               </a:ext>
             </a:extLst>
           </p:cNvPr>
@@ -866,7 +866,7 @@
           <a:bodyPr/>
           <a:lstStyle/>
           <a:p>
-            <a:fld id="{EFC7B293-C39B-4341-97D8-8A5D589474B0}" type="datetimeFigureOut">
+            <a:fld id="{BD548FE3-2BC9-4C2E-A898-444148D39519}" type="datetimeFigureOut">
               <a:rPr lang="en-US" smtClean="0"/>
               <a:t>4/11/2026</a:t>
             </a:fld>
@@ -879,7 +879,7 @@
           <p:cNvPr id="5" name="Footer Placeholder 4">
             <a:extLst>
               <a:ext uri="{FF2B5EF4-FFF2-40B4-BE49-F238E27FC236}">
-                <a16:creationId xmlns:a16="http://schemas.microsoft.com/office/drawing/2014/main" id="{A87DFE6E-AD45-0AD2-7C00-7E1A7A81539D}"/>
+                <a16:creationId xmlns:a16="http://schemas.microsoft.com/office/drawing/2014/main" id="{E6957A5B-EA11-D004-1312-5EF76D6FB7D2}"/>
               </a:ext>
             </a:extLst>
           </p:cNvPr>
@@ -904,7 +904,7 @@
           <p:cNvPr id="6" name="Slide Number Placeholder 5">
             <a:extLst>
               <a:ext uri="{FF2B5EF4-FFF2-40B4-BE49-F238E27FC236}">
-                <a16:creationId xmlns:a16="http://schemas.microsoft.com/office/drawing/2014/main" id="{44E35E1E-3593-722C-EECB-78F5E8EA6ABB}"/>
+                <a16:creationId xmlns:a16="http://schemas.microsoft.com/office/drawing/2014/main" id="{B3F5546B-087C-9253-D555-1381A081168A}"/>
               </a:ext>
             </a:extLst>
           </p:cNvPr>
@@ -920,7 +920,7 @@
           <a:bodyPr/>
           <a:lstStyle/>
           <a:p>
-            <a:fld id="{1E42A513-68A6-42F7-94CC-B181D5F7CFB8}" type="slidenum">
+            <a:fld id="{E99D46A9-7C22-4BEE-A79D-4FCC3D42940E}" type="slidenum">
               <a:rPr lang="en-US" smtClean="0"/>
               <a:t>‹#›</a:t>
             </a:fld>
@@ -931,7 +931,7 @@
     </p:spTree>
     <p:extLst>
       <p:ext uri="{BB962C8B-B14F-4D97-AF65-F5344CB8AC3E}">
-        <p14:creationId xmlns:p14="http://schemas.microsoft.com/office/powerpoint/2010/main" val="2557513472"/>
+        <p14:creationId xmlns:p14="http://schemas.microsoft.com/office/powerpoint/2010/main" val="163427301"/>
       </p:ext>
     </p:extLst>
   </p:cSld>
@@ -963,7 +963,7 @@
           <p:cNvPr id="2" name="Title 1">
             <a:extLst>
               <a:ext uri="{FF2B5EF4-FFF2-40B4-BE49-F238E27FC236}">
-                <a16:creationId xmlns:a16="http://schemas.microsoft.com/office/drawing/2014/main" id="{4C13461E-C2A2-47FC-E405-40209D52BDF4}"/>
+                <a16:creationId xmlns:a16="http://schemas.microsoft.com/office/drawing/2014/main" id="{A9B9DBE7-211B-E7CE-3836-1EF7FAC71CC2}"/>
               </a:ext>
             </a:extLst>
           </p:cNvPr>
@@ -1000,7 +1000,7 @@
           <p:cNvPr id="3" name="Text Placeholder 2">
             <a:extLst>
               <a:ext uri="{FF2B5EF4-FFF2-40B4-BE49-F238E27FC236}">
-                <a16:creationId xmlns:a16="http://schemas.microsoft.com/office/drawing/2014/main" id="{224A3973-ECC4-7C82-19F8-3F378618540D}"/>
+                <a16:creationId xmlns:a16="http://schemas.microsoft.com/office/drawing/2014/main" id="{7E3B714C-34A0-A9D4-EA75-5AD81DD887F8}"/>
               </a:ext>
             </a:extLst>
           </p:cNvPr>
@@ -1125,7 +1125,7 @@
           <p:cNvPr id="4" name="Date Placeholder 3">
             <a:extLst>
               <a:ext uri="{FF2B5EF4-FFF2-40B4-BE49-F238E27FC236}">
-                <a16:creationId xmlns:a16="http://schemas.microsoft.com/office/drawing/2014/main" id="{951E0EB2-7666-CB02-E8DF-D753B206F767}"/>
+                <a16:creationId xmlns:a16="http://schemas.microsoft.com/office/drawing/2014/main" id="{67AB125B-ED49-EE90-CC5B-6B65B7FE9CFA}"/>
               </a:ext>
             </a:extLst>
           </p:cNvPr>
@@ -1141,7 +1141,7 @@
           <a:bodyPr/>
           <a:lstStyle/>
           <a:p>
-            <a:fld id="{EFC7B293-C39B-4341-97D8-8A5D589474B0}" type="datetimeFigureOut">
+            <a:fld id="{BD548FE3-2BC9-4C2E-A898-444148D39519}" type="datetimeFigureOut">
               <a:rPr lang="en-US" smtClean="0"/>
               <a:t>4/11/2026</a:t>
             </a:fld>
@@ -1154,7 +1154,7 @@
           <p:cNvPr id="5" name="Footer Placeholder 4">
             <a:extLst>
               <a:ext uri="{FF2B5EF4-FFF2-40B4-BE49-F238E27FC236}">
-                <a16:creationId xmlns:a16="http://schemas.microsoft.com/office/drawing/2014/main" id="{C377353B-12E8-75C8-D506-52EAA31516BA}"/>
+                <a16:creationId xmlns:a16="http://schemas.microsoft.com/office/drawing/2014/main" id="{23987DF2-2174-8DAE-00CA-0B00DE84D0F6}"/>
               </a:ext>
             </a:extLst>
           </p:cNvPr>
@@ -1179,7 +1179,7 @@
           <p:cNvPr id="6" name="Slide Number Placeholder 5">
             <a:extLst>
               <a:ext uri="{FF2B5EF4-FFF2-40B4-BE49-F238E27FC236}">
-                <a16:creationId xmlns:a16="http://schemas.microsoft.com/office/drawing/2014/main" id="{9E74C5A0-EBBD-C3B5-71E1-1C104747C978}"/>
+                <a16:creationId xmlns:a16="http://schemas.microsoft.com/office/drawing/2014/main" id="{4977D564-E0B7-0CB5-E2F9-65B4C2B54633}"/>
               </a:ext>
             </a:extLst>
           </p:cNvPr>
@@ -1195,7 +1195,7 @@
           <a:bodyPr/>
           <a:lstStyle/>
           <a:p>
-            <a:fld id="{1E42A513-68A6-42F7-94CC-B181D5F7CFB8}" type="slidenum">
+            <a:fld id="{E99D46A9-7C22-4BEE-A79D-4FCC3D42940E}" type="slidenum">
               <a:rPr lang="en-US" smtClean="0"/>
               <a:t>‹#›</a:t>
             </a:fld>
@@ -1206,7 +1206,7 @@
     </p:spTree>
     <p:extLst>
       <p:ext uri="{BB962C8B-B14F-4D97-AF65-F5344CB8AC3E}">
-        <p14:creationId xmlns:p14="http://schemas.microsoft.com/office/powerpoint/2010/main" val="4143902439"/>
+        <p14:creationId xmlns:p14="http://schemas.microsoft.com/office/powerpoint/2010/main" val="3006449195"/>
       </p:ext>
     </p:extLst>
   </p:cSld>
@@ -1238,7 +1238,7 @@
           <p:cNvPr id="2" name="Title 1">
             <a:extLst>
               <a:ext uri="{FF2B5EF4-FFF2-40B4-BE49-F238E27FC236}">
-                <a16:creationId xmlns:a16="http://schemas.microsoft.com/office/drawing/2014/main" id="{0DA08D84-4E49-1637-3A04-E67B3CCF62B8}"/>
+                <a16:creationId xmlns:a16="http://schemas.microsoft.com/office/drawing/2014/main" id="{697A2A9F-8053-E601-35CE-224B08740010}"/>
               </a:ext>
             </a:extLst>
           </p:cNvPr>
@@ -1266,7 +1266,7 @@
           <p:cNvPr id="3" name="Content Placeholder 2">
             <a:extLst>
               <a:ext uri="{FF2B5EF4-FFF2-40B4-BE49-F238E27FC236}">
-                <a16:creationId xmlns:a16="http://schemas.microsoft.com/office/drawing/2014/main" id="{B52C1875-07EE-A050-FFE1-E4A4C4690F8A}"/>
+                <a16:creationId xmlns:a16="http://schemas.microsoft.com/office/drawing/2014/main" id="{5026BE8E-F5DC-DC9B-3211-1B20F8078C4D}"/>
               </a:ext>
             </a:extLst>
           </p:cNvPr>
@@ -1328,7 +1328,7 @@
           <p:cNvPr id="4" name="Content Placeholder 3">
             <a:extLst>
               <a:ext uri="{FF2B5EF4-FFF2-40B4-BE49-F238E27FC236}">
-                <a16:creationId xmlns:a16="http://schemas.microsoft.com/office/drawing/2014/main" id="{FF795A98-BD01-6CC6-F242-8A3ECA85ACD3}"/>
+                <a16:creationId xmlns:a16="http://schemas.microsoft.com/office/drawing/2014/main" id="{C4E0FFED-19EC-E8E2-C40F-F4CCEFE0CB03}"/>
               </a:ext>
             </a:extLst>
           </p:cNvPr>
@@ -1390,7 +1390,7 @@
           <p:cNvPr id="5" name="Date Placeholder 4">
             <a:extLst>
               <a:ext uri="{FF2B5EF4-FFF2-40B4-BE49-F238E27FC236}">
-                <a16:creationId xmlns:a16="http://schemas.microsoft.com/office/drawing/2014/main" id="{61DE5EF6-41D9-959A-10FD-612BD83F351F}"/>
+                <a16:creationId xmlns:a16="http://schemas.microsoft.com/office/drawing/2014/main" id="{3EBD31B7-35E3-C915-69DD-AEF18130B9CE}"/>
               </a:ext>
             </a:extLst>
           </p:cNvPr>
@@ -1406,7 +1406,7 @@
           <a:bodyPr/>
           <a:lstStyle/>
           <a:p>
-            <a:fld id="{EFC7B293-C39B-4341-97D8-8A5D589474B0}" type="datetimeFigureOut">
+            <a:fld id="{BD548FE3-2BC9-4C2E-A898-444148D39519}" type="datetimeFigureOut">
               <a:rPr lang="en-US" smtClean="0"/>
               <a:t>4/11/2026</a:t>
             </a:fld>
@@ -1419,7 +1419,7 @@
           <p:cNvPr id="6" name="Footer Placeholder 5">
             <a:extLst>
               <a:ext uri="{FF2B5EF4-FFF2-40B4-BE49-F238E27FC236}">
-                <a16:creationId xmlns:a16="http://schemas.microsoft.com/office/drawing/2014/main" id="{DAB01AA7-E5AB-912C-8E48-E5281BCCEAB8}"/>
+                <a16:creationId xmlns:a16="http://schemas.microsoft.com/office/drawing/2014/main" id="{7DB9A5D1-97D1-2A65-C487-0D2697366C16}"/>
               </a:ext>
             </a:extLst>
           </p:cNvPr>
@@ -1444,7 +1444,7 @@
           <p:cNvPr id="7" name="Slide Number Placeholder 6">
             <a:extLst>
               <a:ext uri="{FF2B5EF4-FFF2-40B4-BE49-F238E27FC236}">
-                <a16:creationId xmlns:a16="http://schemas.microsoft.com/office/drawing/2014/main" id="{1A04BB1B-E86A-DA32-2EE5-ED08712B5CFD}"/>
+                <a16:creationId xmlns:a16="http://schemas.microsoft.com/office/drawing/2014/main" id="{346DFA8A-42F6-F5F0-B887-DEEB9413EC71}"/>
               </a:ext>
             </a:extLst>
           </p:cNvPr>
@@ -1460,7 +1460,7 @@
           <a:bodyPr/>
           <a:lstStyle/>
           <a:p>
-            <a:fld id="{1E42A513-68A6-42F7-94CC-B181D5F7CFB8}" type="slidenum">
+            <a:fld id="{E99D46A9-7C22-4BEE-A79D-4FCC3D42940E}" type="slidenum">
               <a:rPr lang="en-US" smtClean="0"/>
               <a:t>‹#›</a:t>
             </a:fld>
@@ -1471,7 +1471,7 @@
     </p:spTree>
     <p:extLst>
       <p:ext uri="{BB962C8B-B14F-4D97-AF65-F5344CB8AC3E}">
-        <p14:creationId xmlns:p14="http://schemas.microsoft.com/office/powerpoint/2010/main" val="305011567"/>
+        <p14:creationId xmlns:p14="http://schemas.microsoft.com/office/powerpoint/2010/main" val="726826693"/>
       </p:ext>
     </p:extLst>
   </p:cSld>
@@ -1503,7 +1503,7 @@
           <p:cNvPr id="2" name="Title 1">
             <a:extLst>
               <a:ext uri="{FF2B5EF4-FFF2-40B4-BE49-F238E27FC236}">
-                <a16:creationId xmlns:a16="http://schemas.microsoft.com/office/drawing/2014/main" id="{59D8796A-3A90-6194-C5E7-DBEAFBE583A8}"/>
+                <a16:creationId xmlns:a16="http://schemas.microsoft.com/office/drawing/2014/main" id="{53D4D3D7-C679-DC87-A8F9-1FDB1C8B2449}"/>
               </a:ext>
             </a:extLst>
           </p:cNvPr>
@@ -1536,7 +1536,7 @@
           <p:cNvPr id="3" name="Text Placeholder 2">
             <a:extLst>
               <a:ext uri="{FF2B5EF4-FFF2-40B4-BE49-F238E27FC236}">
-                <a16:creationId xmlns:a16="http://schemas.microsoft.com/office/drawing/2014/main" id="{AA209B99-A3E1-51BA-F792-2618108BF0A3}"/>
+                <a16:creationId xmlns:a16="http://schemas.microsoft.com/office/drawing/2014/main" id="{451889EF-89D0-C3AF-AA07-F8C828CC9C9E}"/>
               </a:ext>
             </a:extLst>
           </p:cNvPr>
@@ -1607,7 +1607,7 @@
           <p:cNvPr id="4" name="Content Placeholder 3">
             <a:extLst>
               <a:ext uri="{FF2B5EF4-FFF2-40B4-BE49-F238E27FC236}">
-                <a16:creationId xmlns:a16="http://schemas.microsoft.com/office/drawing/2014/main" id="{DCB3E1F2-FC7C-876E-4082-E608A3427066}"/>
+                <a16:creationId xmlns:a16="http://schemas.microsoft.com/office/drawing/2014/main" id="{8BFA7DAC-DF6E-29CB-79D2-89C6457F47C9}"/>
               </a:ext>
             </a:extLst>
           </p:cNvPr>
@@ -1669,7 +1669,7 @@
           <p:cNvPr id="5" name="Text Placeholder 4">
             <a:extLst>
               <a:ext uri="{FF2B5EF4-FFF2-40B4-BE49-F238E27FC236}">
-                <a16:creationId xmlns:a16="http://schemas.microsoft.com/office/drawing/2014/main" id="{A840A954-B3D2-0D69-7A87-4589C93835D3}"/>
+                <a16:creationId xmlns:a16="http://schemas.microsoft.com/office/drawing/2014/main" id="{E9D6574F-8FF2-D894-9765-ECEF9BAA9354}"/>
               </a:ext>
             </a:extLst>
           </p:cNvPr>
@@ -1740,7 +1740,7 @@
           <p:cNvPr id="6" name="Content Placeholder 5">
             <a:extLst>
               <a:ext uri="{FF2B5EF4-FFF2-40B4-BE49-F238E27FC236}">
-                <a16:creationId xmlns:a16="http://schemas.microsoft.com/office/drawing/2014/main" id="{60C643D7-641B-5D83-83D5-D5E800B064B3}"/>
+                <a16:creationId xmlns:a16="http://schemas.microsoft.com/office/drawing/2014/main" id="{5A2B3CB7-6EAF-632C-BCD8-B69FBB59FEF0}"/>
               </a:ext>
             </a:extLst>
           </p:cNvPr>
@@ -1802,7 +1802,7 @@
           <p:cNvPr id="7" name="Date Placeholder 6">
             <a:extLst>
               <a:ext uri="{FF2B5EF4-FFF2-40B4-BE49-F238E27FC236}">
-                <a16:creationId xmlns:a16="http://schemas.microsoft.com/office/drawing/2014/main" id="{38938BFC-1D0F-A32A-5988-7DCD9019634E}"/>
+                <a16:creationId xmlns:a16="http://schemas.microsoft.com/office/drawing/2014/main" id="{85FA67BB-5202-C44A-260F-F15ADB92AA57}"/>
               </a:ext>
             </a:extLst>
           </p:cNvPr>
@@ -1818,7 +1818,7 @@
           <a:bodyPr/>
           <a:lstStyle/>
           <a:p>
-            <a:fld id="{EFC7B293-C39B-4341-97D8-8A5D589474B0}" type="datetimeFigureOut">
+            <a:fld id="{BD548FE3-2BC9-4C2E-A898-444148D39519}" type="datetimeFigureOut">
               <a:rPr lang="en-US" smtClean="0"/>
               <a:t>4/11/2026</a:t>
             </a:fld>
@@ -1831,7 +1831,7 @@
           <p:cNvPr id="8" name="Footer Placeholder 7">
             <a:extLst>
               <a:ext uri="{FF2B5EF4-FFF2-40B4-BE49-F238E27FC236}">
-                <a16:creationId xmlns:a16="http://schemas.microsoft.com/office/drawing/2014/main" id="{C63177B4-DB06-4823-B350-D8C29306F4B6}"/>
+                <a16:creationId xmlns:a16="http://schemas.microsoft.com/office/drawing/2014/main" id="{6995F75E-8159-DFF9-4B61-3381BDC28C4E}"/>
               </a:ext>
             </a:extLst>
           </p:cNvPr>
@@ -1856,7 +1856,7 @@
           <p:cNvPr id="9" name="Slide Number Placeholder 8">
             <a:extLst>
               <a:ext uri="{FF2B5EF4-FFF2-40B4-BE49-F238E27FC236}">
-                <a16:creationId xmlns:a16="http://schemas.microsoft.com/office/drawing/2014/main" id="{AD6B9A2F-27FF-89EB-DC43-CA20A931F6A1}"/>
+                <a16:creationId xmlns:a16="http://schemas.microsoft.com/office/drawing/2014/main" id="{60F34C50-4FCA-B540-7F0F-808ECA0101B1}"/>
               </a:ext>
             </a:extLst>
           </p:cNvPr>
@@ -1872,7 +1872,7 @@
           <a:bodyPr/>
           <a:lstStyle/>
           <a:p>
-            <a:fld id="{1E42A513-68A6-42F7-94CC-B181D5F7CFB8}" type="slidenum">
+            <a:fld id="{E99D46A9-7C22-4BEE-A79D-4FCC3D42940E}" type="slidenum">
               <a:rPr lang="en-US" smtClean="0"/>
               <a:t>‹#›</a:t>
             </a:fld>
@@ -1883,7 +1883,7 @@
     </p:spTree>
     <p:extLst>
       <p:ext uri="{BB962C8B-B14F-4D97-AF65-F5344CB8AC3E}">
-        <p14:creationId xmlns:p14="http://schemas.microsoft.com/office/powerpoint/2010/main" val="785872257"/>
+        <p14:creationId xmlns:p14="http://schemas.microsoft.com/office/powerpoint/2010/main" val="1621899383"/>
       </p:ext>
     </p:extLst>
   </p:cSld>
@@ -1915,7 +1915,7 @@
           <p:cNvPr id="2" name="Title 1">
             <a:extLst>
               <a:ext uri="{FF2B5EF4-FFF2-40B4-BE49-F238E27FC236}">
-                <a16:creationId xmlns:a16="http://schemas.microsoft.com/office/drawing/2014/main" id="{7B734E6C-3453-8960-95C9-B0505EC4C108}"/>
+                <a16:creationId xmlns:a16="http://schemas.microsoft.com/office/drawing/2014/main" id="{E1231575-16BF-6E49-75B7-24BFDBF4187E}"/>
               </a:ext>
             </a:extLst>
           </p:cNvPr>
@@ -1943,7 +1943,7 @@
           <p:cNvPr id="3" name="Date Placeholder 2">
             <a:extLst>
               <a:ext uri="{FF2B5EF4-FFF2-40B4-BE49-F238E27FC236}">
-                <a16:creationId xmlns:a16="http://schemas.microsoft.com/office/drawing/2014/main" id="{D47B2AC6-D81A-16E3-3AB5-3B14F1C131AF}"/>
+                <a16:creationId xmlns:a16="http://schemas.microsoft.com/office/drawing/2014/main" id="{E4F0884B-772B-A1AD-683C-24C5016E2B7E}"/>
               </a:ext>
             </a:extLst>
           </p:cNvPr>
@@ -1959,7 +1959,7 @@
           <a:bodyPr/>
           <a:lstStyle/>
           <a:p>
-            <a:fld id="{EFC7B293-C39B-4341-97D8-8A5D589474B0}" type="datetimeFigureOut">
+            <a:fld id="{BD548FE3-2BC9-4C2E-A898-444148D39519}" type="datetimeFigureOut">
               <a:rPr lang="en-US" smtClean="0"/>
               <a:t>4/11/2026</a:t>
             </a:fld>
@@ -1972,7 +1972,7 @@
           <p:cNvPr id="4" name="Footer Placeholder 3">
             <a:extLst>
               <a:ext uri="{FF2B5EF4-FFF2-40B4-BE49-F238E27FC236}">
-                <a16:creationId xmlns:a16="http://schemas.microsoft.com/office/drawing/2014/main" id="{B7DD85EC-27D8-F58A-96B1-6817C3555EAA}"/>
+                <a16:creationId xmlns:a16="http://schemas.microsoft.com/office/drawing/2014/main" id="{EBA76BE8-C50E-09D6-2933-BB0AA4A854D1}"/>
               </a:ext>
             </a:extLst>
           </p:cNvPr>
@@ -1997,7 +1997,7 @@
           <p:cNvPr id="5" name="Slide Number Placeholder 4">
             <a:extLst>
               <a:ext uri="{FF2B5EF4-FFF2-40B4-BE49-F238E27FC236}">
-                <a16:creationId xmlns:a16="http://schemas.microsoft.com/office/drawing/2014/main" id="{66AF8BDD-BAF5-36D9-D231-89ED42CA2D4F}"/>
+                <a16:creationId xmlns:a16="http://schemas.microsoft.com/office/drawing/2014/main" id="{91866410-3B73-7D25-5E0C-654E3091880F}"/>
               </a:ext>
             </a:extLst>
           </p:cNvPr>
@@ -2013,7 +2013,7 @@
           <a:bodyPr/>
           <a:lstStyle/>
           <a:p>
-            <a:fld id="{1E42A513-68A6-42F7-94CC-B181D5F7CFB8}" type="slidenum">
+            <a:fld id="{E99D46A9-7C22-4BEE-A79D-4FCC3D42940E}" type="slidenum">
               <a:rPr lang="en-US" smtClean="0"/>
               <a:t>‹#›</a:t>
             </a:fld>
@@ -2024,7 +2024,7 @@
     </p:spTree>
     <p:extLst>
       <p:ext uri="{BB962C8B-B14F-4D97-AF65-F5344CB8AC3E}">
-        <p14:creationId xmlns:p14="http://schemas.microsoft.com/office/powerpoint/2010/main" val="1720431638"/>
+        <p14:creationId xmlns:p14="http://schemas.microsoft.com/office/powerpoint/2010/main" val="4266922832"/>
       </p:ext>
     </p:extLst>
   </p:cSld>
@@ -2056,7 +2056,7 @@
           <p:cNvPr id="2" name="Date Placeholder 1">
             <a:extLst>
               <a:ext uri="{FF2B5EF4-FFF2-40B4-BE49-F238E27FC236}">
-                <a16:creationId xmlns:a16="http://schemas.microsoft.com/office/drawing/2014/main" id="{ADC5EB96-24FA-2819-D9D8-978B66D24A28}"/>
+                <a16:creationId xmlns:a16="http://schemas.microsoft.com/office/drawing/2014/main" id="{42B7C8A5-3685-6929-EC5D-5E1438077CC8}"/>
               </a:ext>
             </a:extLst>
           </p:cNvPr>
@@ -2072,7 +2072,7 @@
           <a:bodyPr/>
           <a:lstStyle/>
           <a:p>
-            <a:fld id="{EFC7B293-C39B-4341-97D8-8A5D589474B0}" type="datetimeFigureOut">
+            <a:fld id="{BD548FE3-2BC9-4C2E-A898-444148D39519}" type="datetimeFigureOut">
               <a:rPr lang="en-US" smtClean="0"/>
               <a:t>4/11/2026</a:t>
             </a:fld>
@@ -2085,7 +2085,7 @@
           <p:cNvPr id="3" name="Footer Placeholder 2">
             <a:extLst>
               <a:ext uri="{FF2B5EF4-FFF2-40B4-BE49-F238E27FC236}">
-                <a16:creationId xmlns:a16="http://schemas.microsoft.com/office/drawing/2014/main" id="{A82DF6A0-6A06-08DE-46E0-37072CE6B8E0}"/>
+                <a16:creationId xmlns:a16="http://schemas.microsoft.com/office/drawing/2014/main" id="{20E8D5D6-67CB-0665-FA33-D4E60FB1C1C9}"/>
               </a:ext>
             </a:extLst>
           </p:cNvPr>
@@ -2110,7 +2110,7 @@
           <p:cNvPr id="4" name="Slide Number Placeholder 3">
             <a:extLst>
               <a:ext uri="{FF2B5EF4-FFF2-40B4-BE49-F238E27FC236}">
-                <a16:creationId xmlns:a16="http://schemas.microsoft.com/office/drawing/2014/main" id="{2F448D67-1696-EF86-C59E-E6CC4430551C}"/>
+                <a16:creationId xmlns:a16="http://schemas.microsoft.com/office/drawing/2014/main" id="{FFB5F7A1-5398-5F5F-B093-08E58A98ECEB}"/>
               </a:ext>
             </a:extLst>
           </p:cNvPr>
@@ -2126,7 +2126,7 @@
           <a:bodyPr/>
           <a:lstStyle/>
           <a:p>
-            <a:fld id="{1E42A513-68A6-42F7-94CC-B181D5F7CFB8}" type="slidenum">
+            <a:fld id="{E99D46A9-7C22-4BEE-A79D-4FCC3D42940E}" type="slidenum">
               <a:rPr lang="en-US" smtClean="0"/>
               <a:t>‹#›</a:t>
             </a:fld>
@@ -2137,7 +2137,7 @@
     </p:spTree>
     <p:extLst>
       <p:ext uri="{BB962C8B-B14F-4D97-AF65-F5344CB8AC3E}">
-        <p14:creationId xmlns:p14="http://schemas.microsoft.com/office/powerpoint/2010/main" val="3410793900"/>
+        <p14:creationId xmlns:p14="http://schemas.microsoft.com/office/powerpoint/2010/main" val="681617123"/>
       </p:ext>
     </p:extLst>
   </p:cSld>
@@ -2169,7 +2169,7 @@
           <p:cNvPr id="2" name="Title 1">
             <a:extLst>
               <a:ext uri="{FF2B5EF4-FFF2-40B4-BE49-F238E27FC236}">
-                <a16:creationId xmlns:a16="http://schemas.microsoft.com/office/drawing/2014/main" id="{26D1EF70-F521-B823-E51E-ADD771F0C0B1}"/>
+                <a16:creationId xmlns:a16="http://schemas.microsoft.com/office/drawing/2014/main" id="{645DBAC0-3064-D82D-6D2D-E97C8C3876EE}"/>
               </a:ext>
             </a:extLst>
           </p:cNvPr>
@@ -2206,7 +2206,7 @@
           <p:cNvPr id="3" name="Content Placeholder 2">
             <a:extLst>
               <a:ext uri="{FF2B5EF4-FFF2-40B4-BE49-F238E27FC236}">
-                <a16:creationId xmlns:a16="http://schemas.microsoft.com/office/drawing/2014/main" id="{0FFD40D8-A5DF-785D-05F9-CE5FBD8DDA95}"/>
+                <a16:creationId xmlns:a16="http://schemas.microsoft.com/office/drawing/2014/main" id="{0E6A69F6-BF3D-A00B-1D16-F0CC896DA807}"/>
               </a:ext>
             </a:extLst>
           </p:cNvPr>
@@ -2296,7 +2296,7 @@
           <p:cNvPr id="4" name="Text Placeholder 3">
             <a:extLst>
               <a:ext uri="{FF2B5EF4-FFF2-40B4-BE49-F238E27FC236}">
-                <a16:creationId xmlns:a16="http://schemas.microsoft.com/office/drawing/2014/main" id="{E963F68A-7D48-9569-D6E6-D102D7B40987}"/>
+                <a16:creationId xmlns:a16="http://schemas.microsoft.com/office/drawing/2014/main" id="{D0114895-C91F-7959-C4D2-2BD73AD80054}"/>
               </a:ext>
             </a:extLst>
           </p:cNvPr>
@@ -2367,7 +2367,7 @@
           <p:cNvPr id="5" name="Date Placeholder 4">
             <a:extLst>
               <a:ext uri="{FF2B5EF4-FFF2-40B4-BE49-F238E27FC236}">
-                <a16:creationId xmlns:a16="http://schemas.microsoft.com/office/drawing/2014/main" id="{85EF194D-7F6C-AAD5-9424-BC0FD8CEA343}"/>
+                <a16:creationId xmlns:a16="http://schemas.microsoft.com/office/drawing/2014/main" id="{7F85FAC4-109F-2040-851B-5FEAA09BB04E}"/>
               </a:ext>
             </a:extLst>
           </p:cNvPr>
@@ -2383,7 +2383,7 @@
           <a:bodyPr/>
           <a:lstStyle/>
           <a:p>
-            <a:fld id="{EFC7B293-C39B-4341-97D8-8A5D589474B0}" type="datetimeFigureOut">
+            <a:fld id="{BD548FE3-2BC9-4C2E-A898-444148D39519}" type="datetimeFigureOut">
               <a:rPr lang="en-US" smtClean="0"/>
               <a:t>4/11/2026</a:t>
             </a:fld>
@@ -2396,7 +2396,7 @@
           <p:cNvPr id="6" name="Footer Placeholder 5">
             <a:extLst>
               <a:ext uri="{FF2B5EF4-FFF2-40B4-BE49-F238E27FC236}">
-                <a16:creationId xmlns:a16="http://schemas.microsoft.com/office/drawing/2014/main" id="{C6C90EE8-A6D7-F920-B3EB-86A3DE5B05A2}"/>
+                <a16:creationId xmlns:a16="http://schemas.microsoft.com/office/drawing/2014/main" id="{E7E03243-DDBA-8999-C6A6-3ECBED96FC98}"/>
               </a:ext>
             </a:extLst>
           </p:cNvPr>
@@ -2421,7 +2421,7 @@
           <p:cNvPr id="7" name="Slide Number Placeholder 6">
             <a:extLst>
               <a:ext uri="{FF2B5EF4-FFF2-40B4-BE49-F238E27FC236}">
-                <a16:creationId xmlns:a16="http://schemas.microsoft.com/office/drawing/2014/main" id="{6DA53E23-DD7C-E43C-6119-816C30EAFE26}"/>
+                <a16:creationId xmlns:a16="http://schemas.microsoft.com/office/drawing/2014/main" id="{6161667B-F21B-F061-4A9E-3A0197496F1D}"/>
               </a:ext>
             </a:extLst>
           </p:cNvPr>
@@ -2437,7 +2437,7 @@
           <a:bodyPr/>
           <a:lstStyle/>
           <a:p>
-            <a:fld id="{1E42A513-68A6-42F7-94CC-B181D5F7CFB8}" type="slidenum">
+            <a:fld id="{E99D46A9-7C22-4BEE-A79D-4FCC3D42940E}" type="slidenum">
               <a:rPr lang="en-US" smtClean="0"/>
               <a:t>‹#›</a:t>
             </a:fld>
@@ -2448,7 +2448,7 @@
     </p:spTree>
     <p:extLst>
       <p:ext uri="{BB962C8B-B14F-4D97-AF65-F5344CB8AC3E}">
-        <p14:creationId xmlns:p14="http://schemas.microsoft.com/office/powerpoint/2010/main" val="2126612357"/>
+        <p14:creationId xmlns:p14="http://schemas.microsoft.com/office/powerpoint/2010/main" val="1010843961"/>
       </p:ext>
     </p:extLst>
   </p:cSld>
@@ -2480,7 +2480,7 @@
           <p:cNvPr id="2" name="Title 1">
             <a:extLst>
               <a:ext uri="{FF2B5EF4-FFF2-40B4-BE49-F238E27FC236}">
-                <a16:creationId xmlns:a16="http://schemas.microsoft.com/office/drawing/2014/main" id="{489103C6-3A31-FF88-968B-0642858CEF4B}"/>
+                <a16:creationId xmlns:a16="http://schemas.microsoft.com/office/drawing/2014/main" id="{37170260-17B1-BF0B-3458-27B98BF15C2C}"/>
               </a:ext>
             </a:extLst>
           </p:cNvPr>
@@ -2517,7 +2517,7 @@
           <p:cNvPr id="3" name="Picture Placeholder 2">
             <a:extLst>
               <a:ext uri="{FF2B5EF4-FFF2-40B4-BE49-F238E27FC236}">
-                <a16:creationId xmlns:a16="http://schemas.microsoft.com/office/drawing/2014/main" id="{4C93C130-2A6B-BD35-96C4-3FA7F0CC62AC}"/>
+                <a16:creationId xmlns:a16="http://schemas.microsoft.com/office/drawing/2014/main" id="{A4F8C5DA-0FD0-73B4-E6FA-34F56784C723}"/>
               </a:ext>
             </a:extLst>
           </p:cNvPr>
@@ -2584,7 +2584,7 @@
           <p:cNvPr id="4" name="Text Placeholder 3">
             <a:extLst>
               <a:ext uri="{FF2B5EF4-FFF2-40B4-BE49-F238E27FC236}">
-                <a16:creationId xmlns:a16="http://schemas.microsoft.com/office/drawing/2014/main" id="{2D1F6DF4-CC4A-B7B7-3BE7-393DE4421B42}"/>
+                <a16:creationId xmlns:a16="http://schemas.microsoft.com/office/drawing/2014/main" id="{08CC9523-C1F8-6402-C8A2-FE11F949269D}"/>
               </a:ext>
             </a:extLst>
           </p:cNvPr>
@@ -2655,7 +2655,7 @@
           <p:cNvPr id="5" name="Date Placeholder 4">
             <a:extLst>
               <a:ext uri="{FF2B5EF4-FFF2-40B4-BE49-F238E27FC236}">
-                <a16:creationId xmlns:a16="http://schemas.microsoft.com/office/drawing/2014/main" id="{0A27004A-CE81-477C-2B29-3291CFAF4379}"/>
+                <a16:creationId xmlns:a16="http://schemas.microsoft.com/office/drawing/2014/main" id="{9FE6DD65-7523-2F73-0FE8-D0863A4E7F2F}"/>
               </a:ext>
             </a:extLst>
           </p:cNvPr>
@@ -2671,7 +2671,7 @@
           <a:bodyPr/>
           <a:lstStyle/>
           <a:p>
-            <a:fld id="{EFC7B293-C39B-4341-97D8-8A5D589474B0}" type="datetimeFigureOut">
+            <a:fld id="{BD548FE3-2BC9-4C2E-A898-444148D39519}" type="datetimeFigureOut">
               <a:rPr lang="en-US" smtClean="0"/>
               <a:t>4/11/2026</a:t>
             </a:fld>
@@ -2684,7 +2684,7 @@
           <p:cNvPr id="6" name="Footer Placeholder 5">
             <a:extLst>
               <a:ext uri="{FF2B5EF4-FFF2-40B4-BE49-F238E27FC236}">
-                <a16:creationId xmlns:a16="http://schemas.microsoft.com/office/drawing/2014/main" id="{BE8B3C0B-0CDC-6447-73AD-2495AF2FB3F9}"/>
+                <a16:creationId xmlns:a16="http://schemas.microsoft.com/office/drawing/2014/main" id="{A1F4195C-E241-DA61-BA3D-45EF0F90959B}"/>
               </a:ext>
             </a:extLst>
           </p:cNvPr>
@@ -2709,7 +2709,7 @@
           <p:cNvPr id="7" name="Slide Number Placeholder 6">
             <a:extLst>
               <a:ext uri="{FF2B5EF4-FFF2-40B4-BE49-F238E27FC236}">
-                <a16:creationId xmlns:a16="http://schemas.microsoft.com/office/drawing/2014/main" id="{68A7CBDB-38F4-50CA-2C27-7252820C7211}"/>
+                <a16:creationId xmlns:a16="http://schemas.microsoft.com/office/drawing/2014/main" id="{F7E5C535-ED96-02CE-7303-ACE235EE0FE7}"/>
               </a:ext>
             </a:extLst>
           </p:cNvPr>
@@ -2725,7 +2725,7 @@
           <a:bodyPr/>
           <a:lstStyle/>
           <a:p>
-            <a:fld id="{1E42A513-68A6-42F7-94CC-B181D5F7CFB8}" type="slidenum">
+            <a:fld id="{E99D46A9-7C22-4BEE-A79D-4FCC3D42940E}" type="slidenum">
               <a:rPr lang="en-US" smtClean="0"/>
               <a:t>‹#›</a:t>
             </a:fld>
@@ -2736,7 +2736,7 @@
     </p:spTree>
     <p:extLst>
       <p:ext uri="{BB962C8B-B14F-4D97-AF65-F5344CB8AC3E}">
-        <p14:creationId xmlns:p14="http://schemas.microsoft.com/office/powerpoint/2010/main" val="3350915204"/>
+        <p14:creationId xmlns:p14="http://schemas.microsoft.com/office/powerpoint/2010/main" val="1256362347"/>
       </p:ext>
     </p:extLst>
   </p:cSld>
@@ -2773,7 +2773,7 @@
           <p:cNvPr id="2" name="Title Placeholder 1">
             <a:extLst>
               <a:ext uri="{FF2B5EF4-FFF2-40B4-BE49-F238E27FC236}">
-                <a16:creationId xmlns:a16="http://schemas.microsoft.com/office/drawing/2014/main" id="{0DE83F64-15DE-C502-0202-02CD280E1EE6}"/>
+                <a16:creationId xmlns:a16="http://schemas.microsoft.com/office/drawing/2014/main" id="{0C65D277-F19D-C168-F8BE-F9CAC281A348}"/>
               </a:ext>
             </a:extLst>
           </p:cNvPr>
@@ -2811,7 +2811,7 @@
           <p:cNvPr id="3" name="Text Placeholder 2">
             <a:extLst>
               <a:ext uri="{FF2B5EF4-FFF2-40B4-BE49-F238E27FC236}">
-                <a16:creationId xmlns:a16="http://schemas.microsoft.com/office/drawing/2014/main" id="{D0EEAB74-A744-42E0-2970-E646CC9DB508}"/>
+                <a16:creationId xmlns:a16="http://schemas.microsoft.com/office/drawing/2014/main" id="{5A12DFD5-E792-CDB8-296D-5AF7C26F7FDE}"/>
               </a:ext>
             </a:extLst>
           </p:cNvPr>
@@ -2878,7 +2878,7 @@
           <p:cNvPr id="4" name="Date Placeholder 3">
             <a:extLst>
               <a:ext uri="{FF2B5EF4-FFF2-40B4-BE49-F238E27FC236}">
-                <a16:creationId xmlns:a16="http://schemas.microsoft.com/office/drawing/2014/main" id="{1D9F8FDD-ADE4-A755-2FA1-79CB129693DA}"/>
+                <a16:creationId xmlns:a16="http://schemas.microsoft.com/office/drawing/2014/main" id="{CE3FFD96-216A-EC1E-94E1-36A2693B04CC}"/>
               </a:ext>
             </a:extLst>
           </p:cNvPr>
@@ -2912,7 +2912,7 @@
             </a:lvl1pPr>
           </a:lstStyle>
           <a:p>
-            <a:fld id="{EFC7B293-C39B-4341-97D8-8A5D589474B0}" type="datetimeFigureOut">
+            <a:fld id="{BD548FE3-2BC9-4C2E-A898-444148D39519}" type="datetimeFigureOut">
               <a:rPr lang="en-US" smtClean="0"/>
               <a:t>4/11/2026</a:t>
             </a:fld>
@@ -2925,7 +2925,7 @@
           <p:cNvPr id="5" name="Footer Placeholder 4">
             <a:extLst>
               <a:ext uri="{FF2B5EF4-FFF2-40B4-BE49-F238E27FC236}">
-                <a16:creationId xmlns:a16="http://schemas.microsoft.com/office/drawing/2014/main" id="{D51FA743-4839-2FB3-6A81-F92D5B4DB6E4}"/>
+                <a16:creationId xmlns:a16="http://schemas.microsoft.com/office/drawing/2014/main" id="{6764F964-8891-2A67-2F5B-60670C2876F7}"/>
               </a:ext>
             </a:extLst>
           </p:cNvPr>
@@ -2968,7 +2968,7 @@
           <p:cNvPr id="6" name="Slide Number Placeholder 5">
             <a:extLst>
               <a:ext uri="{FF2B5EF4-FFF2-40B4-BE49-F238E27FC236}">
-                <a16:creationId xmlns:a16="http://schemas.microsoft.com/office/drawing/2014/main" id="{083419FE-DEA7-DE89-1F06-CBFB24EC4E3F}"/>
+                <a16:creationId xmlns:a16="http://schemas.microsoft.com/office/drawing/2014/main" id="{26668BFD-0757-B4A2-D481-17EECC51A25A}"/>
               </a:ext>
             </a:extLst>
           </p:cNvPr>
@@ -3002,7 +3002,7 @@
             </a:lvl1pPr>
           </a:lstStyle>
           <a:p>
-            <a:fld id="{1E42A513-68A6-42F7-94CC-B181D5F7CFB8}" type="slidenum">
+            <a:fld id="{E99D46A9-7C22-4BEE-A79D-4FCC3D42940E}" type="slidenum">
               <a:rPr lang="en-US" smtClean="0"/>
               <a:t>‹#›</a:t>
             </a:fld>
@@ -3013,7 +3013,7 @@
     </p:spTree>
     <p:extLst>
       <p:ext uri="{BB962C8B-B14F-4D97-AF65-F5344CB8AC3E}">
-        <p14:creationId xmlns:p14="http://schemas.microsoft.com/office/powerpoint/2010/main" val="1948317811"/>
+        <p14:creationId xmlns:p14="http://schemas.microsoft.com/office/powerpoint/2010/main" val="274087973"/>
       </p:ext>
     </p:extLst>
   </p:cSld>
@@ -3336,7 +3336,7 @@
           <p:cNvPr id="2" name="Title 1">
             <a:extLst>
               <a:ext uri="{FF2B5EF4-FFF2-40B4-BE49-F238E27FC236}">
-                <a16:creationId xmlns:a16="http://schemas.microsoft.com/office/drawing/2014/main" id="{7D4E470A-88BA-C0EE-CB14-A66CCACBD3B4}"/>
+                <a16:creationId xmlns:a16="http://schemas.microsoft.com/office/drawing/2014/main" id="{64F8D9FE-D881-7B59-F460-475C050ABDAB}"/>
               </a:ext>
             </a:extLst>
           </p:cNvPr>
@@ -3368,7 +3368,7 @@
           <p:cNvPr id="3" name="TextBox 2">
             <a:extLst>
               <a:ext uri="{FF2B5EF4-FFF2-40B4-BE49-F238E27FC236}">
-                <a16:creationId xmlns:a16="http://schemas.microsoft.com/office/drawing/2014/main" id="{4470E1FC-F68C-939D-C272-57E4F506D125}"/>
+                <a16:creationId xmlns:a16="http://schemas.microsoft.com/office/drawing/2014/main" id="{F17C3A4C-A5AC-FA98-2EA2-39AA463BE2B1}"/>
               </a:ext>
             </a:extLst>
           </p:cNvPr>
@@ -3459,7 +3459,7 @@
     </p:spTree>
     <p:extLst>
       <p:ext uri="{BB962C8B-B14F-4D97-AF65-F5344CB8AC3E}">
-        <p14:creationId xmlns:p14="http://schemas.microsoft.com/office/powerpoint/2010/main" val="3813466840"/>
+        <p14:creationId xmlns:p14="http://schemas.microsoft.com/office/powerpoint/2010/main" val="1215386107"/>
       </p:ext>
     </p:extLst>
   </p:cSld>
@@ -3491,7 +3491,7 @@
           <p:cNvPr id="2" name="Title 1">
             <a:extLst>
               <a:ext uri="{FF2B5EF4-FFF2-40B4-BE49-F238E27FC236}">
-                <a16:creationId xmlns:a16="http://schemas.microsoft.com/office/drawing/2014/main" id="{9F101CC7-BAE3-6205-5598-60A9B398E898}"/>
+                <a16:creationId xmlns:a16="http://schemas.microsoft.com/office/drawing/2014/main" id="{4420A7DC-95CC-7202-615D-8431932E1026}"/>
               </a:ext>
             </a:extLst>
           </p:cNvPr>
@@ -3523,7 +3523,7 @@
           <p:cNvPr id="3" name="TextBox 2">
             <a:extLst>
               <a:ext uri="{FF2B5EF4-FFF2-40B4-BE49-F238E27FC236}">
-                <a16:creationId xmlns:a16="http://schemas.microsoft.com/office/drawing/2014/main" id="{5F8B3106-29FD-06E5-7F45-CDE1C9CF2FF6}"/>
+                <a16:creationId xmlns:a16="http://schemas.microsoft.com/office/drawing/2014/main" id="{64737436-35C4-44B6-2403-9376BFDF110E}"/>
               </a:ext>
             </a:extLst>
           </p:cNvPr>
@@ -3566,7 +3566,7 @@
               <a:rPr lang="en-US" sz="2200">
                 <a:latin typeface="Aptos" panose="020B0004020202020204" pitchFamily="34" charset="0"/>
               </a:rPr>
-              <a:t>2. attach the saved package evidence to GitHub Issues #2, #3, and #4</a:t>
+              <a:t>2. retest purchase validation, import confirm, and invoice cancellation after fixes are available</a:t>
             </a:r>
           </a:p>
           <a:p>
@@ -3670,7 +3670,7 @@
     </p:spTree>
     <p:extLst>
       <p:ext uri="{BB962C8B-B14F-4D97-AF65-F5344CB8AC3E}">
-        <p14:creationId xmlns:p14="http://schemas.microsoft.com/office/powerpoint/2010/main" val="1918212448"/>
+        <p14:creationId xmlns:p14="http://schemas.microsoft.com/office/powerpoint/2010/main" val="2256719605"/>
       </p:ext>
     </p:extLst>
   </p:cSld>
@@ -3702,7 +3702,7 @@
           <p:cNvPr id="2" name="Title 1">
             <a:extLst>
               <a:ext uri="{FF2B5EF4-FFF2-40B4-BE49-F238E27FC236}">
-                <a16:creationId xmlns:a16="http://schemas.microsoft.com/office/drawing/2014/main" id="{56389405-4355-EB10-8284-AEA67267F612}"/>
+                <a16:creationId xmlns:a16="http://schemas.microsoft.com/office/drawing/2014/main" id="{616A0921-8F88-29E2-5F40-89CAC1499DC2}"/>
               </a:ext>
             </a:extLst>
           </p:cNvPr>
@@ -3734,7 +3734,7 @@
           <p:cNvPr id="3" name="TextBox 2">
             <a:extLst>
               <a:ext uri="{FF2B5EF4-FFF2-40B4-BE49-F238E27FC236}">
-                <a16:creationId xmlns:a16="http://schemas.microsoft.com/office/drawing/2014/main" id="{8A49AB1A-E7BD-C808-C317-C539C3DDED3A}"/>
+                <a16:creationId xmlns:a16="http://schemas.microsoft.com/office/drawing/2014/main" id="{B23B2C65-7EBD-4C92-EED1-4EBB18ACEACF}"/>
               </a:ext>
             </a:extLst>
           </p:cNvPr>
@@ -3809,7 +3809,7 @@
     </p:spTree>
     <p:extLst>
       <p:ext uri="{BB962C8B-B14F-4D97-AF65-F5344CB8AC3E}">
-        <p14:creationId xmlns:p14="http://schemas.microsoft.com/office/powerpoint/2010/main" val="3116988605"/>
+        <p14:creationId xmlns:p14="http://schemas.microsoft.com/office/powerpoint/2010/main" val="1025403266"/>
       </p:ext>
     </p:extLst>
   </p:cSld>
@@ -3841,7 +3841,7 @@
           <p:cNvPr id="2" name="Title 1">
             <a:extLst>
               <a:ext uri="{FF2B5EF4-FFF2-40B4-BE49-F238E27FC236}">
-                <a16:creationId xmlns:a16="http://schemas.microsoft.com/office/drawing/2014/main" id="{89EF4DB3-BC61-0259-617C-7C326736948F}"/>
+                <a16:creationId xmlns:a16="http://schemas.microsoft.com/office/drawing/2014/main" id="{5052A2B9-CBFD-94A3-6BFD-CC4A592679EA}"/>
               </a:ext>
             </a:extLst>
           </p:cNvPr>
@@ -3873,7 +3873,7 @@
           <p:cNvPr id="3" name="TextBox 2">
             <a:extLst>
               <a:ext uri="{FF2B5EF4-FFF2-40B4-BE49-F238E27FC236}">
-                <a16:creationId xmlns:a16="http://schemas.microsoft.com/office/drawing/2014/main" id="{31829902-406C-606D-CDF0-BFC175B7105C}"/>
+                <a16:creationId xmlns:a16="http://schemas.microsoft.com/office/drawing/2014/main" id="{DC80019C-1276-CEAA-D889-1664189A8D52}"/>
               </a:ext>
             </a:extLst>
           </p:cNvPr>
@@ -3988,7 +3988,7 @@
     </p:spTree>
     <p:extLst>
       <p:ext uri="{BB962C8B-B14F-4D97-AF65-F5344CB8AC3E}">
-        <p14:creationId xmlns:p14="http://schemas.microsoft.com/office/powerpoint/2010/main" val="3932739692"/>
+        <p14:creationId xmlns:p14="http://schemas.microsoft.com/office/powerpoint/2010/main" val="3363232154"/>
       </p:ext>
     </p:extLst>
   </p:cSld>
@@ -4020,7 +4020,7 @@
           <p:cNvPr id="2" name="Title 1">
             <a:extLst>
               <a:ext uri="{FF2B5EF4-FFF2-40B4-BE49-F238E27FC236}">
-                <a16:creationId xmlns:a16="http://schemas.microsoft.com/office/drawing/2014/main" id="{EA323ECF-AF6C-1FC1-0DBE-83C26C9BB4B7}"/>
+                <a16:creationId xmlns:a16="http://schemas.microsoft.com/office/drawing/2014/main" id="{090901D9-F4B7-D85C-0DC3-A9B4ACED54DB}"/>
               </a:ext>
             </a:extLst>
           </p:cNvPr>
@@ -4052,7 +4052,7 @@
           <p:cNvPr id="3" name="TextBox 2">
             <a:extLst>
               <a:ext uri="{FF2B5EF4-FFF2-40B4-BE49-F238E27FC236}">
-                <a16:creationId xmlns:a16="http://schemas.microsoft.com/office/drawing/2014/main" id="{EC23528D-80CF-0283-D8E8-D5AEB77575C4}"/>
+                <a16:creationId xmlns:a16="http://schemas.microsoft.com/office/drawing/2014/main" id="{05DEC990-E811-526F-5FDE-8DE6AA89D832}"/>
               </a:ext>
             </a:extLst>
           </p:cNvPr>
@@ -4151,7 +4151,7 @@
     </p:spTree>
     <p:extLst>
       <p:ext uri="{BB962C8B-B14F-4D97-AF65-F5344CB8AC3E}">
-        <p14:creationId xmlns:p14="http://schemas.microsoft.com/office/powerpoint/2010/main" val="4265834926"/>
+        <p14:creationId xmlns:p14="http://schemas.microsoft.com/office/powerpoint/2010/main" val="583549080"/>
       </p:ext>
     </p:extLst>
   </p:cSld>
@@ -4183,7 +4183,7 @@
           <p:cNvPr id="2" name="Title 1">
             <a:extLst>
               <a:ext uri="{FF2B5EF4-FFF2-40B4-BE49-F238E27FC236}">
-                <a16:creationId xmlns:a16="http://schemas.microsoft.com/office/drawing/2014/main" id="{6074B849-B066-EB6F-A9EB-7B6D0DF6B351}"/>
+                <a16:creationId xmlns:a16="http://schemas.microsoft.com/office/drawing/2014/main" id="{D58C27AE-3E27-DC63-C81E-BC27E5732A3A}"/>
               </a:ext>
             </a:extLst>
           </p:cNvPr>
@@ -4215,7 +4215,7 @@
           <p:cNvPr id="3" name="TextBox 2">
             <a:extLst>
               <a:ext uri="{FF2B5EF4-FFF2-40B4-BE49-F238E27FC236}">
-                <a16:creationId xmlns:a16="http://schemas.microsoft.com/office/drawing/2014/main" id="{4F68C5B4-4ECC-5E4A-5DBD-2C7BD7F48A59}"/>
+                <a16:creationId xmlns:a16="http://schemas.microsoft.com/office/drawing/2014/main" id="{B35E96D7-B644-F2E1-66FE-A2BB4DC3E643}"/>
               </a:ext>
             </a:extLst>
           </p:cNvPr>
@@ -4322,7 +4322,7 @@
     </p:spTree>
     <p:extLst>
       <p:ext uri="{BB962C8B-B14F-4D97-AF65-F5344CB8AC3E}">
-        <p14:creationId xmlns:p14="http://schemas.microsoft.com/office/powerpoint/2010/main" val="1742529042"/>
+        <p14:creationId xmlns:p14="http://schemas.microsoft.com/office/powerpoint/2010/main" val="3317940090"/>
       </p:ext>
     </p:extLst>
   </p:cSld>
@@ -4354,7 +4354,7 @@
           <p:cNvPr id="2" name="Title 1">
             <a:extLst>
               <a:ext uri="{FF2B5EF4-FFF2-40B4-BE49-F238E27FC236}">
-                <a16:creationId xmlns:a16="http://schemas.microsoft.com/office/drawing/2014/main" id="{9CD46124-779D-E355-F1AB-32B20B239FB5}"/>
+                <a16:creationId xmlns:a16="http://schemas.microsoft.com/office/drawing/2014/main" id="{D0513042-B0C3-73D8-1793-83F8ADBA5AE9}"/>
               </a:ext>
             </a:extLst>
           </p:cNvPr>
@@ -4386,7 +4386,7 @@
           <p:cNvPr id="3" name="TextBox 2">
             <a:extLst>
               <a:ext uri="{FF2B5EF4-FFF2-40B4-BE49-F238E27FC236}">
-                <a16:creationId xmlns:a16="http://schemas.microsoft.com/office/drawing/2014/main" id="{2185FACF-8EB7-96E5-12D4-242404A071AC}"/>
+                <a16:creationId xmlns:a16="http://schemas.microsoft.com/office/drawing/2014/main" id="{6A66F3BD-495C-807B-1A48-732CD9861321}"/>
               </a:ext>
             </a:extLst>
           </p:cNvPr>
@@ -4501,7 +4501,7 @@
     </p:spTree>
     <p:extLst>
       <p:ext uri="{BB962C8B-B14F-4D97-AF65-F5344CB8AC3E}">
-        <p14:creationId xmlns:p14="http://schemas.microsoft.com/office/powerpoint/2010/main" val="647110517"/>
+        <p14:creationId xmlns:p14="http://schemas.microsoft.com/office/powerpoint/2010/main" val="181301688"/>
       </p:ext>
     </p:extLst>
   </p:cSld>
@@ -4533,7 +4533,7 @@
           <p:cNvPr id="2" name="Title 1">
             <a:extLst>
               <a:ext uri="{FF2B5EF4-FFF2-40B4-BE49-F238E27FC236}">
-                <a16:creationId xmlns:a16="http://schemas.microsoft.com/office/drawing/2014/main" id="{80B59349-CB18-8063-0967-19A13C649A33}"/>
+                <a16:creationId xmlns:a16="http://schemas.microsoft.com/office/drawing/2014/main" id="{FBFCFB9F-FDF4-50C3-CC4D-584DB2A07FFE}"/>
               </a:ext>
             </a:extLst>
           </p:cNvPr>
@@ -4565,7 +4565,7 @@
           <p:cNvPr id="3" name="TextBox 2">
             <a:extLst>
               <a:ext uri="{FF2B5EF4-FFF2-40B4-BE49-F238E27FC236}">
-                <a16:creationId xmlns:a16="http://schemas.microsoft.com/office/drawing/2014/main" id="{7822B5BA-CCFC-33DD-4EB1-3DF6946D4ED9}"/>
+                <a16:creationId xmlns:a16="http://schemas.microsoft.com/office/drawing/2014/main" id="{5D616E96-7D9F-75C1-DC48-DA6875FDC066}"/>
               </a:ext>
             </a:extLst>
           </p:cNvPr>
@@ -4722,7 +4722,7 @@
           <p:cNvPr id="5" name="Picture 4">
             <a:extLst>
               <a:ext uri="{FF2B5EF4-FFF2-40B4-BE49-F238E27FC236}">
-                <a16:creationId xmlns:a16="http://schemas.microsoft.com/office/drawing/2014/main" id="{56DC671F-BFC2-1150-361D-865EFDCF3098}"/>
+                <a16:creationId xmlns:a16="http://schemas.microsoft.com/office/drawing/2014/main" id="{DF992A7C-152B-2B83-E663-3BB119913DAF}"/>
               </a:ext>
             </a:extLst>
           </p:cNvPr>
@@ -4756,7 +4756,7 @@
     </p:spTree>
     <p:extLst>
       <p:ext uri="{BB962C8B-B14F-4D97-AF65-F5344CB8AC3E}">
-        <p14:creationId xmlns:p14="http://schemas.microsoft.com/office/powerpoint/2010/main" val="855949967"/>
+        <p14:creationId xmlns:p14="http://schemas.microsoft.com/office/powerpoint/2010/main" val="261138899"/>
       </p:ext>
     </p:extLst>
   </p:cSld>
@@ -4788,7 +4788,7 @@
           <p:cNvPr id="2" name="Title 1">
             <a:extLst>
               <a:ext uri="{FF2B5EF4-FFF2-40B4-BE49-F238E27FC236}">
-                <a16:creationId xmlns:a16="http://schemas.microsoft.com/office/drawing/2014/main" id="{9B38594C-E952-F25D-C21E-E2540C3E3D70}"/>
+                <a16:creationId xmlns:a16="http://schemas.microsoft.com/office/drawing/2014/main" id="{F0FC6204-5603-5E75-F241-4098A5443D70}"/>
               </a:ext>
             </a:extLst>
           </p:cNvPr>
@@ -4820,7 +4820,7 @@
           <p:cNvPr id="3" name="TextBox 2">
             <a:extLst>
               <a:ext uri="{FF2B5EF4-FFF2-40B4-BE49-F238E27FC236}">
-                <a16:creationId xmlns:a16="http://schemas.microsoft.com/office/drawing/2014/main" id="{BEEA19F3-00E6-D389-2C01-4FD322287F80}"/>
+                <a16:creationId xmlns:a16="http://schemas.microsoft.com/office/drawing/2014/main" id="{6D288B59-7650-23B3-33AE-B6984E8151A0}"/>
               </a:ext>
             </a:extLst>
           </p:cNvPr>
@@ -4945,7 +4945,7 @@
           <p:cNvPr id="5" name="Picture 4">
             <a:extLst>
               <a:ext uri="{FF2B5EF4-FFF2-40B4-BE49-F238E27FC236}">
-                <a16:creationId xmlns:a16="http://schemas.microsoft.com/office/drawing/2014/main" id="{CADC0842-5834-0120-D665-B037F4B2D1D9}"/>
+                <a16:creationId xmlns:a16="http://schemas.microsoft.com/office/drawing/2014/main" id="{3E077960-7B38-4E57-3F04-C29A73ADBE54}"/>
               </a:ext>
             </a:extLst>
           </p:cNvPr>
@@ -4979,7 +4979,7 @@
     </p:spTree>
     <p:extLst>
       <p:ext uri="{BB962C8B-B14F-4D97-AF65-F5344CB8AC3E}">
-        <p14:creationId xmlns:p14="http://schemas.microsoft.com/office/powerpoint/2010/main" val="1252753076"/>
+        <p14:creationId xmlns:p14="http://schemas.microsoft.com/office/powerpoint/2010/main" val="3154678670"/>
       </p:ext>
     </p:extLst>
   </p:cSld>
@@ -5011,7 +5011,7 @@
           <p:cNvPr id="2" name="Title 1">
             <a:extLst>
               <a:ext uri="{FF2B5EF4-FFF2-40B4-BE49-F238E27FC236}">
-                <a16:creationId xmlns:a16="http://schemas.microsoft.com/office/drawing/2014/main" id="{2D7E75CF-71A9-0CE4-E2F1-BFDACA26F2DD}"/>
+                <a16:creationId xmlns:a16="http://schemas.microsoft.com/office/drawing/2014/main" id="{E5E36EB9-6CD3-DFD6-EE55-6D8622DB56A6}"/>
               </a:ext>
             </a:extLst>
           </p:cNvPr>
@@ -5043,7 +5043,7 @@
           <p:cNvPr id="3" name="TextBox 2">
             <a:extLst>
               <a:ext uri="{FF2B5EF4-FFF2-40B4-BE49-F238E27FC236}">
-                <a16:creationId xmlns:a16="http://schemas.microsoft.com/office/drawing/2014/main" id="{0BB10611-5CB4-7DBB-7169-28CA12C552DB}"/>
+                <a16:creationId xmlns:a16="http://schemas.microsoft.com/office/drawing/2014/main" id="{95F2C1F0-091D-9B1F-F79A-F0853EFC8A91}"/>
               </a:ext>
             </a:extLst>
           </p:cNvPr>
@@ -5184,7 +5184,7 @@
           <p:cNvPr id="5" name="Picture 4">
             <a:extLst>
               <a:ext uri="{FF2B5EF4-FFF2-40B4-BE49-F238E27FC236}">
-                <a16:creationId xmlns:a16="http://schemas.microsoft.com/office/drawing/2014/main" id="{946522F4-012A-7C5C-2828-31097C10623C}"/>
+                <a16:creationId xmlns:a16="http://schemas.microsoft.com/office/drawing/2014/main" id="{332153AB-107C-6A08-E312-DD5FBFAA9D34}"/>
               </a:ext>
             </a:extLst>
           </p:cNvPr>
@@ -5218,7 +5218,7 @@
     </p:spTree>
     <p:extLst>
       <p:ext uri="{BB962C8B-B14F-4D97-AF65-F5344CB8AC3E}">
-        <p14:creationId xmlns:p14="http://schemas.microsoft.com/office/powerpoint/2010/main" val="2592893824"/>
+        <p14:creationId xmlns:p14="http://schemas.microsoft.com/office/powerpoint/2010/main" val="2198680852"/>
       </p:ext>
     </p:extLst>
   </p:cSld>
@@ -5250,7 +5250,7 @@
           <p:cNvPr id="2" name="Title 1">
             <a:extLst>
               <a:ext uri="{FF2B5EF4-FFF2-40B4-BE49-F238E27FC236}">
-                <a16:creationId xmlns:a16="http://schemas.microsoft.com/office/drawing/2014/main" id="{359BE020-A800-6F6A-0B72-74E9B3BC85FC}"/>
+                <a16:creationId xmlns:a16="http://schemas.microsoft.com/office/drawing/2014/main" id="{7ECBCF06-A47A-32EC-778F-C6492C56D157}"/>
               </a:ext>
             </a:extLst>
           </p:cNvPr>
@@ -5282,7 +5282,7 @@
           <p:cNvPr id="3" name="TextBox 2">
             <a:extLst>
               <a:ext uri="{FF2B5EF4-FFF2-40B4-BE49-F238E27FC236}">
-                <a16:creationId xmlns:a16="http://schemas.microsoft.com/office/drawing/2014/main" id="{165C5D9E-A901-520C-58AB-808CFCB5E679}"/>
+                <a16:creationId xmlns:a16="http://schemas.microsoft.com/office/drawing/2014/main" id="{CDEC7DD6-428B-ACED-5615-3324E2ACBAA3}"/>
               </a:ext>
             </a:extLst>
           </p:cNvPr>
@@ -5373,7 +5373,7 @@
     </p:spTree>
     <p:extLst>
       <p:ext uri="{BB962C8B-B14F-4D97-AF65-F5344CB8AC3E}">
-        <p14:creationId xmlns:p14="http://schemas.microsoft.com/office/powerpoint/2010/main" val="4089292942"/>
+        <p14:creationId xmlns:p14="http://schemas.microsoft.com/office/powerpoint/2010/main" val="2731307478"/>
       </p:ext>
     </p:extLst>
   </p:cSld>

</xml_diff>

<commit_message>
docs: add real defect retest evidence and edge smoke coverage
</commit_message>
<xml_diff>
--- a/Report Test subject/Powered by GPT/MainReport/Powered by GPT - Software Quality Verification - Presentation.pptx
+++ b/Report Test subject/Powered by GPT/MainReport/Powered by GPT - Software Quality Verification - Presentation.pptx
@@ -139,7 +139,7 @@
           <p:cNvPr id="2" name="Title 1">
             <a:extLst>
               <a:ext uri="{FF2B5EF4-FFF2-40B4-BE49-F238E27FC236}">
-                <a16:creationId xmlns:a16="http://schemas.microsoft.com/office/drawing/2014/main" id="{07B023E5-14E9-075C-BB9C-938E9048BFBB}"/>
+                <a16:creationId xmlns:a16="http://schemas.microsoft.com/office/drawing/2014/main" id="{C9480FD3-02D3-8B67-B71A-4185FBF1F3BE}"/>
               </a:ext>
             </a:extLst>
           </p:cNvPr>
@@ -176,7 +176,7 @@
           <p:cNvPr id="3" name="Subtitle 2">
             <a:extLst>
               <a:ext uri="{FF2B5EF4-FFF2-40B4-BE49-F238E27FC236}">
-                <a16:creationId xmlns:a16="http://schemas.microsoft.com/office/drawing/2014/main" id="{D6FE90A3-047E-F498-09D3-FF27D2C9CD46}"/>
+                <a16:creationId xmlns:a16="http://schemas.microsoft.com/office/drawing/2014/main" id="{946A3DAE-3CCE-EC37-8855-BCDBA7FA36D8}"/>
               </a:ext>
             </a:extLst>
           </p:cNvPr>
@@ -246,7 +246,7 @@
           <p:cNvPr id="4" name="Date Placeholder 3">
             <a:extLst>
               <a:ext uri="{FF2B5EF4-FFF2-40B4-BE49-F238E27FC236}">
-                <a16:creationId xmlns:a16="http://schemas.microsoft.com/office/drawing/2014/main" id="{EF233487-3BAB-C48A-CB82-5472D7B04739}"/>
+                <a16:creationId xmlns:a16="http://schemas.microsoft.com/office/drawing/2014/main" id="{407FB60E-C5D3-278C-6299-5D22CCF32A3E}"/>
               </a:ext>
             </a:extLst>
           </p:cNvPr>
@@ -262,7 +262,7 @@
           <a:bodyPr/>
           <a:lstStyle/>
           <a:p>
-            <a:fld id="{BD548FE3-2BC9-4C2E-A898-444148D39519}" type="datetimeFigureOut">
+            <a:fld id="{6D1FBE4F-525F-44CD-BC5F-F1D6017AEA63}" type="datetimeFigureOut">
               <a:rPr lang="en-US" smtClean="0"/>
               <a:t>4/11/2026</a:t>
             </a:fld>
@@ -275,7 +275,7 @@
           <p:cNvPr id="5" name="Footer Placeholder 4">
             <a:extLst>
               <a:ext uri="{FF2B5EF4-FFF2-40B4-BE49-F238E27FC236}">
-                <a16:creationId xmlns:a16="http://schemas.microsoft.com/office/drawing/2014/main" id="{1F701C24-B3D2-2A36-D8C4-A97918497FAA}"/>
+                <a16:creationId xmlns:a16="http://schemas.microsoft.com/office/drawing/2014/main" id="{FC623BCF-2D48-CCC5-A143-132CEF0D4480}"/>
               </a:ext>
             </a:extLst>
           </p:cNvPr>
@@ -300,7 +300,7 @@
           <p:cNvPr id="6" name="Slide Number Placeholder 5">
             <a:extLst>
               <a:ext uri="{FF2B5EF4-FFF2-40B4-BE49-F238E27FC236}">
-                <a16:creationId xmlns:a16="http://schemas.microsoft.com/office/drawing/2014/main" id="{BB26296B-E557-F894-524C-EAFA7374B742}"/>
+                <a16:creationId xmlns:a16="http://schemas.microsoft.com/office/drawing/2014/main" id="{484ACB4C-5391-1C8A-03E7-1F1CF7C8DB72}"/>
               </a:ext>
             </a:extLst>
           </p:cNvPr>
@@ -316,7 +316,7 @@
           <a:bodyPr/>
           <a:lstStyle/>
           <a:p>
-            <a:fld id="{E99D46A9-7C22-4BEE-A79D-4FCC3D42940E}" type="slidenum">
+            <a:fld id="{BF3C3688-BAAA-4754-AAD6-035CCC78683D}" type="slidenum">
               <a:rPr lang="en-US" smtClean="0"/>
               <a:t>‹#›</a:t>
             </a:fld>
@@ -327,7 +327,7 @@
     </p:spTree>
     <p:extLst>
       <p:ext uri="{BB962C8B-B14F-4D97-AF65-F5344CB8AC3E}">
-        <p14:creationId xmlns:p14="http://schemas.microsoft.com/office/powerpoint/2010/main" val="1432057293"/>
+        <p14:creationId xmlns:p14="http://schemas.microsoft.com/office/powerpoint/2010/main" val="1107052267"/>
       </p:ext>
     </p:extLst>
   </p:cSld>
@@ -359,7 +359,7 @@
           <p:cNvPr id="2" name="Title 1">
             <a:extLst>
               <a:ext uri="{FF2B5EF4-FFF2-40B4-BE49-F238E27FC236}">
-                <a16:creationId xmlns:a16="http://schemas.microsoft.com/office/drawing/2014/main" id="{798ED3FA-20EF-684E-C262-F9B698F023F2}"/>
+                <a16:creationId xmlns:a16="http://schemas.microsoft.com/office/drawing/2014/main" id="{93A52CF5-9D62-DDB0-C153-53CEE07AD4F5}"/>
               </a:ext>
             </a:extLst>
           </p:cNvPr>
@@ -387,7 +387,7 @@
           <p:cNvPr id="3" name="Vertical Text Placeholder 2">
             <a:extLst>
               <a:ext uri="{FF2B5EF4-FFF2-40B4-BE49-F238E27FC236}">
-                <a16:creationId xmlns:a16="http://schemas.microsoft.com/office/drawing/2014/main" id="{19F518FC-C90A-3816-72B8-07DB6ED1A0C8}"/>
+                <a16:creationId xmlns:a16="http://schemas.microsoft.com/office/drawing/2014/main" id="{4E489C40-802C-63AD-349C-4F011D893392}"/>
               </a:ext>
             </a:extLst>
           </p:cNvPr>
@@ -444,7 +444,7 @@
           <p:cNvPr id="4" name="Date Placeholder 3">
             <a:extLst>
               <a:ext uri="{FF2B5EF4-FFF2-40B4-BE49-F238E27FC236}">
-                <a16:creationId xmlns:a16="http://schemas.microsoft.com/office/drawing/2014/main" id="{B63F6860-0302-4EEA-BFDB-45C0655F7EC8}"/>
+                <a16:creationId xmlns:a16="http://schemas.microsoft.com/office/drawing/2014/main" id="{DB3A704E-94F7-5B40-842B-7932730058DF}"/>
               </a:ext>
             </a:extLst>
           </p:cNvPr>
@@ -460,7 +460,7 @@
           <a:bodyPr/>
           <a:lstStyle/>
           <a:p>
-            <a:fld id="{BD548FE3-2BC9-4C2E-A898-444148D39519}" type="datetimeFigureOut">
+            <a:fld id="{6D1FBE4F-525F-44CD-BC5F-F1D6017AEA63}" type="datetimeFigureOut">
               <a:rPr lang="en-US" smtClean="0"/>
               <a:t>4/11/2026</a:t>
             </a:fld>
@@ -473,7 +473,7 @@
           <p:cNvPr id="5" name="Footer Placeholder 4">
             <a:extLst>
               <a:ext uri="{FF2B5EF4-FFF2-40B4-BE49-F238E27FC236}">
-                <a16:creationId xmlns:a16="http://schemas.microsoft.com/office/drawing/2014/main" id="{D9874196-C9C4-01C3-A0D7-B9B042153AE8}"/>
+                <a16:creationId xmlns:a16="http://schemas.microsoft.com/office/drawing/2014/main" id="{6828687F-0587-5758-0D4D-4365DEE74A64}"/>
               </a:ext>
             </a:extLst>
           </p:cNvPr>
@@ -498,7 +498,7 @@
           <p:cNvPr id="6" name="Slide Number Placeholder 5">
             <a:extLst>
               <a:ext uri="{FF2B5EF4-FFF2-40B4-BE49-F238E27FC236}">
-                <a16:creationId xmlns:a16="http://schemas.microsoft.com/office/drawing/2014/main" id="{FF2D5FAC-1ABC-90FF-8662-A3E79E1BF80E}"/>
+                <a16:creationId xmlns:a16="http://schemas.microsoft.com/office/drawing/2014/main" id="{C357E263-25E1-58E9-3312-EB0353CCE1F6}"/>
               </a:ext>
             </a:extLst>
           </p:cNvPr>
@@ -514,7 +514,7 @@
           <a:bodyPr/>
           <a:lstStyle/>
           <a:p>
-            <a:fld id="{E99D46A9-7C22-4BEE-A79D-4FCC3D42940E}" type="slidenum">
+            <a:fld id="{BF3C3688-BAAA-4754-AAD6-035CCC78683D}" type="slidenum">
               <a:rPr lang="en-US" smtClean="0"/>
               <a:t>‹#›</a:t>
             </a:fld>
@@ -525,7 +525,7 @@
     </p:spTree>
     <p:extLst>
       <p:ext uri="{BB962C8B-B14F-4D97-AF65-F5344CB8AC3E}">
-        <p14:creationId xmlns:p14="http://schemas.microsoft.com/office/powerpoint/2010/main" val="3415446000"/>
+        <p14:creationId xmlns:p14="http://schemas.microsoft.com/office/powerpoint/2010/main" val="1425029519"/>
       </p:ext>
     </p:extLst>
   </p:cSld>
@@ -557,7 +557,7 @@
           <p:cNvPr id="2" name="Vertical Title 1">
             <a:extLst>
               <a:ext uri="{FF2B5EF4-FFF2-40B4-BE49-F238E27FC236}">
-                <a16:creationId xmlns:a16="http://schemas.microsoft.com/office/drawing/2014/main" id="{599515CE-9359-0049-9BE6-ABF15DEFDF17}"/>
+                <a16:creationId xmlns:a16="http://schemas.microsoft.com/office/drawing/2014/main" id="{7DE88423-5E87-7289-27E8-9F9AD2CBB411}"/>
               </a:ext>
             </a:extLst>
           </p:cNvPr>
@@ -590,7 +590,7 @@
           <p:cNvPr id="3" name="Vertical Text Placeholder 2">
             <a:extLst>
               <a:ext uri="{FF2B5EF4-FFF2-40B4-BE49-F238E27FC236}">
-                <a16:creationId xmlns:a16="http://schemas.microsoft.com/office/drawing/2014/main" id="{7F24640C-0325-A6A3-08B7-90FD88954E3C}"/>
+                <a16:creationId xmlns:a16="http://schemas.microsoft.com/office/drawing/2014/main" id="{F68DC8F3-B7B1-5C39-28BA-BADED5F8D02A}"/>
               </a:ext>
             </a:extLst>
           </p:cNvPr>
@@ -652,7 +652,7 @@
           <p:cNvPr id="4" name="Date Placeholder 3">
             <a:extLst>
               <a:ext uri="{FF2B5EF4-FFF2-40B4-BE49-F238E27FC236}">
-                <a16:creationId xmlns:a16="http://schemas.microsoft.com/office/drawing/2014/main" id="{1C286C95-982C-BB32-F2C1-3D2BA18DB490}"/>
+                <a16:creationId xmlns:a16="http://schemas.microsoft.com/office/drawing/2014/main" id="{8792590E-B070-0F12-6A95-03CDB62676A2}"/>
               </a:ext>
             </a:extLst>
           </p:cNvPr>
@@ -668,7 +668,7 @@
           <a:bodyPr/>
           <a:lstStyle/>
           <a:p>
-            <a:fld id="{BD548FE3-2BC9-4C2E-A898-444148D39519}" type="datetimeFigureOut">
+            <a:fld id="{6D1FBE4F-525F-44CD-BC5F-F1D6017AEA63}" type="datetimeFigureOut">
               <a:rPr lang="en-US" smtClean="0"/>
               <a:t>4/11/2026</a:t>
             </a:fld>
@@ -681,7 +681,7 @@
           <p:cNvPr id="5" name="Footer Placeholder 4">
             <a:extLst>
               <a:ext uri="{FF2B5EF4-FFF2-40B4-BE49-F238E27FC236}">
-                <a16:creationId xmlns:a16="http://schemas.microsoft.com/office/drawing/2014/main" id="{3E583679-CC40-FB2C-0DDF-01469A3432B0}"/>
+                <a16:creationId xmlns:a16="http://schemas.microsoft.com/office/drawing/2014/main" id="{D0C47DE2-9236-B673-47DD-3ED09F64520B}"/>
               </a:ext>
             </a:extLst>
           </p:cNvPr>
@@ -706,7 +706,7 @@
           <p:cNvPr id="6" name="Slide Number Placeholder 5">
             <a:extLst>
               <a:ext uri="{FF2B5EF4-FFF2-40B4-BE49-F238E27FC236}">
-                <a16:creationId xmlns:a16="http://schemas.microsoft.com/office/drawing/2014/main" id="{98ADDF0A-2B35-A8E6-3600-186265C886C8}"/>
+                <a16:creationId xmlns:a16="http://schemas.microsoft.com/office/drawing/2014/main" id="{1D7CE497-49F6-0F13-0B20-2DD437AA2B56}"/>
               </a:ext>
             </a:extLst>
           </p:cNvPr>
@@ -722,7 +722,7 @@
           <a:bodyPr/>
           <a:lstStyle/>
           <a:p>
-            <a:fld id="{E99D46A9-7C22-4BEE-A79D-4FCC3D42940E}" type="slidenum">
+            <a:fld id="{BF3C3688-BAAA-4754-AAD6-035CCC78683D}" type="slidenum">
               <a:rPr lang="en-US" smtClean="0"/>
               <a:t>‹#›</a:t>
             </a:fld>
@@ -733,7 +733,7 @@
     </p:spTree>
     <p:extLst>
       <p:ext uri="{BB962C8B-B14F-4D97-AF65-F5344CB8AC3E}">
-        <p14:creationId xmlns:p14="http://schemas.microsoft.com/office/powerpoint/2010/main" val="81774956"/>
+        <p14:creationId xmlns:p14="http://schemas.microsoft.com/office/powerpoint/2010/main" val="493851729"/>
       </p:ext>
     </p:extLst>
   </p:cSld>
@@ -765,7 +765,7 @@
           <p:cNvPr id="2" name="Title 1">
             <a:extLst>
               <a:ext uri="{FF2B5EF4-FFF2-40B4-BE49-F238E27FC236}">
-                <a16:creationId xmlns:a16="http://schemas.microsoft.com/office/drawing/2014/main" id="{DD7CBB8E-0095-E203-4845-42DD7C3F395F}"/>
+                <a16:creationId xmlns:a16="http://schemas.microsoft.com/office/drawing/2014/main" id="{324D6FAA-562D-3013-E9B2-4C5C954D9AF7}"/>
               </a:ext>
             </a:extLst>
           </p:cNvPr>
@@ -793,7 +793,7 @@
           <p:cNvPr id="3" name="Content Placeholder 2">
             <a:extLst>
               <a:ext uri="{FF2B5EF4-FFF2-40B4-BE49-F238E27FC236}">
-                <a16:creationId xmlns:a16="http://schemas.microsoft.com/office/drawing/2014/main" id="{802A9BA3-58BB-55E6-03E2-083DBD223A2A}"/>
+                <a16:creationId xmlns:a16="http://schemas.microsoft.com/office/drawing/2014/main" id="{F54E37C7-6EFF-D902-EEE9-81BBB0C278A1}"/>
               </a:ext>
             </a:extLst>
           </p:cNvPr>
@@ -850,7 +850,7 @@
           <p:cNvPr id="4" name="Date Placeholder 3">
             <a:extLst>
               <a:ext uri="{FF2B5EF4-FFF2-40B4-BE49-F238E27FC236}">
-                <a16:creationId xmlns:a16="http://schemas.microsoft.com/office/drawing/2014/main" id="{F29258C8-BA66-9FA2-978C-BD96D42DA6FB}"/>
+                <a16:creationId xmlns:a16="http://schemas.microsoft.com/office/drawing/2014/main" id="{7868C37E-4068-74F2-13AA-C5A7281C0C31}"/>
               </a:ext>
             </a:extLst>
           </p:cNvPr>
@@ -866,7 +866,7 @@
           <a:bodyPr/>
           <a:lstStyle/>
           <a:p>
-            <a:fld id="{BD548FE3-2BC9-4C2E-A898-444148D39519}" type="datetimeFigureOut">
+            <a:fld id="{6D1FBE4F-525F-44CD-BC5F-F1D6017AEA63}" type="datetimeFigureOut">
               <a:rPr lang="en-US" smtClean="0"/>
               <a:t>4/11/2026</a:t>
             </a:fld>
@@ -879,7 +879,7 @@
           <p:cNvPr id="5" name="Footer Placeholder 4">
             <a:extLst>
               <a:ext uri="{FF2B5EF4-FFF2-40B4-BE49-F238E27FC236}">
-                <a16:creationId xmlns:a16="http://schemas.microsoft.com/office/drawing/2014/main" id="{E6957A5B-EA11-D004-1312-5EF76D6FB7D2}"/>
+                <a16:creationId xmlns:a16="http://schemas.microsoft.com/office/drawing/2014/main" id="{5C963376-719F-1A15-617B-0E0F3067C026}"/>
               </a:ext>
             </a:extLst>
           </p:cNvPr>
@@ -904,7 +904,7 @@
           <p:cNvPr id="6" name="Slide Number Placeholder 5">
             <a:extLst>
               <a:ext uri="{FF2B5EF4-FFF2-40B4-BE49-F238E27FC236}">
-                <a16:creationId xmlns:a16="http://schemas.microsoft.com/office/drawing/2014/main" id="{B3F5546B-087C-9253-D555-1381A081168A}"/>
+                <a16:creationId xmlns:a16="http://schemas.microsoft.com/office/drawing/2014/main" id="{C62A8BFD-B81A-AE3F-DD73-5324314FF783}"/>
               </a:ext>
             </a:extLst>
           </p:cNvPr>
@@ -920,7 +920,7 @@
           <a:bodyPr/>
           <a:lstStyle/>
           <a:p>
-            <a:fld id="{E99D46A9-7C22-4BEE-A79D-4FCC3D42940E}" type="slidenum">
+            <a:fld id="{BF3C3688-BAAA-4754-AAD6-035CCC78683D}" type="slidenum">
               <a:rPr lang="en-US" smtClean="0"/>
               <a:t>‹#›</a:t>
             </a:fld>
@@ -931,7 +931,7 @@
     </p:spTree>
     <p:extLst>
       <p:ext uri="{BB962C8B-B14F-4D97-AF65-F5344CB8AC3E}">
-        <p14:creationId xmlns:p14="http://schemas.microsoft.com/office/powerpoint/2010/main" val="163427301"/>
+        <p14:creationId xmlns:p14="http://schemas.microsoft.com/office/powerpoint/2010/main" val="3056083745"/>
       </p:ext>
     </p:extLst>
   </p:cSld>
@@ -963,7 +963,7 @@
           <p:cNvPr id="2" name="Title 1">
             <a:extLst>
               <a:ext uri="{FF2B5EF4-FFF2-40B4-BE49-F238E27FC236}">
-                <a16:creationId xmlns:a16="http://schemas.microsoft.com/office/drawing/2014/main" id="{A9B9DBE7-211B-E7CE-3836-1EF7FAC71CC2}"/>
+                <a16:creationId xmlns:a16="http://schemas.microsoft.com/office/drawing/2014/main" id="{B8A43191-4FF3-9FDD-752D-A60BE1705322}"/>
               </a:ext>
             </a:extLst>
           </p:cNvPr>
@@ -1000,7 +1000,7 @@
           <p:cNvPr id="3" name="Text Placeholder 2">
             <a:extLst>
               <a:ext uri="{FF2B5EF4-FFF2-40B4-BE49-F238E27FC236}">
-                <a16:creationId xmlns:a16="http://schemas.microsoft.com/office/drawing/2014/main" id="{7E3B714C-34A0-A9D4-EA75-5AD81DD887F8}"/>
+                <a16:creationId xmlns:a16="http://schemas.microsoft.com/office/drawing/2014/main" id="{08572574-D79F-2F48-488C-B6783054A204}"/>
               </a:ext>
             </a:extLst>
           </p:cNvPr>
@@ -1125,7 +1125,7 @@
           <p:cNvPr id="4" name="Date Placeholder 3">
             <a:extLst>
               <a:ext uri="{FF2B5EF4-FFF2-40B4-BE49-F238E27FC236}">
-                <a16:creationId xmlns:a16="http://schemas.microsoft.com/office/drawing/2014/main" id="{67AB125B-ED49-EE90-CC5B-6B65B7FE9CFA}"/>
+                <a16:creationId xmlns:a16="http://schemas.microsoft.com/office/drawing/2014/main" id="{AACA2FB0-DC4D-C29D-F5A3-0F0BC7F92003}"/>
               </a:ext>
             </a:extLst>
           </p:cNvPr>
@@ -1141,7 +1141,7 @@
           <a:bodyPr/>
           <a:lstStyle/>
           <a:p>
-            <a:fld id="{BD548FE3-2BC9-4C2E-A898-444148D39519}" type="datetimeFigureOut">
+            <a:fld id="{6D1FBE4F-525F-44CD-BC5F-F1D6017AEA63}" type="datetimeFigureOut">
               <a:rPr lang="en-US" smtClean="0"/>
               <a:t>4/11/2026</a:t>
             </a:fld>
@@ -1154,7 +1154,7 @@
           <p:cNvPr id="5" name="Footer Placeholder 4">
             <a:extLst>
               <a:ext uri="{FF2B5EF4-FFF2-40B4-BE49-F238E27FC236}">
-                <a16:creationId xmlns:a16="http://schemas.microsoft.com/office/drawing/2014/main" id="{23987DF2-2174-8DAE-00CA-0B00DE84D0F6}"/>
+                <a16:creationId xmlns:a16="http://schemas.microsoft.com/office/drawing/2014/main" id="{434A414D-FE4A-EB1D-3062-19C7E3717C6E}"/>
               </a:ext>
             </a:extLst>
           </p:cNvPr>
@@ -1179,7 +1179,7 @@
           <p:cNvPr id="6" name="Slide Number Placeholder 5">
             <a:extLst>
               <a:ext uri="{FF2B5EF4-FFF2-40B4-BE49-F238E27FC236}">
-                <a16:creationId xmlns:a16="http://schemas.microsoft.com/office/drawing/2014/main" id="{4977D564-E0B7-0CB5-E2F9-65B4C2B54633}"/>
+                <a16:creationId xmlns:a16="http://schemas.microsoft.com/office/drawing/2014/main" id="{366713F8-4CE8-6AB1-7367-F2A5F1D63498}"/>
               </a:ext>
             </a:extLst>
           </p:cNvPr>
@@ -1195,7 +1195,7 @@
           <a:bodyPr/>
           <a:lstStyle/>
           <a:p>
-            <a:fld id="{E99D46A9-7C22-4BEE-A79D-4FCC3D42940E}" type="slidenum">
+            <a:fld id="{BF3C3688-BAAA-4754-AAD6-035CCC78683D}" type="slidenum">
               <a:rPr lang="en-US" smtClean="0"/>
               <a:t>‹#›</a:t>
             </a:fld>
@@ -1206,7 +1206,7 @@
     </p:spTree>
     <p:extLst>
       <p:ext uri="{BB962C8B-B14F-4D97-AF65-F5344CB8AC3E}">
-        <p14:creationId xmlns:p14="http://schemas.microsoft.com/office/powerpoint/2010/main" val="3006449195"/>
+        <p14:creationId xmlns:p14="http://schemas.microsoft.com/office/powerpoint/2010/main" val="485534507"/>
       </p:ext>
     </p:extLst>
   </p:cSld>
@@ -1238,7 +1238,7 @@
           <p:cNvPr id="2" name="Title 1">
             <a:extLst>
               <a:ext uri="{FF2B5EF4-FFF2-40B4-BE49-F238E27FC236}">
-                <a16:creationId xmlns:a16="http://schemas.microsoft.com/office/drawing/2014/main" id="{697A2A9F-8053-E601-35CE-224B08740010}"/>
+                <a16:creationId xmlns:a16="http://schemas.microsoft.com/office/drawing/2014/main" id="{1E97D8C7-FC8E-8B1B-5B1A-32B0CC86B004}"/>
               </a:ext>
             </a:extLst>
           </p:cNvPr>
@@ -1266,7 +1266,7 @@
           <p:cNvPr id="3" name="Content Placeholder 2">
             <a:extLst>
               <a:ext uri="{FF2B5EF4-FFF2-40B4-BE49-F238E27FC236}">
-                <a16:creationId xmlns:a16="http://schemas.microsoft.com/office/drawing/2014/main" id="{5026BE8E-F5DC-DC9B-3211-1B20F8078C4D}"/>
+                <a16:creationId xmlns:a16="http://schemas.microsoft.com/office/drawing/2014/main" id="{0371F35B-2CAB-7D20-A163-500FFCA982C0}"/>
               </a:ext>
             </a:extLst>
           </p:cNvPr>
@@ -1328,7 +1328,7 @@
           <p:cNvPr id="4" name="Content Placeholder 3">
             <a:extLst>
               <a:ext uri="{FF2B5EF4-FFF2-40B4-BE49-F238E27FC236}">
-                <a16:creationId xmlns:a16="http://schemas.microsoft.com/office/drawing/2014/main" id="{C4E0FFED-19EC-E8E2-C40F-F4CCEFE0CB03}"/>
+                <a16:creationId xmlns:a16="http://schemas.microsoft.com/office/drawing/2014/main" id="{D7452D7C-8521-467C-FB9F-9BAB4929C28B}"/>
               </a:ext>
             </a:extLst>
           </p:cNvPr>
@@ -1390,7 +1390,7 @@
           <p:cNvPr id="5" name="Date Placeholder 4">
             <a:extLst>
               <a:ext uri="{FF2B5EF4-FFF2-40B4-BE49-F238E27FC236}">
-                <a16:creationId xmlns:a16="http://schemas.microsoft.com/office/drawing/2014/main" id="{3EBD31B7-35E3-C915-69DD-AEF18130B9CE}"/>
+                <a16:creationId xmlns:a16="http://schemas.microsoft.com/office/drawing/2014/main" id="{631B065C-D45F-EBDB-C6DA-8E38B0035EF2}"/>
               </a:ext>
             </a:extLst>
           </p:cNvPr>
@@ -1406,7 +1406,7 @@
           <a:bodyPr/>
           <a:lstStyle/>
           <a:p>
-            <a:fld id="{BD548FE3-2BC9-4C2E-A898-444148D39519}" type="datetimeFigureOut">
+            <a:fld id="{6D1FBE4F-525F-44CD-BC5F-F1D6017AEA63}" type="datetimeFigureOut">
               <a:rPr lang="en-US" smtClean="0"/>
               <a:t>4/11/2026</a:t>
             </a:fld>
@@ -1419,7 +1419,7 @@
           <p:cNvPr id="6" name="Footer Placeholder 5">
             <a:extLst>
               <a:ext uri="{FF2B5EF4-FFF2-40B4-BE49-F238E27FC236}">
-                <a16:creationId xmlns:a16="http://schemas.microsoft.com/office/drawing/2014/main" id="{7DB9A5D1-97D1-2A65-C487-0D2697366C16}"/>
+                <a16:creationId xmlns:a16="http://schemas.microsoft.com/office/drawing/2014/main" id="{422475A9-9968-2625-9DA7-C9B16AC3F8B3}"/>
               </a:ext>
             </a:extLst>
           </p:cNvPr>
@@ -1444,7 +1444,7 @@
           <p:cNvPr id="7" name="Slide Number Placeholder 6">
             <a:extLst>
               <a:ext uri="{FF2B5EF4-FFF2-40B4-BE49-F238E27FC236}">
-                <a16:creationId xmlns:a16="http://schemas.microsoft.com/office/drawing/2014/main" id="{346DFA8A-42F6-F5F0-B887-DEEB9413EC71}"/>
+                <a16:creationId xmlns:a16="http://schemas.microsoft.com/office/drawing/2014/main" id="{67C1E542-28AB-2829-89DE-8E2DCC33C7DB}"/>
               </a:ext>
             </a:extLst>
           </p:cNvPr>
@@ -1460,7 +1460,7 @@
           <a:bodyPr/>
           <a:lstStyle/>
           <a:p>
-            <a:fld id="{E99D46A9-7C22-4BEE-A79D-4FCC3D42940E}" type="slidenum">
+            <a:fld id="{BF3C3688-BAAA-4754-AAD6-035CCC78683D}" type="slidenum">
               <a:rPr lang="en-US" smtClean="0"/>
               <a:t>‹#›</a:t>
             </a:fld>
@@ -1471,7 +1471,7 @@
     </p:spTree>
     <p:extLst>
       <p:ext uri="{BB962C8B-B14F-4D97-AF65-F5344CB8AC3E}">
-        <p14:creationId xmlns:p14="http://schemas.microsoft.com/office/powerpoint/2010/main" val="726826693"/>
+        <p14:creationId xmlns:p14="http://schemas.microsoft.com/office/powerpoint/2010/main" val="3581727613"/>
       </p:ext>
     </p:extLst>
   </p:cSld>
@@ -1503,7 +1503,7 @@
           <p:cNvPr id="2" name="Title 1">
             <a:extLst>
               <a:ext uri="{FF2B5EF4-FFF2-40B4-BE49-F238E27FC236}">
-                <a16:creationId xmlns:a16="http://schemas.microsoft.com/office/drawing/2014/main" id="{53D4D3D7-C679-DC87-A8F9-1FDB1C8B2449}"/>
+                <a16:creationId xmlns:a16="http://schemas.microsoft.com/office/drawing/2014/main" id="{629F2513-D0CE-8229-AA36-2BEDDC9AF220}"/>
               </a:ext>
             </a:extLst>
           </p:cNvPr>
@@ -1536,7 +1536,7 @@
           <p:cNvPr id="3" name="Text Placeholder 2">
             <a:extLst>
               <a:ext uri="{FF2B5EF4-FFF2-40B4-BE49-F238E27FC236}">
-                <a16:creationId xmlns:a16="http://schemas.microsoft.com/office/drawing/2014/main" id="{451889EF-89D0-C3AF-AA07-F8C828CC9C9E}"/>
+                <a16:creationId xmlns:a16="http://schemas.microsoft.com/office/drawing/2014/main" id="{79328BC2-8D03-EB3B-65AC-29CD5F1841B1}"/>
               </a:ext>
             </a:extLst>
           </p:cNvPr>
@@ -1607,7 +1607,7 @@
           <p:cNvPr id="4" name="Content Placeholder 3">
             <a:extLst>
               <a:ext uri="{FF2B5EF4-FFF2-40B4-BE49-F238E27FC236}">
-                <a16:creationId xmlns:a16="http://schemas.microsoft.com/office/drawing/2014/main" id="{8BFA7DAC-DF6E-29CB-79D2-89C6457F47C9}"/>
+                <a16:creationId xmlns:a16="http://schemas.microsoft.com/office/drawing/2014/main" id="{9F52A4B5-F7D9-E2C8-EF25-5A3D0100C8E8}"/>
               </a:ext>
             </a:extLst>
           </p:cNvPr>
@@ -1669,7 +1669,7 @@
           <p:cNvPr id="5" name="Text Placeholder 4">
             <a:extLst>
               <a:ext uri="{FF2B5EF4-FFF2-40B4-BE49-F238E27FC236}">
-                <a16:creationId xmlns:a16="http://schemas.microsoft.com/office/drawing/2014/main" id="{E9D6574F-8FF2-D894-9765-ECEF9BAA9354}"/>
+                <a16:creationId xmlns:a16="http://schemas.microsoft.com/office/drawing/2014/main" id="{2995CE6A-D87D-EA35-3F9E-26197F40524A}"/>
               </a:ext>
             </a:extLst>
           </p:cNvPr>
@@ -1740,7 +1740,7 @@
           <p:cNvPr id="6" name="Content Placeholder 5">
             <a:extLst>
               <a:ext uri="{FF2B5EF4-FFF2-40B4-BE49-F238E27FC236}">
-                <a16:creationId xmlns:a16="http://schemas.microsoft.com/office/drawing/2014/main" id="{5A2B3CB7-6EAF-632C-BCD8-B69FBB59FEF0}"/>
+                <a16:creationId xmlns:a16="http://schemas.microsoft.com/office/drawing/2014/main" id="{42DB4343-86B1-C0E5-EF71-621D0C5AC007}"/>
               </a:ext>
             </a:extLst>
           </p:cNvPr>
@@ -1802,7 +1802,7 @@
           <p:cNvPr id="7" name="Date Placeholder 6">
             <a:extLst>
               <a:ext uri="{FF2B5EF4-FFF2-40B4-BE49-F238E27FC236}">
-                <a16:creationId xmlns:a16="http://schemas.microsoft.com/office/drawing/2014/main" id="{85FA67BB-5202-C44A-260F-F15ADB92AA57}"/>
+                <a16:creationId xmlns:a16="http://schemas.microsoft.com/office/drawing/2014/main" id="{A9B12B65-731C-C8B4-C671-66B5A88416BA}"/>
               </a:ext>
             </a:extLst>
           </p:cNvPr>
@@ -1818,7 +1818,7 @@
           <a:bodyPr/>
           <a:lstStyle/>
           <a:p>
-            <a:fld id="{BD548FE3-2BC9-4C2E-A898-444148D39519}" type="datetimeFigureOut">
+            <a:fld id="{6D1FBE4F-525F-44CD-BC5F-F1D6017AEA63}" type="datetimeFigureOut">
               <a:rPr lang="en-US" smtClean="0"/>
               <a:t>4/11/2026</a:t>
             </a:fld>
@@ -1831,7 +1831,7 @@
           <p:cNvPr id="8" name="Footer Placeholder 7">
             <a:extLst>
               <a:ext uri="{FF2B5EF4-FFF2-40B4-BE49-F238E27FC236}">
-                <a16:creationId xmlns:a16="http://schemas.microsoft.com/office/drawing/2014/main" id="{6995F75E-8159-DFF9-4B61-3381BDC28C4E}"/>
+                <a16:creationId xmlns:a16="http://schemas.microsoft.com/office/drawing/2014/main" id="{D1A4E9BE-CF36-C6F2-D81F-E1CCDE8AEA02}"/>
               </a:ext>
             </a:extLst>
           </p:cNvPr>
@@ -1856,7 +1856,7 @@
           <p:cNvPr id="9" name="Slide Number Placeholder 8">
             <a:extLst>
               <a:ext uri="{FF2B5EF4-FFF2-40B4-BE49-F238E27FC236}">
-                <a16:creationId xmlns:a16="http://schemas.microsoft.com/office/drawing/2014/main" id="{60F34C50-4FCA-B540-7F0F-808ECA0101B1}"/>
+                <a16:creationId xmlns:a16="http://schemas.microsoft.com/office/drawing/2014/main" id="{87D86055-3636-DE9D-1B7E-7AB150B0E5E3}"/>
               </a:ext>
             </a:extLst>
           </p:cNvPr>
@@ -1872,7 +1872,7 @@
           <a:bodyPr/>
           <a:lstStyle/>
           <a:p>
-            <a:fld id="{E99D46A9-7C22-4BEE-A79D-4FCC3D42940E}" type="slidenum">
+            <a:fld id="{BF3C3688-BAAA-4754-AAD6-035CCC78683D}" type="slidenum">
               <a:rPr lang="en-US" smtClean="0"/>
               <a:t>‹#›</a:t>
             </a:fld>
@@ -1883,7 +1883,7 @@
     </p:spTree>
     <p:extLst>
       <p:ext uri="{BB962C8B-B14F-4D97-AF65-F5344CB8AC3E}">
-        <p14:creationId xmlns:p14="http://schemas.microsoft.com/office/powerpoint/2010/main" val="1621899383"/>
+        <p14:creationId xmlns:p14="http://schemas.microsoft.com/office/powerpoint/2010/main" val="11130815"/>
       </p:ext>
     </p:extLst>
   </p:cSld>
@@ -1915,7 +1915,7 @@
           <p:cNvPr id="2" name="Title 1">
             <a:extLst>
               <a:ext uri="{FF2B5EF4-FFF2-40B4-BE49-F238E27FC236}">
-                <a16:creationId xmlns:a16="http://schemas.microsoft.com/office/drawing/2014/main" id="{E1231575-16BF-6E49-75B7-24BFDBF4187E}"/>
+                <a16:creationId xmlns:a16="http://schemas.microsoft.com/office/drawing/2014/main" id="{22EC9276-7387-5771-452D-5A838C865BE6}"/>
               </a:ext>
             </a:extLst>
           </p:cNvPr>
@@ -1943,7 +1943,7 @@
           <p:cNvPr id="3" name="Date Placeholder 2">
             <a:extLst>
               <a:ext uri="{FF2B5EF4-FFF2-40B4-BE49-F238E27FC236}">
-                <a16:creationId xmlns:a16="http://schemas.microsoft.com/office/drawing/2014/main" id="{E4F0884B-772B-A1AD-683C-24C5016E2B7E}"/>
+                <a16:creationId xmlns:a16="http://schemas.microsoft.com/office/drawing/2014/main" id="{EFFE7F6D-D7F5-6F9F-C5FC-10C11DAE263B}"/>
               </a:ext>
             </a:extLst>
           </p:cNvPr>
@@ -1959,7 +1959,7 @@
           <a:bodyPr/>
           <a:lstStyle/>
           <a:p>
-            <a:fld id="{BD548FE3-2BC9-4C2E-A898-444148D39519}" type="datetimeFigureOut">
+            <a:fld id="{6D1FBE4F-525F-44CD-BC5F-F1D6017AEA63}" type="datetimeFigureOut">
               <a:rPr lang="en-US" smtClean="0"/>
               <a:t>4/11/2026</a:t>
             </a:fld>
@@ -1972,7 +1972,7 @@
           <p:cNvPr id="4" name="Footer Placeholder 3">
             <a:extLst>
               <a:ext uri="{FF2B5EF4-FFF2-40B4-BE49-F238E27FC236}">
-                <a16:creationId xmlns:a16="http://schemas.microsoft.com/office/drawing/2014/main" id="{EBA76BE8-C50E-09D6-2933-BB0AA4A854D1}"/>
+                <a16:creationId xmlns:a16="http://schemas.microsoft.com/office/drawing/2014/main" id="{FD5B7BD8-DC03-5264-E3AB-E29D9FAEB24B}"/>
               </a:ext>
             </a:extLst>
           </p:cNvPr>
@@ -1997,7 +1997,7 @@
           <p:cNvPr id="5" name="Slide Number Placeholder 4">
             <a:extLst>
               <a:ext uri="{FF2B5EF4-FFF2-40B4-BE49-F238E27FC236}">
-                <a16:creationId xmlns:a16="http://schemas.microsoft.com/office/drawing/2014/main" id="{91866410-3B73-7D25-5E0C-654E3091880F}"/>
+                <a16:creationId xmlns:a16="http://schemas.microsoft.com/office/drawing/2014/main" id="{ADA55A7E-9A0A-48F0-C93F-8F42948511DD}"/>
               </a:ext>
             </a:extLst>
           </p:cNvPr>
@@ -2013,7 +2013,7 @@
           <a:bodyPr/>
           <a:lstStyle/>
           <a:p>
-            <a:fld id="{E99D46A9-7C22-4BEE-A79D-4FCC3D42940E}" type="slidenum">
+            <a:fld id="{BF3C3688-BAAA-4754-AAD6-035CCC78683D}" type="slidenum">
               <a:rPr lang="en-US" smtClean="0"/>
               <a:t>‹#›</a:t>
             </a:fld>
@@ -2024,7 +2024,7 @@
     </p:spTree>
     <p:extLst>
       <p:ext uri="{BB962C8B-B14F-4D97-AF65-F5344CB8AC3E}">
-        <p14:creationId xmlns:p14="http://schemas.microsoft.com/office/powerpoint/2010/main" val="4266922832"/>
+        <p14:creationId xmlns:p14="http://schemas.microsoft.com/office/powerpoint/2010/main" val="3962464942"/>
       </p:ext>
     </p:extLst>
   </p:cSld>
@@ -2056,7 +2056,7 @@
           <p:cNvPr id="2" name="Date Placeholder 1">
             <a:extLst>
               <a:ext uri="{FF2B5EF4-FFF2-40B4-BE49-F238E27FC236}">
-                <a16:creationId xmlns:a16="http://schemas.microsoft.com/office/drawing/2014/main" id="{42B7C8A5-3685-6929-EC5D-5E1438077CC8}"/>
+                <a16:creationId xmlns:a16="http://schemas.microsoft.com/office/drawing/2014/main" id="{F9BB42C0-D8C3-7E0B-3EDC-AE5EB2B65AF8}"/>
               </a:ext>
             </a:extLst>
           </p:cNvPr>
@@ -2072,7 +2072,7 @@
           <a:bodyPr/>
           <a:lstStyle/>
           <a:p>
-            <a:fld id="{BD548FE3-2BC9-4C2E-A898-444148D39519}" type="datetimeFigureOut">
+            <a:fld id="{6D1FBE4F-525F-44CD-BC5F-F1D6017AEA63}" type="datetimeFigureOut">
               <a:rPr lang="en-US" smtClean="0"/>
               <a:t>4/11/2026</a:t>
             </a:fld>
@@ -2085,7 +2085,7 @@
           <p:cNvPr id="3" name="Footer Placeholder 2">
             <a:extLst>
               <a:ext uri="{FF2B5EF4-FFF2-40B4-BE49-F238E27FC236}">
-                <a16:creationId xmlns:a16="http://schemas.microsoft.com/office/drawing/2014/main" id="{20E8D5D6-67CB-0665-FA33-D4E60FB1C1C9}"/>
+                <a16:creationId xmlns:a16="http://schemas.microsoft.com/office/drawing/2014/main" id="{EBB4CBED-660F-8B61-BE55-FDA5CEBA67A6}"/>
               </a:ext>
             </a:extLst>
           </p:cNvPr>
@@ -2110,7 +2110,7 @@
           <p:cNvPr id="4" name="Slide Number Placeholder 3">
             <a:extLst>
               <a:ext uri="{FF2B5EF4-FFF2-40B4-BE49-F238E27FC236}">
-                <a16:creationId xmlns:a16="http://schemas.microsoft.com/office/drawing/2014/main" id="{FFB5F7A1-5398-5F5F-B093-08E58A98ECEB}"/>
+                <a16:creationId xmlns:a16="http://schemas.microsoft.com/office/drawing/2014/main" id="{BB9B8C6E-A9ED-F316-A543-3089ECCBC3EA}"/>
               </a:ext>
             </a:extLst>
           </p:cNvPr>
@@ -2126,7 +2126,7 @@
           <a:bodyPr/>
           <a:lstStyle/>
           <a:p>
-            <a:fld id="{E99D46A9-7C22-4BEE-A79D-4FCC3D42940E}" type="slidenum">
+            <a:fld id="{BF3C3688-BAAA-4754-AAD6-035CCC78683D}" type="slidenum">
               <a:rPr lang="en-US" smtClean="0"/>
               <a:t>‹#›</a:t>
             </a:fld>
@@ -2137,7 +2137,7 @@
     </p:spTree>
     <p:extLst>
       <p:ext uri="{BB962C8B-B14F-4D97-AF65-F5344CB8AC3E}">
-        <p14:creationId xmlns:p14="http://schemas.microsoft.com/office/powerpoint/2010/main" val="681617123"/>
+        <p14:creationId xmlns:p14="http://schemas.microsoft.com/office/powerpoint/2010/main" val="214882038"/>
       </p:ext>
     </p:extLst>
   </p:cSld>
@@ -2169,7 +2169,7 @@
           <p:cNvPr id="2" name="Title 1">
             <a:extLst>
               <a:ext uri="{FF2B5EF4-FFF2-40B4-BE49-F238E27FC236}">
-                <a16:creationId xmlns:a16="http://schemas.microsoft.com/office/drawing/2014/main" id="{645DBAC0-3064-D82D-6D2D-E97C8C3876EE}"/>
+                <a16:creationId xmlns:a16="http://schemas.microsoft.com/office/drawing/2014/main" id="{A5D82BCC-E633-0A93-B9BB-447D09B4ADDC}"/>
               </a:ext>
             </a:extLst>
           </p:cNvPr>
@@ -2206,7 +2206,7 @@
           <p:cNvPr id="3" name="Content Placeholder 2">
             <a:extLst>
               <a:ext uri="{FF2B5EF4-FFF2-40B4-BE49-F238E27FC236}">
-                <a16:creationId xmlns:a16="http://schemas.microsoft.com/office/drawing/2014/main" id="{0E6A69F6-BF3D-A00B-1D16-F0CC896DA807}"/>
+                <a16:creationId xmlns:a16="http://schemas.microsoft.com/office/drawing/2014/main" id="{E1A52B76-7632-AE79-96E6-5A376951435A}"/>
               </a:ext>
             </a:extLst>
           </p:cNvPr>
@@ -2296,7 +2296,7 @@
           <p:cNvPr id="4" name="Text Placeholder 3">
             <a:extLst>
               <a:ext uri="{FF2B5EF4-FFF2-40B4-BE49-F238E27FC236}">
-                <a16:creationId xmlns:a16="http://schemas.microsoft.com/office/drawing/2014/main" id="{D0114895-C91F-7959-C4D2-2BD73AD80054}"/>
+                <a16:creationId xmlns:a16="http://schemas.microsoft.com/office/drawing/2014/main" id="{8E2C4384-427A-A88A-1670-6451A00B72BD}"/>
               </a:ext>
             </a:extLst>
           </p:cNvPr>
@@ -2367,7 +2367,7 @@
           <p:cNvPr id="5" name="Date Placeholder 4">
             <a:extLst>
               <a:ext uri="{FF2B5EF4-FFF2-40B4-BE49-F238E27FC236}">
-                <a16:creationId xmlns:a16="http://schemas.microsoft.com/office/drawing/2014/main" id="{7F85FAC4-109F-2040-851B-5FEAA09BB04E}"/>
+                <a16:creationId xmlns:a16="http://schemas.microsoft.com/office/drawing/2014/main" id="{AE6E704C-2B76-BD07-0BAA-D05B4C4B1EAD}"/>
               </a:ext>
             </a:extLst>
           </p:cNvPr>
@@ -2383,7 +2383,7 @@
           <a:bodyPr/>
           <a:lstStyle/>
           <a:p>
-            <a:fld id="{BD548FE3-2BC9-4C2E-A898-444148D39519}" type="datetimeFigureOut">
+            <a:fld id="{6D1FBE4F-525F-44CD-BC5F-F1D6017AEA63}" type="datetimeFigureOut">
               <a:rPr lang="en-US" smtClean="0"/>
               <a:t>4/11/2026</a:t>
             </a:fld>
@@ -2396,7 +2396,7 @@
           <p:cNvPr id="6" name="Footer Placeholder 5">
             <a:extLst>
               <a:ext uri="{FF2B5EF4-FFF2-40B4-BE49-F238E27FC236}">
-                <a16:creationId xmlns:a16="http://schemas.microsoft.com/office/drawing/2014/main" id="{E7E03243-DDBA-8999-C6A6-3ECBED96FC98}"/>
+                <a16:creationId xmlns:a16="http://schemas.microsoft.com/office/drawing/2014/main" id="{9A35E8C9-C8E0-2598-B743-B953BFE08D31}"/>
               </a:ext>
             </a:extLst>
           </p:cNvPr>
@@ -2421,7 +2421,7 @@
           <p:cNvPr id="7" name="Slide Number Placeholder 6">
             <a:extLst>
               <a:ext uri="{FF2B5EF4-FFF2-40B4-BE49-F238E27FC236}">
-                <a16:creationId xmlns:a16="http://schemas.microsoft.com/office/drawing/2014/main" id="{6161667B-F21B-F061-4A9E-3A0197496F1D}"/>
+                <a16:creationId xmlns:a16="http://schemas.microsoft.com/office/drawing/2014/main" id="{C6B9E6EE-C54F-C483-C595-1735DF9C440F}"/>
               </a:ext>
             </a:extLst>
           </p:cNvPr>
@@ -2437,7 +2437,7 @@
           <a:bodyPr/>
           <a:lstStyle/>
           <a:p>
-            <a:fld id="{E99D46A9-7C22-4BEE-A79D-4FCC3D42940E}" type="slidenum">
+            <a:fld id="{BF3C3688-BAAA-4754-AAD6-035CCC78683D}" type="slidenum">
               <a:rPr lang="en-US" smtClean="0"/>
               <a:t>‹#›</a:t>
             </a:fld>
@@ -2448,7 +2448,7 @@
     </p:spTree>
     <p:extLst>
       <p:ext uri="{BB962C8B-B14F-4D97-AF65-F5344CB8AC3E}">
-        <p14:creationId xmlns:p14="http://schemas.microsoft.com/office/powerpoint/2010/main" val="1010843961"/>
+        <p14:creationId xmlns:p14="http://schemas.microsoft.com/office/powerpoint/2010/main" val="1005790847"/>
       </p:ext>
     </p:extLst>
   </p:cSld>
@@ -2480,7 +2480,7 @@
           <p:cNvPr id="2" name="Title 1">
             <a:extLst>
               <a:ext uri="{FF2B5EF4-FFF2-40B4-BE49-F238E27FC236}">
-                <a16:creationId xmlns:a16="http://schemas.microsoft.com/office/drawing/2014/main" id="{37170260-17B1-BF0B-3458-27B98BF15C2C}"/>
+                <a16:creationId xmlns:a16="http://schemas.microsoft.com/office/drawing/2014/main" id="{B1F9015C-8C73-BEA8-2993-EF71CD648DA4}"/>
               </a:ext>
             </a:extLst>
           </p:cNvPr>
@@ -2517,7 +2517,7 @@
           <p:cNvPr id="3" name="Picture Placeholder 2">
             <a:extLst>
               <a:ext uri="{FF2B5EF4-FFF2-40B4-BE49-F238E27FC236}">
-                <a16:creationId xmlns:a16="http://schemas.microsoft.com/office/drawing/2014/main" id="{A4F8C5DA-0FD0-73B4-E6FA-34F56784C723}"/>
+                <a16:creationId xmlns:a16="http://schemas.microsoft.com/office/drawing/2014/main" id="{422DC32A-FA7B-A3C7-7D05-6F2DA207544F}"/>
               </a:ext>
             </a:extLst>
           </p:cNvPr>
@@ -2584,7 +2584,7 @@
           <p:cNvPr id="4" name="Text Placeholder 3">
             <a:extLst>
               <a:ext uri="{FF2B5EF4-FFF2-40B4-BE49-F238E27FC236}">
-                <a16:creationId xmlns:a16="http://schemas.microsoft.com/office/drawing/2014/main" id="{08CC9523-C1F8-6402-C8A2-FE11F949269D}"/>
+                <a16:creationId xmlns:a16="http://schemas.microsoft.com/office/drawing/2014/main" id="{6EEE5989-5BAF-96DA-DF70-50E5176FA91D}"/>
               </a:ext>
             </a:extLst>
           </p:cNvPr>
@@ -2655,7 +2655,7 @@
           <p:cNvPr id="5" name="Date Placeholder 4">
             <a:extLst>
               <a:ext uri="{FF2B5EF4-FFF2-40B4-BE49-F238E27FC236}">
-                <a16:creationId xmlns:a16="http://schemas.microsoft.com/office/drawing/2014/main" id="{9FE6DD65-7523-2F73-0FE8-D0863A4E7F2F}"/>
+                <a16:creationId xmlns:a16="http://schemas.microsoft.com/office/drawing/2014/main" id="{4FBAB4D4-D955-D021-5B1F-DFE65AAFD789}"/>
               </a:ext>
             </a:extLst>
           </p:cNvPr>
@@ -2671,7 +2671,7 @@
           <a:bodyPr/>
           <a:lstStyle/>
           <a:p>
-            <a:fld id="{BD548FE3-2BC9-4C2E-A898-444148D39519}" type="datetimeFigureOut">
+            <a:fld id="{6D1FBE4F-525F-44CD-BC5F-F1D6017AEA63}" type="datetimeFigureOut">
               <a:rPr lang="en-US" smtClean="0"/>
               <a:t>4/11/2026</a:t>
             </a:fld>
@@ -2684,7 +2684,7 @@
           <p:cNvPr id="6" name="Footer Placeholder 5">
             <a:extLst>
               <a:ext uri="{FF2B5EF4-FFF2-40B4-BE49-F238E27FC236}">
-                <a16:creationId xmlns:a16="http://schemas.microsoft.com/office/drawing/2014/main" id="{A1F4195C-E241-DA61-BA3D-45EF0F90959B}"/>
+                <a16:creationId xmlns:a16="http://schemas.microsoft.com/office/drawing/2014/main" id="{B7020030-38DA-E5F0-922A-96349FCBF9E9}"/>
               </a:ext>
             </a:extLst>
           </p:cNvPr>
@@ -2709,7 +2709,7 @@
           <p:cNvPr id="7" name="Slide Number Placeholder 6">
             <a:extLst>
               <a:ext uri="{FF2B5EF4-FFF2-40B4-BE49-F238E27FC236}">
-                <a16:creationId xmlns:a16="http://schemas.microsoft.com/office/drawing/2014/main" id="{F7E5C535-ED96-02CE-7303-ACE235EE0FE7}"/>
+                <a16:creationId xmlns:a16="http://schemas.microsoft.com/office/drawing/2014/main" id="{F79E3A48-CE79-4042-FA76-09891BDA873B}"/>
               </a:ext>
             </a:extLst>
           </p:cNvPr>
@@ -2725,7 +2725,7 @@
           <a:bodyPr/>
           <a:lstStyle/>
           <a:p>
-            <a:fld id="{E99D46A9-7C22-4BEE-A79D-4FCC3D42940E}" type="slidenum">
+            <a:fld id="{BF3C3688-BAAA-4754-AAD6-035CCC78683D}" type="slidenum">
               <a:rPr lang="en-US" smtClean="0"/>
               <a:t>‹#›</a:t>
             </a:fld>
@@ -2736,7 +2736,7 @@
     </p:spTree>
     <p:extLst>
       <p:ext uri="{BB962C8B-B14F-4D97-AF65-F5344CB8AC3E}">
-        <p14:creationId xmlns:p14="http://schemas.microsoft.com/office/powerpoint/2010/main" val="1256362347"/>
+        <p14:creationId xmlns:p14="http://schemas.microsoft.com/office/powerpoint/2010/main" val="1924414378"/>
       </p:ext>
     </p:extLst>
   </p:cSld>
@@ -2773,7 +2773,7 @@
           <p:cNvPr id="2" name="Title Placeholder 1">
             <a:extLst>
               <a:ext uri="{FF2B5EF4-FFF2-40B4-BE49-F238E27FC236}">
-                <a16:creationId xmlns:a16="http://schemas.microsoft.com/office/drawing/2014/main" id="{0C65D277-F19D-C168-F8BE-F9CAC281A348}"/>
+                <a16:creationId xmlns:a16="http://schemas.microsoft.com/office/drawing/2014/main" id="{4372F610-6535-A9BB-95A5-909029D55E7D}"/>
               </a:ext>
             </a:extLst>
           </p:cNvPr>
@@ -2811,7 +2811,7 @@
           <p:cNvPr id="3" name="Text Placeholder 2">
             <a:extLst>
               <a:ext uri="{FF2B5EF4-FFF2-40B4-BE49-F238E27FC236}">
-                <a16:creationId xmlns:a16="http://schemas.microsoft.com/office/drawing/2014/main" id="{5A12DFD5-E792-CDB8-296D-5AF7C26F7FDE}"/>
+                <a16:creationId xmlns:a16="http://schemas.microsoft.com/office/drawing/2014/main" id="{7970BE92-6812-C256-B5AD-7A6446D6CD46}"/>
               </a:ext>
             </a:extLst>
           </p:cNvPr>
@@ -2878,7 +2878,7 @@
           <p:cNvPr id="4" name="Date Placeholder 3">
             <a:extLst>
               <a:ext uri="{FF2B5EF4-FFF2-40B4-BE49-F238E27FC236}">
-                <a16:creationId xmlns:a16="http://schemas.microsoft.com/office/drawing/2014/main" id="{CE3FFD96-216A-EC1E-94E1-36A2693B04CC}"/>
+                <a16:creationId xmlns:a16="http://schemas.microsoft.com/office/drawing/2014/main" id="{F0834F58-C233-D171-182F-6E5E29CE8C2C}"/>
               </a:ext>
             </a:extLst>
           </p:cNvPr>
@@ -2912,7 +2912,7 @@
             </a:lvl1pPr>
           </a:lstStyle>
           <a:p>
-            <a:fld id="{BD548FE3-2BC9-4C2E-A898-444148D39519}" type="datetimeFigureOut">
+            <a:fld id="{6D1FBE4F-525F-44CD-BC5F-F1D6017AEA63}" type="datetimeFigureOut">
               <a:rPr lang="en-US" smtClean="0"/>
               <a:t>4/11/2026</a:t>
             </a:fld>
@@ -2925,7 +2925,7 @@
           <p:cNvPr id="5" name="Footer Placeholder 4">
             <a:extLst>
               <a:ext uri="{FF2B5EF4-FFF2-40B4-BE49-F238E27FC236}">
-                <a16:creationId xmlns:a16="http://schemas.microsoft.com/office/drawing/2014/main" id="{6764F964-8891-2A67-2F5B-60670C2876F7}"/>
+                <a16:creationId xmlns:a16="http://schemas.microsoft.com/office/drawing/2014/main" id="{91CE58B9-AA2F-C9D6-C93E-486B5F38DB7C}"/>
               </a:ext>
             </a:extLst>
           </p:cNvPr>
@@ -2968,7 +2968,7 @@
           <p:cNvPr id="6" name="Slide Number Placeholder 5">
             <a:extLst>
               <a:ext uri="{FF2B5EF4-FFF2-40B4-BE49-F238E27FC236}">
-                <a16:creationId xmlns:a16="http://schemas.microsoft.com/office/drawing/2014/main" id="{26668BFD-0757-B4A2-D481-17EECC51A25A}"/>
+                <a16:creationId xmlns:a16="http://schemas.microsoft.com/office/drawing/2014/main" id="{6E49B7CA-E9E3-4E2F-4DF7-23289C89653D}"/>
               </a:ext>
             </a:extLst>
           </p:cNvPr>
@@ -3002,7 +3002,7 @@
             </a:lvl1pPr>
           </a:lstStyle>
           <a:p>
-            <a:fld id="{E99D46A9-7C22-4BEE-A79D-4FCC3D42940E}" type="slidenum">
+            <a:fld id="{BF3C3688-BAAA-4754-AAD6-035CCC78683D}" type="slidenum">
               <a:rPr lang="en-US" smtClean="0"/>
               <a:t>‹#›</a:t>
             </a:fld>
@@ -3013,7 +3013,7 @@
     </p:spTree>
     <p:extLst>
       <p:ext uri="{BB962C8B-B14F-4D97-AF65-F5344CB8AC3E}">
-        <p14:creationId xmlns:p14="http://schemas.microsoft.com/office/powerpoint/2010/main" val="274087973"/>
+        <p14:creationId xmlns:p14="http://schemas.microsoft.com/office/powerpoint/2010/main" val="247334513"/>
       </p:ext>
     </p:extLst>
   </p:cSld>
@@ -3336,7 +3336,7 @@
           <p:cNvPr id="2" name="Title 1">
             <a:extLst>
               <a:ext uri="{FF2B5EF4-FFF2-40B4-BE49-F238E27FC236}">
-                <a16:creationId xmlns:a16="http://schemas.microsoft.com/office/drawing/2014/main" id="{64F8D9FE-D881-7B59-F460-475C050ABDAB}"/>
+                <a16:creationId xmlns:a16="http://schemas.microsoft.com/office/drawing/2014/main" id="{0D28244C-9BD7-8256-3DAA-54CFEE0FC532}"/>
               </a:ext>
             </a:extLst>
           </p:cNvPr>
@@ -3368,7 +3368,7 @@
           <p:cNvPr id="3" name="TextBox 2">
             <a:extLst>
               <a:ext uri="{FF2B5EF4-FFF2-40B4-BE49-F238E27FC236}">
-                <a16:creationId xmlns:a16="http://schemas.microsoft.com/office/drawing/2014/main" id="{F17C3A4C-A5AC-FA98-2EA2-39AA463BE2B1}"/>
+                <a16:creationId xmlns:a16="http://schemas.microsoft.com/office/drawing/2014/main" id="{E631125C-A993-59A4-B3D3-D2B05B71D799}"/>
               </a:ext>
             </a:extLst>
           </p:cNvPr>
@@ -3459,7 +3459,7 @@
     </p:spTree>
     <p:extLst>
       <p:ext uri="{BB962C8B-B14F-4D97-AF65-F5344CB8AC3E}">
-        <p14:creationId xmlns:p14="http://schemas.microsoft.com/office/powerpoint/2010/main" val="1215386107"/>
+        <p14:creationId xmlns:p14="http://schemas.microsoft.com/office/powerpoint/2010/main" val="2188262174"/>
       </p:ext>
     </p:extLst>
   </p:cSld>
@@ -3491,7 +3491,7 @@
           <p:cNvPr id="2" name="Title 1">
             <a:extLst>
               <a:ext uri="{FF2B5EF4-FFF2-40B4-BE49-F238E27FC236}">
-                <a16:creationId xmlns:a16="http://schemas.microsoft.com/office/drawing/2014/main" id="{4420A7DC-95CC-7202-615D-8431932E1026}"/>
+                <a16:creationId xmlns:a16="http://schemas.microsoft.com/office/drawing/2014/main" id="{80CA89B8-4324-C820-937C-3836535015D0}"/>
               </a:ext>
             </a:extLst>
           </p:cNvPr>
@@ -3523,7 +3523,7 @@
           <p:cNvPr id="3" name="TextBox 2">
             <a:extLst>
               <a:ext uri="{FF2B5EF4-FFF2-40B4-BE49-F238E27FC236}">
-                <a16:creationId xmlns:a16="http://schemas.microsoft.com/office/drawing/2014/main" id="{64737436-35C4-44B6-2403-9376BFDF110E}"/>
+                <a16:creationId xmlns:a16="http://schemas.microsoft.com/office/drawing/2014/main" id="{BBAB199C-FB36-8509-E9CE-54045E8CAAD7}"/>
               </a:ext>
             </a:extLst>
           </p:cNvPr>
@@ -3566,23 +3566,23 @@
               <a:rPr lang="en-US" sz="2200">
                 <a:latin typeface="Aptos" panose="020B0004020202020204" pitchFamily="34" charset="0"/>
               </a:rPr>
-              <a:t>2. retest purchase validation, import confirm, and invoice cancellation after fixes are available</a:t>
-            </a:r>
-          </a:p>
-          <a:p>
-            <a:r>
-              <a:rPr lang="en-US" sz="2200">
-                <a:latin typeface="Aptos" panose="020B0004020202020204" pitchFamily="34" charset="0"/>
-              </a:rPr>
-              <a:t>3. add post-fix retest evidence for all confirmed defects</a:t>
-            </a:r>
-          </a:p>
-          <a:p>
-            <a:r>
-              <a:rPr lang="en-US" sz="2200">
-                <a:latin typeface="Aptos" panose="020B0004020202020204" pitchFamily="34" charset="0"/>
-              </a:rPr>
-              <a:t>4. add optional cross-browser evidence if Edge is available</a:t>
+              <a:t>2. fix and retest purchase validation, import confirm, and invoice cancellation after fixes are available</a:t>
+            </a:r>
+          </a:p>
+          <a:p>
+            <a:r>
+              <a:rPr lang="en-US" sz="2200">
+                <a:latin typeface="Aptos" panose="020B0004020202020204" pitchFamily="34" charset="0"/>
+              </a:rPr>
+              <a:t>3. add post-fix pass evidence for all confirmed defects</a:t>
+            </a:r>
+          </a:p>
+          <a:p>
+            <a:r>
+              <a:rPr lang="en-US" sz="2200">
+                <a:latin typeface="Aptos" panose="020B0004020202020204" pitchFamily="34" charset="0"/>
+              </a:rPr>
+              <a:t>4. expand cross-browser proof beyond the current Edge smoke evidence if time permits</a:t>
             </a:r>
           </a:p>
           <a:p>
@@ -3670,7 +3670,7 @@
     </p:spTree>
     <p:extLst>
       <p:ext uri="{BB962C8B-B14F-4D97-AF65-F5344CB8AC3E}">
-        <p14:creationId xmlns:p14="http://schemas.microsoft.com/office/powerpoint/2010/main" val="2256719605"/>
+        <p14:creationId xmlns:p14="http://schemas.microsoft.com/office/powerpoint/2010/main" val="4209394793"/>
       </p:ext>
     </p:extLst>
   </p:cSld>
@@ -3702,7 +3702,7 @@
           <p:cNvPr id="2" name="Title 1">
             <a:extLst>
               <a:ext uri="{FF2B5EF4-FFF2-40B4-BE49-F238E27FC236}">
-                <a16:creationId xmlns:a16="http://schemas.microsoft.com/office/drawing/2014/main" id="{616A0921-8F88-29E2-5F40-89CAC1499DC2}"/>
+                <a16:creationId xmlns:a16="http://schemas.microsoft.com/office/drawing/2014/main" id="{B383BE16-B74F-CF0F-B9B9-CF9BBC99894F}"/>
               </a:ext>
             </a:extLst>
           </p:cNvPr>
@@ -3734,7 +3734,7 @@
           <p:cNvPr id="3" name="TextBox 2">
             <a:extLst>
               <a:ext uri="{FF2B5EF4-FFF2-40B4-BE49-F238E27FC236}">
-                <a16:creationId xmlns:a16="http://schemas.microsoft.com/office/drawing/2014/main" id="{B23B2C65-7EBD-4C92-EED1-4EBB18ACEACF}"/>
+                <a16:creationId xmlns:a16="http://schemas.microsoft.com/office/drawing/2014/main" id="{13C1DE0A-E756-CF07-5742-6139F79078C2}"/>
               </a:ext>
             </a:extLst>
           </p:cNvPr>
@@ -3809,7 +3809,7 @@
     </p:spTree>
     <p:extLst>
       <p:ext uri="{BB962C8B-B14F-4D97-AF65-F5344CB8AC3E}">
-        <p14:creationId xmlns:p14="http://schemas.microsoft.com/office/powerpoint/2010/main" val="1025403266"/>
+        <p14:creationId xmlns:p14="http://schemas.microsoft.com/office/powerpoint/2010/main" val="2865944463"/>
       </p:ext>
     </p:extLst>
   </p:cSld>
@@ -3841,7 +3841,7 @@
           <p:cNvPr id="2" name="Title 1">
             <a:extLst>
               <a:ext uri="{FF2B5EF4-FFF2-40B4-BE49-F238E27FC236}">
-                <a16:creationId xmlns:a16="http://schemas.microsoft.com/office/drawing/2014/main" id="{5052A2B9-CBFD-94A3-6BFD-CC4A592679EA}"/>
+                <a16:creationId xmlns:a16="http://schemas.microsoft.com/office/drawing/2014/main" id="{A932C008-1CEB-7B59-92BB-9561B558C5C7}"/>
               </a:ext>
             </a:extLst>
           </p:cNvPr>
@@ -3873,7 +3873,7 @@
           <p:cNvPr id="3" name="TextBox 2">
             <a:extLst>
               <a:ext uri="{FF2B5EF4-FFF2-40B4-BE49-F238E27FC236}">
-                <a16:creationId xmlns:a16="http://schemas.microsoft.com/office/drawing/2014/main" id="{DC80019C-1276-CEAA-D889-1664189A8D52}"/>
+                <a16:creationId xmlns:a16="http://schemas.microsoft.com/office/drawing/2014/main" id="{F3D5E86C-58CF-9DCE-1E19-8701F86F89C3}"/>
               </a:ext>
             </a:extLst>
           </p:cNvPr>
@@ -3988,7 +3988,7 @@
     </p:spTree>
     <p:extLst>
       <p:ext uri="{BB962C8B-B14F-4D97-AF65-F5344CB8AC3E}">
-        <p14:creationId xmlns:p14="http://schemas.microsoft.com/office/powerpoint/2010/main" val="3363232154"/>
+        <p14:creationId xmlns:p14="http://schemas.microsoft.com/office/powerpoint/2010/main" val="3348047594"/>
       </p:ext>
     </p:extLst>
   </p:cSld>
@@ -4020,7 +4020,7 @@
           <p:cNvPr id="2" name="Title 1">
             <a:extLst>
               <a:ext uri="{FF2B5EF4-FFF2-40B4-BE49-F238E27FC236}">
-                <a16:creationId xmlns:a16="http://schemas.microsoft.com/office/drawing/2014/main" id="{090901D9-F4B7-D85C-0DC3-A9B4ACED54DB}"/>
+                <a16:creationId xmlns:a16="http://schemas.microsoft.com/office/drawing/2014/main" id="{56DF91FC-CC81-BEBC-90DF-0087BE77EA1C}"/>
               </a:ext>
             </a:extLst>
           </p:cNvPr>
@@ -4052,7 +4052,7 @@
           <p:cNvPr id="3" name="TextBox 2">
             <a:extLst>
               <a:ext uri="{FF2B5EF4-FFF2-40B4-BE49-F238E27FC236}">
-                <a16:creationId xmlns:a16="http://schemas.microsoft.com/office/drawing/2014/main" id="{05DEC990-E811-526F-5FDE-8DE6AA89D832}"/>
+                <a16:creationId xmlns:a16="http://schemas.microsoft.com/office/drawing/2014/main" id="{53CCB6B7-5A0A-E7A9-1339-7E696B57A259}"/>
               </a:ext>
             </a:extLst>
           </p:cNvPr>
@@ -4151,7 +4151,7 @@
     </p:spTree>
     <p:extLst>
       <p:ext uri="{BB962C8B-B14F-4D97-AF65-F5344CB8AC3E}">
-        <p14:creationId xmlns:p14="http://schemas.microsoft.com/office/powerpoint/2010/main" val="583549080"/>
+        <p14:creationId xmlns:p14="http://schemas.microsoft.com/office/powerpoint/2010/main" val="290097738"/>
       </p:ext>
     </p:extLst>
   </p:cSld>
@@ -4183,7 +4183,7 @@
           <p:cNvPr id="2" name="Title 1">
             <a:extLst>
               <a:ext uri="{FF2B5EF4-FFF2-40B4-BE49-F238E27FC236}">
-                <a16:creationId xmlns:a16="http://schemas.microsoft.com/office/drawing/2014/main" id="{D58C27AE-3E27-DC63-C81E-BC27E5732A3A}"/>
+                <a16:creationId xmlns:a16="http://schemas.microsoft.com/office/drawing/2014/main" id="{BF441A15-1565-9202-834D-D9854FEF4640}"/>
               </a:ext>
             </a:extLst>
           </p:cNvPr>
@@ -4215,7 +4215,7 @@
           <p:cNvPr id="3" name="TextBox 2">
             <a:extLst>
               <a:ext uri="{FF2B5EF4-FFF2-40B4-BE49-F238E27FC236}">
-                <a16:creationId xmlns:a16="http://schemas.microsoft.com/office/drawing/2014/main" id="{B35E96D7-B644-F2E1-66FE-A2BB4DC3E643}"/>
+                <a16:creationId xmlns:a16="http://schemas.microsoft.com/office/drawing/2014/main" id="{987C4F58-0FAF-ED46-7795-B41CC09F9DE9}"/>
               </a:ext>
             </a:extLst>
           </p:cNvPr>
@@ -4322,7 +4322,7 @@
     </p:spTree>
     <p:extLst>
       <p:ext uri="{BB962C8B-B14F-4D97-AF65-F5344CB8AC3E}">
-        <p14:creationId xmlns:p14="http://schemas.microsoft.com/office/powerpoint/2010/main" val="3317940090"/>
+        <p14:creationId xmlns:p14="http://schemas.microsoft.com/office/powerpoint/2010/main" val="2430374657"/>
       </p:ext>
     </p:extLst>
   </p:cSld>
@@ -4354,7 +4354,7 @@
           <p:cNvPr id="2" name="Title 1">
             <a:extLst>
               <a:ext uri="{FF2B5EF4-FFF2-40B4-BE49-F238E27FC236}">
-                <a16:creationId xmlns:a16="http://schemas.microsoft.com/office/drawing/2014/main" id="{D0513042-B0C3-73D8-1793-83F8ADBA5AE9}"/>
+                <a16:creationId xmlns:a16="http://schemas.microsoft.com/office/drawing/2014/main" id="{C1A54A98-6817-DB7D-26DF-598DF128BDE9}"/>
               </a:ext>
             </a:extLst>
           </p:cNvPr>
@@ -4386,7 +4386,7 @@
           <p:cNvPr id="3" name="TextBox 2">
             <a:extLst>
               <a:ext uri="{FF2B5EF4-FFF2-40B4-BE49-F238E27FC236}">
-                <a16:creationId xmlns:a16="http://schemas.microsoft.com/office/drawing/2014/main" id="{6A66F3BD-495C-807B-1A48-732CD9861321}"/>
+                <a16:creationId xmlns:a16="http://schemas.microsoft.com/office/drawing/2014/main" id="{E96ACDB2-AC86-27B1-0F6B-DB1632ADA767}"/>
               </a:ext>
             </a:extLst>
           </p:cNvPr>
@@ -4501,7 +4501,7 @@
     </p:spTree>
     <p:extLst>
       <p:ext uri="{BB962C8B-B14F-4D97-AF65-F5344CB8AC3E}">
-        <p14:creationId xmlns:p14="http://schemas.microsoft.com/office/powerpoint/2010/main" val="181301688"/>
+        <p14:creationId xmlns:p14="http://schemas.microsoft.com/office/powerpoint/2010/main" val="1735533277"/>
       </p:ext>
     </p:extLst>
   </p:cSld>
@@ -4533,7 +4533,7 @@
           <p:cNvPr id="2" name="Title 1">
             <a:extLst>
               <a:ext uri="{FF2B5EF4-FFF2-40B4-BE49-F238E27FC236}">
-                <a16:creationId xmlns:a16="http://schemas.microsoft.com/office/drawing/2014/main" id="{FBFCFB9F-FDF4-50C3-CC4D-584DB2A07FFE}"/>
+                <a16:creationId xmlns:a16="http://schemas.microsoft.com/office/drawing/2014/main" id="{919F66A7-F397-B717-3D6D-6F40155E93C0}"/>
               </a:ext>
             </a:extLst>
           </p:cNvPr>
@@ -4565,7 +4565,7 @@
           <p:cNvPr id="3" name="TextBox 2">
             <a:extLst>
               <a:ext uri="{FF2B5EF4-FFF2-40B4-BE49-F238E27FC236}">
-                <a16:creationId xmlns:a16="http://schemas.microsoft.com/office/drawing/2014/main" id="{5D616E96-7D9F-75C1-DC48-DA6875FDC066}"/>
+                <a16:creationId xmlns:a16="http://schemas.microsoft.com/office/drawing/2014/main" id="{7BCF45FB-02E0-F405-7DD0-650D7223C70B}"/>
               </a:ext>
             </a:extLst>
           </p:cNvPr>
@@ -4722,7 +4722,7 @@
           <p:cNvPr id="5" name="Picture 4">
             <a:extLst>
               <a:ext uri="{FF2B5EF4-FFF2-40B4-BE49-F238E27FC236}">
-                <a16:creationId xmlns:a16="http://schemas.microsoft.com/office/drawing/2014/main" id="{DF992A7C-152B-2B83-E663-3BB119913DAF}"/>
+                <a16:creationId xmlns:a16="http://schemas.microsoft.com/office/drawing/2014/main" id="{6B5D2A37-1DC0-0D28-C2CD-9D7DE2B2C33E}"/>
               </a:ext>
             </a:extLst>
           </p:cNvPr>
@@ -4756,7 +4756,7 @@
     </p:spTree>
     <p:extLst>
       <p:ext uri="{BB962C8B-B14F-4D97-AF65-F5344CB8AC3E}">
-        <p14:creationId xmlns:p14="http://schemas.microsoft.com/office/powerpoint/2010/main" val="261138899"/>
+        <p14:creationId xmlns:p14="http://schemas.microsoft.com/office/powerpoint/2010/main" val="3485625924"/>
       </p:ext>
     </p:extLst>
   </p:cSld>
@@ -4788,7 +4788,7 @@
           <p:cNvPr id="2" name="Title 1">
             <a:extLst>
               <a:ext uri="{FF2B5EF4-FFF2-40B4-BE49-F238E27FC236}">
-                <a16:creationId xmlns:a16="http://schemas.microsoft.com/office/drawing/2014/main" id="{F0FC6204-5603-5E75-F241-4098A5443D70}"/>
+                <a16:creationId xmlns:a16="http://schemas.microsoft.com/office/drawing/2014/main" id="{705FC688-8595-E50F-A64F-D6CEA3CDB4E5}"/>
               </a:ext>
             </a:extLst>
           </p:cNvPr>
@@ -4820,7 +4820,7 @@
           <p:cNvPr id="3" name="TextBox 2">
             <a:extLst>
               <a:ext uri="{FF2B5EF4-FFF2-40B4-BE49-F238E27FC236}">
-                <a16:creationId xmlns:a16="http://schemas.microsoft.com/office/drawing/2014/main" id="{6D288B59-7650-23B3-33AE-B6984E8151A0}"/>
+                <a16:creationId xmlns:a16="http://schemas.microsoft.com/office/drawing/2014/main" id="{9FCB45B0-AA15-16D5-C5DE-ECAEA16F3399}"/>
               </a:ext>
             </a:extLst>
           </p:cNvPr>
@@ -4945,7 +4945,7 @@
           <p:cNvPr id="5" name="Picture 4">
             <a:extLst>
               <a:ext uri="{FF2B5EF4-FFF2-40B4-BE49-F238E27FC236}">
-                <a16:creationId xmlns:a16="http://schemas.microsoft.com/office/drawing/2014/main" id="{3E077960-7B38-4E57-3F04-C29A73ADBE54}"/>
+                <a16:creationId xmlns:a16="http://schemas.microsoft.com/office/drawing/2014/main" id="{0AC9AD9A-6B39-CC2E-7C83-151BC9613C70}"/>
               </a:ext>
             </a:extLst>
           </p:cNvPr>
@@ -4979,7 +4979,7 @@
     </p:spTree>
     <p:extLst>
       <p:ext uri="{BB962C8B-B14F-4D97-AF65-F5344CB8AC3E}">
-        <p14:creationId xmlns:p14="http://schemas.microsoft.com/office/powerpoint/2010/main" val="3154678670"/>
+        <p14:creationId xmlns:p14="http://schemas.microsoft.com/office/powerpoint/2010/main" val="2144942988"/>
       </p:ext>
     </p:extLst>
   </p:cSld>
@@ -5011,7 +5011,7 @@
           <p:cNvPr id="2" name="Title 1">
             <a:extLst>
               <a:ext uri="{FF2B5EF4-FFF2-40B4-BE49-F238E27FC236}">
-                <a16:creationId xmlns:a16="http://schemas.microsoft.com/office/drawing/2014/main" id="{E5E36EB9-6CD3-DFD6-EE55-6D8622DB56A6}"/>
+                <a16:creationId xmlns:a16="http://schemas.microsoft.com/office/drawing/2014/main" id="{683CA892-B45B-0F8A-1CA2-3A2EC578B1CE}"/>
               </a:ext>
             </a:extLst>
           </p:cNvPr>
@@ -5043,7 +5043,7 @@
           <p:cNvPr id="3" name="TextBox 2">
             <a:extLst>
               <a:ext uri="{FF2B5EF4-FFF2-40B4-BE49-F238E27FC236}">
-                <a16:creationId xmlns:a16="http://schemas.microsoft.com/office/drawing/2014/main" id="{95F2C1F0-091D-9B1F-F79A-F0853EFC8A91}"/>
+                <a16:creationId xmlns:a16="http://schemas.microsoft.com/office/drawing/2014/main" id="{7340F001-E8C6-AA0A-E638-C1BB7522C81E}"/>
               </a:ext>
             </a:extLst>
           </p:cNvPr>
@@ -5174,7 +5174,7 @@
               <a:rPr lang="en-US" sz="2200">
                 <a:latin typeface="Aptos" panose="020B0004020202020204" pitchFamily="34" charset="0"/>
               </a:rPr>
-              <a:t>no post-fix retest evidence yet for the confirmed defects</a:t>
+              <a:t>focused retests on 2026-04-11 still reproduced all four confirmed defects</a:t>
             </a:r>
           </a:p>
         </p:txBody>
@@ -5184,7 +5184,7 @@
           <p:cNvPr id="5" name="Picture 4">
             <a:extLst>
               <a:ext uri="{FF2B5EF4-FFF2-40B4-BE49-F238E27FC236}">
-                <a16:creationId xmlns:a16="http://schemas.microsoft.com/office/drawing/2014/main" id="{332153AB-107C-6A08-E312-DD5FBFAA9D34}"/>
+                <a16:creationId xmlns:a16="http://schemas.microsoft.com/office/drawing/2014/main" id="{B0E2750B-A52D-C0BF-9204-B3C0F8619AA7}"/>
               </a:ext>
             </a:extLst>
           </p:cNvPr>
@@ -5218,7 +5218,7 @@
     </p:spTree>
     <p:extLst>
       <p:ext uri="{BB962C8B-B14F-4D97-AF65-F5344CB8AC3E}">
-        <p14:creationId xmlns:p14="http://schemas.microsoft.com/office/powerpoint/2010/main" val="2198680852"/>
+        <p14:creationId xmlns:p14="http://schemas.microsoft.com/office/powerpoint/2010/main" val="1745032343"/>
       </p:ext>
     </p:extLst>
   </p:cSld>
@@ -5250,7 +5250,7 @@
           <p:cNvPr id="2" name="Title 1">
             <a:extLst>
               <a:ext uri="{FF2B5EF4-FFF2-40B4-BE49-F238E27FC236}">
-                <a16:creationId xmlns:a16="http://schemas.microsoft.com/office/drawing/2014/main" id="{7ECBCF06-A47A-32EC-778F-C6492C56D157}"/>
+                <a16:creationId xmlns:a16="http://schemas.microsoft.com/office/drawing/2014/main" id="{331AF54F-04AA-435D-BF6E-FC37C2572F66}"/>
               </a:ext>
             </a:extLst>
           </p:cNvPr>
@@ -5282,7 +5282,7 @@
           <p:cNvPr id="3" name="TextBox 2">
             <a:extLst>
               <a:ext uri="{FF2B5EF4-FFF2-40B4-BE49-F238E27FC236}">
-                <a16:creationId xmlns:a16="http://schemas.microsoft.com/office/drawing/2014/main" id="{CDEC7DD6-428B-ACED-5615-3324E2ACBAA3}"/>
+                <a16:creationId xmlns:a16="http://schemas.microsoft.com/office/drawing/2014/main" id="{09DEEBF5-FC5B-7CB6-9013-BDEE5D7FD34E}"/>
               </a:ext>
             </a:extLst>
           </p:cNvPr>
@@ -5365,7 +5365,7 @@
               <a:rPr lang="en-US" sz="2200">
                 <a:latin typeface="Aptos" panose="020B0004020202020204" pitchFamily="34" charset="0"/>
               </a:rPr>
-              <a:t>post-fix retest is still required for maximum confidence</a:t>
+              <a:t>post-fix retest after actual fixes is still required for maximum confidence</a:t>
             </a:r>
           </a:p>
         </p:txBody>
@@ -5373,7 +5373,7 @@
     </p:spTree>
     <p:extLst>
       <p:ext uri="{BB962C8B-B14F-4D97-AF65-F5344CB8AC3E}">
-        <p14:creationId xmlns:p14="http://schemas.microsoft.com/office/powerpoint/2010/main" val="2731307478"/>
+        <p14:creationId xmlns:p14="http://schemas.microsoft.com/office/powerpoint/2010/main" val="695518109"/>
       </p:ext>
     </p:extLst>
   </p:cSld>

</xml_diff>